<commit_message>
docs(ios): trim discovery slide, fix stack-slide layout, add speaker notes
Remove the dedicated "Zero-config discovery" code slide from the iOS overview
deck (PPTX + HTML) - now 8 slides. Rework the "iOS stack" slide so the icon,
name and description sit in separate zones and no longer overlap. Add
SPEAKER-NOTES.md with a per-slide talking script for presenting the deck.

Co-Authored-By: Claude Opus 4.8 <noreply@anthropic.com>
</commit_message>
<xml_diff>
--- a/docs/presentation-ios/EasyPilot-iOS-Overview.pptx
+++ b/docs/presentation-ios/EasyPilot-iOS-Overview.pptx
@@ -13,7 +13,6 @@
     <p:sldId id="261" r:id="rId12"/>
     <p:sldId id="262" r:id="rId13"/>
     <p:sldId id="263" r:id="rId14"/>
-    <p:sldId id="264" r:id="rId15"/>
   </p:sldIdLst>
   <p:sldSz cx="12191695" cy="6858000" type="screen4x3"/>
   <p:notesSz cx="6858000" cy="9144000"/>
@@ -4518,7 +4517,7 @@
         <p:spPr>
           <a:xfrm>
             <a:off x="777240" y="1828800"/>
-            <a:ext cx="3520440" cy="1920240"/>
+            <a:ext cx="3520440" cy="1965960"/>
           </a:xfrm>
           <a:prstGeom prst="roundRect">
             <a:avLst>
@@ -4573,8 +4572,8 @@
         </p:blipFill>
         <p:spPr>
           <a:xfrm>
-            <a:off x="1033272" y="2121408"/>
-            <a:ext cx="1097277" cy="338327"/>
+            <a:off x="1051560" y="2121408"/>
+            <a:ext cx="822957" cy="253745"/>
           </a:xfrm>
           <a:prstGeom prst="rect">
             <a:avLst/>
@@ -4589,8 +4588,8 @@
         </p:nvSpPr>
         <p:spPr>
           <a:xfrm>
-            <a:off x="2331720" y="2103120"/>
-            <a:ext cx="1783080" cy="548640"/>
+            <a:off x="2103120" y="2121408"/>
+            <a:ext cx="1965960" cy="822960"/>
           </a:xfrm>
           <a:prstGeom prst="rect">
             <a:avLst/>
@@ -4598,7 +4597,7 @@
           <a:noFill/>
         </p:spPr>
         <p:txBody>
-          <a:bodyPr wrap="square" anchor="t" lIns="0" rIns="0" tIns="0" bIns="0">
+          <a:bodyPr wrap="square" anchor="ctr" lIns="0" rIns="0" tIns="0" bIns="0">
             <a:spAutoFit/>
           </a:bodyPr>
           <a:lstStyle/>
@@ -4612,7 +4611,7 @@
               </a:spcAft>
             </a:pPr>
             <a:r>
-              <a:rPr sz="1800" b="1">
+              <a:rPr sz="1700" b="1">
                 <a:solidFill>
                   <a:srgbClr val="E9EEFB"/>
                 </a:solidFill>
@@ -4631,8 +4630,8 @@
         </p:nvSpPr>
         <p:spPr>
           <a:xfrm>
-            <a:off x="1051560" y="2880360"/>
-            <a:ext cx="3017520" cy="777240"/>
+            <a:off x="1051560" y="3127248"/>
+            <a:ext cx="2971800" cy="566928"/>
           </a:xfrm>
           <a:prstGeom prst="rect">
             <a:avLst/>
@@ -4654,7 +4653,7 @@
               </a:spcAft>
             </a:pPr>
             <a:r>
-              <a:rPr sz="1350" b="0">
+              <a:rPr sz="1300" b="0">
                 <a:solidFill>
                   <a:srgbClr val="8A97B8"/>
                 </a:solidFill>
@@ -4674,7 +4673,7 @@
         <p:spPr>
           <a:xfrm>
             <a:off x="4572000" y="1828800"/>
-            <a:ext cx="3520440" cy="1920240"/>
+            <a:ext cx="3520440" cy="1965960"/>
           </a:xfrm>
           <a:prstGeom prst="roundRect">
             <a:avLst>
@@ -4729,8 +4728,8 @@
         </p:blipFill>
         <p:spPr>
           <a:xfrm>
-            <a:off x="4828032" y="2121408"/>
-            <a:ext cx="914400" cy="914400"/>
+            <a:off x="4846320" y="2121408"/>
+            <a:ext cx="822960" cy="822960"/>
           </a:xfrm>
           <a:prstGeom prst="rect">
             <a:avLst/>
@@ -4745,8 +4744,8 @@
         </p:nvSpPr>
         <p:spPr>
           <a:xfrm>
-            <a:off x="6126480" y="2103120"/>
-            <a:ext cx="1783080" cy="548640"/>
+            <a:off x="5897880" y="2121408"/>
+            <a:ext cx="1965960" cy="822960"/>
           </a:xfrm>
           <a:prstGeom prst="rect">
             <a:avLst/>
@@ -4754,7 +4753,7 @@
           <a:noFill/>
         </p:spPr>
         <p:txBody>
-          <a:bodyPr wrap="square" anchor="t" lIns="0" rIns="0" tIns="0" bIns="0">
+          <a:bodyPr wrap="square" anchor="ctr" lIns="0" rIns="0" tIns="0" bIns="0">
             <a:spAutoFit/>
           </a:bodyPr>
           <a:lstStyle/>
@@ -4768,7 +4767,7 @@
               </a:spcAft>
             </a:pPr>
             <a:r>
-              <a:rPr sz="1800" b="1">
+              <a:rPr sz="1700" b="1">
                 <a:solidFill>
                   <a:srgbClr val="E9EEFB"/>
                 </a:solidFill>
@@ -4787,8 +4786,8 @@
         </p:nvSpPr>
         <p:spPr>
           <a:xfrm>
-            <a:off x="4846320" y="2880360"/>
-            <a:ext cx="3017520" cy="777240"/>
+            <a:off x="4846320" y="3127248"/>
+            <a:ext cx="2971800" cy="566928"/>
           </a:xfrm>
           <a:prstGeom prst="rect">
             <a:avLst/>
@@ -4810,7 +4809,7 @@
               </a:spcAft>
             </a:pPr>
             <a:r>
-              <a:rPr sz="1350" b="0">
+              <a:rPr sz="1300" b="0">
                 <a:solidFill>
                   <a:srgbClr val="8A97B8"/>
                 </a:solidFill>
@@ -4830,7 +4829,7 @@
         <p:spPr>
           <a:xfrm>
             <a:off x="8366760" y="1828800"/>
-            <a:ext cx="3520440" cy="1920240"/>
+            <a:ext cx="3520440" cy="1965960"/>
           </a:xfrm>
           <a:prstGeom prst="roundRect">
             <a:avLst>
@@ -4885,8 +4884,8 @@
         </p:blipFill>
         <p:spPr>
           <a:xfrm>
-            <a:off x="8622792" y="2121408"/>
-            <a:ext cx="914400" cy="914400"/>
+            <a:off x="8641080" y="2121408"/>
+            <a:ext cx="822960" cy="822960"/>
           </a:xfrm>
           <a:prstGeom prst="rect">
             <a:avLst/>
@@ -4901,8 +4900,8 @@
         </p:nvSpPr>
         <p:spPr>
           <a:xfrm>
-            <a:off x="9921240" y="2103120"/>
-            <a:ext cx="1783080" cy="548640"/>
+            <a:off x="9692640" y="2121408"/>
+            <a:ext cx="1965960" cy="822960"/>
           </a:xfrm>
           <a:prstGeom prst="rect">
             <a:avLst/>
@@ -4910,7 +4909,7 @@
           <a:noFill/>
         </p:spPr>
         <p:txBody>
-          <a:bodyPr wrap="square" anchor="t" lIns="0" rIns="0" tIns="0" bIns="0">
+          <a:bodyPr wrap="square" anchor="ctr" lIns="0" rIns="0" tIns="0" bIns="0">
             <a:spAutoFit/>
           </a:bodyPr>
           <a:lstStyle/>
@@ -4924,7 +4923,7 @@
               </a:spcAft>
             </a:pPr>
             <a:r>
-              <a:rPr sz="1800" b="1">
+              <a:rPr sz="1700" b="1">
                 <a:solidFill>
                   <a:srgbClr val="E9EEFB"/>
                 </a:solidFill>
@@ -4943,8 +4942,8 @@
         </p:nvSpPr>
         <p:spPr>
           <a:xfrm>
-            <a:off x="8641080" y="2880360"/>
-            <a:ext cx="3017520" cy="777240"/>
+            <a:off x="8641080" y="3127248"/>
+            <a:ext cx="2971800" cy="566928"/>
           </a:xfrm>
           <a:prstGeom prst="rect">
             <a:avLst/>
@@ -4966,7 +4965,7 @@
               </a:spcAft>
             </a:pPr>
             <a:r>
-              <a:rPr sz="1350" b="0">
+              <a:rPr sz="1300" b="0">
                 <a:solidFill>
                   <a:srgbClr val="8A97B8"/>
                 </a:solidFill>
@@ -4985,8 +4984,8 @@
         </p:nvSpPr>
         <p:spPr>
           <a:xfrm>
-            <a:off x="777240" y="4023360"/>
-            <a:ext cx="3520440" cy="1920240"/>
+            <a:off x="777240" y="4069080"/>
+            <a:ext cx="3520440" cy="1965960"/>
           </a:xfrm>
           <a:prstGeom prst="roundRect">
             <a:avLst>
@@ -5041,8 +5040,8 @@
         </p:blipFill>
         <p:spPr>
           <a:xfrm>
-            <a:off x="1033272" y="4315968"/>
-            <a:ext cx="914400" cy="914400"/>
+            <a:off x="1051560" y="4361688"/>
+            <a:ext cx="822960" cy="822960"/>
           </a:xfrm>
           <a:prstGeom prst="rect">
             <a:avLst/>
@@ -5057,8 +5056,8 @@
         </p:nvSpPr>
         <p:spPr>
           <a:xfrm>
-            <a:off x="2331720" y="4297680"/>
-            <a:ext cx="1783080" cy="548640"/>
+            <a:off x="2103120" y="4361688"/>
+            <a:ext cx="1965960" cy="822960"/>
           </a:xfrm>
           <a:prstGeom prst="rect">
             <a:avLst/>
@@ -5066,7 +5065,7 @@
           <a:noFill/>
         </p:spPr>
         <p:txBody>
-          <a:bodyPr wrap="square" anchor="t" lIns="0" rIns="0" tIns="0" bIns="0">
+          <a:bodyPr wrap="square" anchor="ctr" lIns="0" rIns="0" tIns="0" bIns="0">
             <a:spAutoFit/>
           </a:bodyPr>
           <a:lstStyle/>
@@ -5080,7 +5079,7 @@
               </a:spcAft>
             </a:pPr>
             <a:r>
-              <a:rPr sz="1800" b="1">
+              <a:rPr sz="1700" b="1">
                 <a:solidFill>
                   <a:srgbClr val="E9EEFB"/>
                 </a:solidFill>
@@ -5099,8 +5098,8 @@
         </p:nvSpPr>
         <p:spPr>
           <a:xfrm>
-            <a:off x="1051560" y="5074920"/>
-            <a:ext cx="3017520" cy="777240"/>
+            <a:off x="1051560" y="5367528"/>
+            <a:ext cx="2971800" cy="566928"/>
           </a:xfrm>
           <a:prstGeom prst="rect">
             <a:avLst/>
@@ -5122,7 +5121,7 @@
               </a:spcAft>
             </a:pPr>
             <a:r>
-              <a:rPr sz="1350" b="0">
+              <a:rPr sz="1300" b="0">
                 <a:solidFill>
                   <a:srgbClr val="8A97B8"/>
                 </a:solidFill>
@@ -5141,8 +5140,8 @@
         </p:nvSpPr>
         <p:spPr>
           <a:xfrm>
-            <a:off x="4572000" y="4023360"/>
-            <a:ext cx="3520440" cy="1920240"/>
+            <a:off x="4572000" y="4069080"/>
+            <a:ext cx="3520440" cy="1965960"/>
           </a:xfrm>
           <a:prstGeom prst="roundRect">
             <a:avLst>
@@ -5197,8 +5196,8 @@
         </p:blipFill>
         <p:spPr>
           <a:xfrm>
-            <a:off x="4828032" y="4315968"/>
-            <a:ext cx="914400" cy="914400"/>
+            <a:off x="4846320" y="4361688"/>
+            <a:ext cx="822960" cy="822960"/>
           </a:xfrm>
           <a:prstGeom prst="rect">
             <a:avLst/>
@@ -5213,8 +5212,8 @@
         </p:nvSpPr>
         <p:spPr>
           <a:xfrm>
-            <a:off x="6126480" y="4297680"/>
-            <a:ext cx="1783080" cy="548640"/>
+            <a:off x="5897880" y="4361688"/>
+            <a:ext cx="1965960" cy="822960"/>
           </a:xfrm>
           <a:prstGeom prst="rect">
             <a:avLst/>
@@ -5222,7 +5221,7 @@
           <a:noFill/>
         </p:spPr>
         <p:txBody>
-          <a:bodyPr wrap="square" anchor="t" lIns="0" rIns="0" tIns="0" bIns="0">
+          <a:bodyPr wrap="square" anchor="ctr" lIns="0" rIns="0" tIns="0" bIns="0">
             <a:spAutoFit/>
           </a:bodyPr>
           <a:lstStyle/>
@@ -5236,7 +5235,7 @@
               </a:spcAft>
             </a:pPr>
             <a:r>
-              <a:rPr sz="1800" b="1">
+              <a:rPr sz="1700" b="1">
                 <a:solidFill>
                   <a:srgbClr val="E9EEFB"/>
                 </a:solidFill>
@@ -5255,8 +5254,8 @@
         </p:nvSpPr>
         <p:spPr>
           <a:xfrm>
-            <a:off x="4846320" y="5074920"/>
-            <a:ext cx="3017520" cy="777240"/>
+            <a:off x="4846320" y="5367528"/>
+            <a:ext cx="2971800" cy="566928"/>
           </a:xfrm>
           <a:prstGeom prst="rect">
             <a:avLst/>
@@ -5278,7 +5277,7 @@
               </a:spcAft>
             </a:pPr>
             <a:r>
-              <a:rPr sz="1350" b="0">
+              <a:rPr sz="1300" b="0">
                 <a:solidFill>
                   <a:srgbClr val="8A97B8"/>
                 </a:solidFill>
@@ -5297,8 +5296,8 @@
         </p:nvSpPr>
         <p:spPr>
           <a:xfrm>
-            <a:off x="8366760" y="4023360"/>
-            <a:ext cx="3520440" cy="1920240"/>
+            <a:off x="8366760" y="4069080"/>
+            <a:ext cx="3520440" cy="1965960"/>
           </a:xfrm>
           <a:prstGeom prst="roundRect">
             <a:avLst>
@@ -5353,8 +5352,8 @@
         </p:blipFill>
         <p:spPr>
           <a:xfrm>
-            <a:off x="8622792" y="4315968"/>
-            <a:ext cx="1097276" cy="246887"/>
+            <a:off x="8641080" y="4361688"/>
+            <a:ext cx="822960" cy="185166"/>
           </a:xfrm>
           <a:prstGeom prst="rect">
             <a:avLst/>
@@ -5369,8 +5368,8 @@
         </p:nvSpPr>
         <p:spPr>
           <a:xfrm>
-            <a:off x="9921240" y="4297680"/>
-            <a:ext cx="1783080" cy="548640"/>
+            <a:off x="9692640" y="4361688"/>
+            <a:ext cx="1965960" cy="822960"/>
           </a:xfrm>
           <a:prstGeom prst="rect">
             <a:avLst/>
@@ -5378,7 +5377,7 @@
           <a:noFill/>
         </p:spPr>
         <p:txBody>
-          <a:bodyPr wrap="square" anchor="t" lIns="0" rIns="0" tIns="0" bIns="0">
+          <a:bodyPr wrap="square" anchor="ctr" lIns="0" rIns="0" tIns="0" bIns="0">
             <a:spAutoFit/>
           </a:bodyPr>
           <a:lstStyle/>
@@ -5392,7 +5391,7 @@
               </a:spcAft>
             </a:pPr>
             <a:r>
-              <a:rPr sz="1800" b="1">
+              <a:rPr sz="1700" b="1">
                 <a:solidFill>
                   <a:srgbClr val="E9EEFB"/>
                 </a:solidFill>
@@ -5411,8 +5410,8 @@
         </p:nvSpPr>
         <p:spPr>
           <a:xfrm>
-            <a:off x="8641080" y="5074920"/>
-            <a:ext cx="3017520" cy="777240"/>
+            <a:off x="8641080" y="5367528"/>
+            <a:ext cx="2971800" cy="566928"/>
           </a:xfrm>
           <a:prstGeom prst="rect">
             <a:avLst/>
@@ -5434,7 +5433,7 @@
               </a:spcAft>
             </a:pPr>
             <a:r>
-              <a:rPr sz="1350" b="0">
+              <a:rPr sz="1300" b="0">
                 <a:solidFill>
                   <a:srgbClr val="8A97B8"/>
                 </a:solidFill>
@@ -5544,7 +5543,7 @@
                 </a:solidFill>
                 <a:latin typeface="Helvetica Neue"/>
               </a:rPr>
-              <a:t>CODE · NETWORKING</a:t>
+              <a:t>CODE · LIVE TELEMETRY</a:t>
             </a:r>
           </a:p>
         </p:txBody>
@@ -5586,62 +5585,20 @@
                 </a:solidFill>
                 <a:latin typeface="Helvetica Neue"/>
               </a:rPr>
-              <a:t>Zero-config discovery + WebSocket</a:t>
-            </a:r>
-          </a:p>
-        </p:txBody>
-      </p:sp>
-      <p:sp>
-        <p:nvSpPr>
-          <p:cNvPr id="5" name="TextBox 4"/>
-          <p:cNvSpPr txBox="1"/>
-          <p:nvPr/>
-        </p:nvSpPr>
-        <p:spPr>
-          <a:xfrm>
-            <a:off x="777240" y="1691640"/>
-            <a:ext cx="10607040" cy="640080"/>
-          </a:xfrm>
-          <a:prstGeom prst="rect">
-            <a:avLst/>
-          </a:prstGeom>
-          <a:noFill/>
-        </p:spPr>
-        <p:txBody>
-          <a:bodyPr wrap="square" anchor="t" lIns="0" rIns="0" tIns="0" bIns="0">
-            <a:spAutoFit/>
-          </a:bodyPr>
-          <a:lstStyle/>
-          <a:p>
-            <a:pPr algn="l">
-              <a:spcBef>
-                <a:spcPts val="0"/>
-              </a:spcBef>
-              <a:spcAft>
-                <a:spcPts val="600"/>
-              </a:spcAft>
-            </a:pPr>
-            <a:r>
-              <a:rPr sz="1600" b="0">
-                <a:solidFill>
-                  <a:srgbClr val="8A97B8"/>
-                </a:solidFill>
-                <a:latin typeface="Helvetica Neue"/>
-              </a:rPr>
-              <a:t>The app finds the drone with no manual IP entry — it listens for the UDP beacon, then upgrades to WebSocket.</a:t>
-            </a:r>
-          </a:p>
-        </p:txBody>
-      </p:sp>
-      <p:sp>
-        <p:nvSpPr>
-          <p:cNvPr id="6" name="Rounded Rectangle 5"/>
+              <a:t>Decoding 10 Hz telemetry into the UI</a:t>
+            </a:r>
+          </a:p>
+        </p:txBody>
+      </p:sp>
+      <p:sp>
+        <p:nvSpPr>
+          <p:cNvPr id="5" name="Rounded Rectangle 4"/>
           <p:cNvSpPr/>
           <p:nvPr/>
         </p:nvSpPr>
         <p:spPr>
           <a:xfrm>
-            <a:off x="777240" y="2423160"/>
+            <a:off x="777240" y="1828800"/>
             <a:ext cx="10607040" cy="3931920"/>
           </a:xfrm>
           <a:prstGeom prst="roundRect">
@@ -5692,7 +5649,7 @@
                 </a:solidFill>
                 <a:latin typeface="Consolas"/>
               </a:rPr>
-              <a:t>// Listen for the ESP32's UDP beacon on port 4242</a:t>
+              <a:t>// Codable struct mirrors the ESP32 JSON exactly</a:t>
             </a:r>
           </a:p>
           <a:p>
@@ -5711,16 +5668,16 @@
                 </a:solidFill>
                 <a:latin typeface="Consolas"/>
               </a:rPr>
-              <a:t>private func </a:t>
-            </a:r>
-            <a:r>
-              <a:rPr sz="1450">
-                <a:solidFill>
-                  <a:srgbClr val="82AAFF"/>
-                </a:solidFill>
-                <a:latin typeface="Consolas"/>
-              </a:rPr>
-              <a:t>receiveBeacon</a:t>
+              <a:t>struct </a:t>
+            </a:r>
+            <a:r>
+              <a:rPr sz="1450">
+                <a:solidFill>
+                  <a:srgbClr val="7EE0C8"/>
+                </a:solidFill>
+                <a:latin typeface="Consolas"/>
+              </a:rPr>
+              <a:t>DroneTelemetry</a:t>
             </a:r>
             <a:r>
               <a:rPr sz="1450">
@@ -5729,7 +5686,7 @@
                 </a:solidFill>
                 <a:latin typeface="Consolas"/>
               </a:rPr>
-              <a:t>(on conn: </a:t>
+              <a:t>: </a:t>
             </a:r>
             <a:r>
               <a:rPr sz="1450">
@@ -5738,7 +5695,7 @@
                 </a:solidFill>
                 <a:latin typeface="Consolas"/>
               </a:rPr>
-              <a:t>NWConnection</a:t>
+              <a:t>Codable</a:t>
             </a:r>
             <a:r>
               <a:rPr sz="1450">
@@ -5747,7 +5704,7 @@
                 </a:solidFill>
                 <a:latin typeface="Consolas"/>
               </a:rPr>
-              <a:t>) {</a:t>
+              <a:t> {</a:t>
             </a:r>
           </a:p>
           <a:p>
@@ -5762,56 +5719,29 @@
             <a:r>
               <a:rPr sz="1450">
                 <a:solidFill>
+                  <a:srgbClr val="FF7AB2"/>
+                </a:solidFill>
+                <a:latin typeface="Consolas"/>
+              </a:rPr>
+              <a:t>    let</a:t>
+            </a:r>
+            <a:r>
+              <a:rPr sz="1450">
+                <a:solidFill>
                   <a:srgbClr val="E9EEFB"/>
                 </a:solidFill>
                 <a:latin typeface="Consolas"/>
               </a:rPr>
-              <a:t>    conn.</a:t>
-            </a:r>
-            <a:r>
-              <a:rPr sz="1450">
-                <a:solidFill>
-                  <a:srgbClr val="82AAFF"/>
-                </a:solidFill>
-                <a:latin typeface="Consolas"/>
-              </a:rPr>
-              <a:t>receiveMessage</a:t>
-            </a:r>
-            <a:r>
-              <a:rPr sz="1450">
-                <a:solidFill>
-                  <a:srgbClr val="E9EEFB"/>
-                </a:solidFill>
-                <a:latin typeface="Consolas"/>
-              </a:rPr>
-              <a:t> { [</a:t>
-            </a:r>
-            <a:r>
-              <a:rPr sz="1450">
-                <a:solidFill>
-                  <a:srgbClr val="FF7AB2"/>
-                </a:solidFill>
-                <a:latin typeface="Consolas"/>
-              </a:rPr>
-              <a:t>weak self</a:t>
-            </a:r>
-            <a:r>
-              <a:rPr sz="1450">
-                <a:solidFill>
-                  <a:srgbClr val="E9EEFB"/>
-                </a:solidFill>
-                <a:latin typeface="Consolas"/>
-              </a:rPr>
-              <a:t>] data, _, _, _ </a:t>
-            </a:r>
-            <a:r>
-              <a:rPr sz="1450">
-                <a:solidFill>
-                  <a:srgbClr val="FF7AB2"/>
-                </a:solidFill>
-                <a:latin typeface="Consolas"/>
-              </a:rPr>
-              <a:t>in</a:t>
+              <a:t> roll, pitch, yaw: </a:t>
+            </a:r>
+            <a:r>
+              <a:rPr sz="1450">
+                <a:solidFill>
+                  <a:srgbClr val="7EE0C8"/>
+                </a:solidFill>
+                <a:latin typeface="Consolas"/>
+              </a:rPr>
+              <a:t>Float</a:t>
             </a:r>
           </a:p>
           <a:p>
@@ -5830,7 +5760,7 @@
                 </a:solidFill>
                 <a:latin typeface="Consolas"/>
               </a:rPr>
-              <a:t>        if let</a:t>
+              <a:t>    let</a:t>
             </a:r>
             <a:r>
               <a:rPr sz="1450">
@@ -5839,7 +5769,25 @@
                 </a:solidFill>
                 <a:latin typeface="Consolas"/>
               </a:rPr>
-              <a:t> data,</a:t>
+              <a:t> m1, m2, m3, m4: </a:t>
+            </a:r>
+            <a:r>
+              <a:rPr sz="1450">
+                <a:solidFill>
+                  <a:srgbClr val="7EE0C8"/>
+                </a:solidFill>
+                <a:latin typeface="Consolas"/>
+              </a:rPr>
+              <a:t>Int</a:t>
+            </a:r>
+            <a:r>
+              <a:rPr sz="1450">
+                <a:solidFill>
+                  <a:srgbClr val="E9EEFB"/>
+                </a:solidFill>
+                <a:latin typeface="Consolas"/>
+              </a:rPr>
+              <a:t>?</a:t>
             </a:r>
           </a:p>
           <a:p>
@@ -5858,7 +5806,7 @@
                 </a:solidFill>
                 <a:latin typeface="Consolas"/>
               </a:rPr>
-              <a:t>           let</a:t>
+              <a:t>    let</a:t>
             </a:r>
             <a:r>
               <a:rPr sz="1450">
@@ -5867,7 +5815,7 @@
                 </a:solidFill>
                 <a:latin typeface="Consolas"/>
               </a:rPr>
-              <a:t> text = </a:t>
+              <a:t> voltage: </a:t>
             </a:r>
             <a:r>
               <a:rPr sz="1450">
@@ -5876,6 +5824,42 @@
                 </a:solidFill>
                 <a:latin typeface="Consolas"/>
               </a:rPr>
+              <a:t>Float</a:t>
+            </a:r>
+            <a:r>
+              <a:rPr sz="1450">
+                <a:solidFill>
+                  <a:srgbClr val="E9EEFB"/>
+                </a:solidFill>
+                <a:latin typeface="Consolas"/>
+              </a:rPr>
+              <a:t>?, armed: </a:t>
+            </a:r>
+            <a:r>
+              <a:rPr sz="1450">
+                <a:solidFill>
+                  <a:srgbClr val="7EE0C8"/>
+                </a:solidFill>
+                <a:latin typeface="Consolas"/>
+              </a:rPr>
+              <a:t>Bool</a:t>
+            </a:r>
+            <a:r>
+              <a:rPr sz="1450">
+                <a:solidFill>
+                  <a:srgbClr val="E9EEFB"/>
+                </a:solidFill>
+                <a:latin typeface="Consolas"/>
+              </a:rPr>
+              <a:t>?, mode: </a:t>
+            </a:r>
+            <a:r>
+              <a:rPr sz="1450">
+                <a:solidFill>
+                  <a:srgbClr val="7EE0C8"/>
+                </a:solidFill>
+                <a:latin typeface="Consolas"/>
+              </a:rPr>
               <a:t>String</a:t>
             </a:r>
             <a:r>
@@ -5885,7 +5869,7 @@
                 </a:solidFill>
                 <a:latin typeface="Consolas"/>
               </a:rPr>
-              <a:t>(data: data, encoding: .utf8),</a:t>
+              <a:t>?</a:t>
             </a:r>
           </a:p>
           <a:p>
@@ -5904,43 +5888,7 @@
                 </a:solidFill>
                 <a:latin typeface="Consolas"/>
               </a:rPr>
-              <a:t>           text.</a:t>
-            </a:r>
-            <a:r>
-              <a:rPr sz="1450">
-                <a:solidFill>
-                  <a:srgbClr val="82AAFF"/>
-                </a:solidFill>
-                <a:latin typeface="Consolas"/>
-              </a:rPr>
-              <a:t>hasPrefix</a:t>
-            </a:r>
-            <a:r>
-              <a:rPr sz="1450">
-                <a:solidFill>
-                  <a:srgbClr val="E9EEFB"/>
-                </a:solidFill>
-                <a:latin typeface="Consolas"/>
-              </a:rPr>
-              <a:t>(</a:t>
-            </a:r>
-            <a:r>
-              <a:rPr sz="1450">
-                <a:solidFill>
-                  <a:srgbClr val="C3E88D"/>
-                </a:solidFill>
-                <a:latin typeface="Consolas"/>
-              </a:rPr>
-              <a:t>"EASYPILOT:"</a:t>
-            </a:r>
-            <a:r>
-              <a:rPr sz="1450">
-                <a:solidFill>
-                  <a:srgbClr val="E9EEFB"/>
-                </a:solidFill>
-                <a:latin typeface="Consolas"/>
-              </a:rPr>
-              <a:t>) {</a:t>
+              <a:t>}</a:t>
             </a:r>
           </a:p>
           <a:p>
@@ -5955,56 +5903,11 @@
             <a:r>
               <a:rPr sz="1450">
                 <a:solidFill>
-                  <a:srgbClr val="FF7AB2"/>
-                </a:solidFill>
-                <a:latin typeface="Consolas"/>
-              </a:rPr>
-              <a:t>            let</a:t>
-            </a:r>
-            <a:r>
-              <a:rPr sz="1450">
-                <a:solidFill>
                   <a:srgbClr val="E9EEFB"/>
                 </a:solidFill>
                 <a:latin typeface="Consolas"/>
               </a:rPr>
-              <a:t> ip = </a:t>
-            </a:r>
-            <a:r>
-              <a:rPr sz="1450">
-                <a:solidFill>
-                  <a:srgbClr val="7EE0C8"/>
-                </a:solidFill>
-                <a:latin typeface="Consolas"/>
-              </a:rPr>
-              <a:t>String</a:t>
-            </a:r>
-            <a:r>
-              <a:rPr sz="1450">
-                <a:solidFill>
-                  <a:srgbClr val="E9EEFB"/>
-                </a:solidFill>
-                <a:latin typeface="Consolas"/>
-              </a:rPr>
-              <a:t>(text.</a:t>
-            </a:r>
-            <a:r>
-              <a:rPr sz="1450">
-                <a:solidFill>
-                  <a:srgbClr val="82AAFF"/>
-                </a:solidFill>
-                <a:latin typeface="Consolas"/>
-              </a:rPr>
-              <a:t>dropFirst</a:t>
-            </a:r>
-            <a:r>
-              <a:rPr sz="1450">
-                <a:solidFill>
-                  <a:srgbClr val="E9EEFB"/>
-                </a:solidFill>
-                <a:latin typeface="Consolas"/>
-              </a:rPr>
-              <a:t>(10))</a:t>
+              <a:t/>
             </a:r>
           </a:p>
           <a:p>
@@ -6019,20 +5922,38 @@
             <a:r>
               <a:rPr sz="1450">
                 <a:solidFill>
+                  <a:srgbClr val="FF7AB2"/>
+                </a:solidFill>
+                <a:latin typeface="Consolas"/>
+              </a:rPr>
+              <a:t>private func </a:t>
+            </a:r>
+            <a:r>
+              <a:rPr sz="1450">
+                <a:solidFill>
+                  <a:srgbClr val="82AAFF"/>
+                </a:solidFill>
+                <a:latin typeface="Consolas"/>
+              </a:rPr>
+              <a:t>decodeJSON</a:t>
+            </a:r>
+            <a:r>
+              <a:rPr sz="1450">
+                <a:solidFill>
                   <a:srgbClr val="E9EEFB"/>
                 </a:solidFill>
                 <a:latin typeface="Consolas"/>
               </a:rPr>
-              <a:t>            </a:t>
-            </a:r>
-            <a:r>
-              <a:rPr sz="1450">
-                <a:solidFill>
-                  <a:srgbClr val="82AAFF"/>
-                </a:solidFill>
-                <a:latin typeface="Consolas"/>
-              </a:rPr>
-              <a:t>connectWebSocket</a:t>
+              <a:t>(_ text: </a:t>
+            </a:r>
+            <a:r>
+              <a:rPr sz="1450">
+                <a:solidFill>
+                  <a:srgbClr val="7EE0C8"/>
+                </a:solidFill>
+                <a:latin typeface="Consolas"/>
+              </a:rPr>
+              <a:t>String</a:t>
             </a:r>
             <a:r>
               <a:rPr sz="1450">
@@ -6041,16 +5962,7 @@
                 </a:solidFill>
                 <a:latin typeface="Consolas"/>
               </a:rPr>
-              <a:t>(to: ip)   </a:t>
-            </a:r>
-            <a:r>
-              <a:rPr sz="1450">
-                <a:solidFill>
-                  <a:srgbClr val="5D6B8F"/>
-                </a:solidFill>
-                <a:latin typeface="Consolas"/>
-              </a:rPr>
-              <a:t>// ws://&lt;ip&gt;:81</a:t>
+              <a:t>) {</a:t>
             </a:r>
           </a:p>
           <a:p>
@@ -6065,11 +5977,92 @@
             <a:r>
               <a:rPr sz="1450">
                 <a:solidFill>
+                  <a:srgbClr val="FF7AB2"/>
+                </a:solidFill>
+                <a:latin typeface="Consolas"/>
+              </a:rPr>
+              <a:t>    let</a:t>
+            </a:r>
+            <a:r>
+              <a:rPr sz="1450">
+                <a:solidFill>
                   <a:srgbClr val="E9EEFB"/>
                 </a:solidFill>
                 <a:latin typeface="Consolas"/>
               </a:rPr>
-              <a:t>        }</a:t>
+              <a:t> decoded = </a:t>
+            </a:r>
+            <a:r>
+              <a:rPr sz="1450">
+                <a:solidFill>
+                  <a:srgbClr val="FF7AB2"/>
+                </a:solidFill>
+                <a:latin typeface="Consolas"/>
+              </a:rPr>
+              <a:t>try</a:t>
+            </a:r>
+            <a:r>
+              <a:rPr sz="1450">
+                <a:solidFill>
+                  <a:srgbClr val="E9EEFB"/>
+                </a:solidFill>
+                <a:latin typeface="Consolas"/>
+              </a:rPr>
+              <a:t> </a:t>
+            </a:r>
+            <a:r>
+              <a:rPr sz="1450">
+                <a:solidFill>
+                  <a:srgbClr val="7EE0C8"/>
+                </a:solidFill>
+                <a:latin typeface="Consolas"/>
+              </a:rPr>
+              <a:t>JSONDecoder</a:t>
+            </a:r>
+            <a:r>
+              <a:rPr sz="1450">
+                <a:solidFill>
+                  <a:srgbClr val="E9EEFB"/>
+                </a:solidFill>
+                <a:latin typeface="Consolas"/>
+              </a:rPr>
+              <a:t>().</a:t>
+            </a:r>
+            <a:r>
+              <a:rPr sz="1450">
+                <a:solidFill>
+                  <a:srgbClr val="82AAFF"/>
+                </a:solidFill>
+                <a:latin typeface="Consolas"/>
+              </a:rPr>
+              <a:t>decode</a:t>
+            </a:r>
+            <a:r>
+              <a:rPr sz="1450">
+                <a:solidFill>
+                  <a:srgbClr val="E9EEFB"/>
+                </a:solidFill>
+                <a:latin typeface="Consolas"/>
+              </a:rPr>
+              <a:t>(</a:t>
+            </a:r>
+            <a:r>
+              <a:rPr sz="1450">
+                <a:solidFill>
+                  <a:srgbClr val="7EE0C8"/>
+                </a:solidFill>
+                <a:latin typeface="Consolas"/>
+              </a:rPr>
+              <a:t>DroneTelemetry</a:t>
+            </a:r>
+            <a:r>
+              <a:rPr sz="1450">
+                <a:solidFill>
+                  <a:srgbClr val="E9EEFB"/>
+                </a:solidFill>
+                <a:latin typeface="Consolas"/>
+              </a:rPr>
+              <a:t>.self, ...)</a:t>
             </a:r>
           </a:p>
           <a:p>
@@ -6088,7 +6081,43 @@
                 </a:solidFill>
                 <a:latin typeface="Consolas"/>
               </a:rPr>
-              <a:t>    }</a:t>
+              <a:t>    </a:t>
+            </a:r>
+            <a:r>
+              <a:rPr sz="1450">
+                <a:solidFill>
+                  <a:srgbClr val="7EE0C8"/>
+                </a:solidFill>
+                <a:latin typeface="Consolas"/>
+              </a:rPr>
+              <a:t>DispatchQueue</a:t>
+            </a:r>
+            <a:r>
+              <a:rPr sz="1450">
+                <a:solidFill>
+                  <a:srgbClr val="E9EEFB"/>
+                </a:solidFill>
+                <a:latin typeface="Consolas"/>
+              </a:rPr>
+              <a:t>.main.</a:t>
+            </a:r>
+            <a:r>
+              <a:rPr sz="1450">
+                <a:solidFill>
+                  <a:srgbClr val="82AAFF"/>
+                </a:solidFill>
+                <a:latin typeface="Consolas"/>
+              </a:rPr>
+              <a:t>async</a:t>
+            </a:r>
+            <a:r>
+              <a:rPr sz="1450">
+                <a:solidFill>
+                  <a:srgbClr val="E9EEFB"/>
+                </a:solidFill>
+                <a:latin typeface="Consolas"/>
+              </a:rPr>
+              <a:t> {</a:t>
             </a:r>
           </a:p>
           <a:p>
@@ -6103,11 +6132,95 @@
             <a:r>
               <a:rPr sz="1450">
                 <a:solidFill>
+                  <a:srgbClr val="FF7AB2"/>
+                </a:solidFill>
+                <a:latin typeface="Consolas"/>
+              </a:rPr>
+              <a:t>        self</a:t>
+            </a:r>
+            <a:r>
+              <a:rPr sz="1450">
+                <a:solidFill>
                   <a:srgbClr val="E9EEFB"/>
                 </a:solidFill>
                 <a:latin typeface="Consolas"/>
               </a:rPr>
-              <a:t>}</a:t>
+              <a:t>.telemetry   = decoded   </a:t>
+            </a:r>
+            <a:r>
+              <a:rPr sz="1450">
+                <a:solidFill>
+                  <a:srgbClr val="5D6B8F"/>
+                </a:solidFill>
+                <a:latin typeface="Consolas"/>
+              </a:rPr>
+              <a:t>// @Published → SwiftUI redraws</a:t>
+            </a:r>
+          </a:p>
+          <a:p>
+            <a:pPr>
+              <a:lnSpc>
+                <a:spcPct val="100000"/>
+              </a:lnSpc>
+              <a:spcAft>
+                <a:spcPts val="200"/>
+              </a:spcAft>
+            </a:pPr>
+            <a:r>
+              <a:rPr sz="1450">
+                <a:solidFill>
+                  <a:srgbClr val="FF7AB2"/>
+                </a:solidFill>
+                <a:latin typeface="Consolas"/>
+              </a:rPr>
+              <a:t>        self</a:t>
+            </a:r>
+            <a:r>
+              <a:rPr sz="1450">
+                <a:solidFill>
+                  <a:srgbClr val="E9EEFB"/>
+                </a:solidFill>
+                <a:latin typeface="Consolas"/>
+              </a:rPr>
+              <a:t>.isConnected = </a:t>
+            </a:r>
+            <a:r>
+              <a:rPr sz="1450">
+                <a:solidFill>
+                  <a:srgbClr val="FF7AB2"/>
+                </a:solidFill>
+                <a:latin typeface="Consolas"/>
+              </a:rPr>
+              <a:t>true</a:t>
+            </a:r>
+          </a:p>
+          <a:p>
+            <a:pPr>
+              <a:lnSpc>
+                <a:spcPct val="100000"/>
+              </a:lnSpc>
+              <a:spcAft>
+                <a:spcPts val="200"/>
+              </a:spcAft>
+            </a:pPr>
+            <a:r>
+              <a:rPr sz="1450">
+                <a:solidFill>
+                  <a:srgbClr val="E9EEFB"/>
+                </a:solidFill>
+                <a:latin typeface="Consolas"/>
+              </a:rPr>
+              <a:t>    }</a:t>
+            </a:r>
+            <a:r>
+              <a:rPr sz="1450">
+                <a:solidFill>
+                  <a:srgbClr val="E9EEFB"/>
+                </a:solidFill>
+                <a:latin typeface="Consolas"/>
+              </a:rPr>
+              <a:t>
+}</a:t>
             </a:r>
           </a:p>
         </p:txBody>
@@ -6211,7 +6324,7 @@
                 </a:solidFill>
                 <a:latin typeface="Helvetica Neue"/>
               </a:rPr>
-              <a:t>CODE · LIVE TELEMETRY</a:t>
+              <a:t>CODE · SENSORS &amp; COMMANDS</a:t>
             </a:r>
           </a:p>
         </p:txBody>
@@ -6253,7 +6366,7 @@
                 </a:solidFill>
                 <a:latin typeface="Helvetica Neue"/>
               </a:rPr>
-              <a:t>Decoding 10 Hz telemetry into the UI</a:t>
+              <a:t>Phone tilt → drone command</a:t>
             </a:r>
           </a:p>
         </p:txBody>
@@ -6317,7 +6430,7 @@
                 </a:solidFill>
                 <a:latin typeface="Consolas"/>
               </a:rPr>
-              <a:t>// Codable struct mirrors the ESP32 JSON exactly</a:t>
+              <a:t>// CoreMotion device-motion updates @ 10 Hz</a:t>
             </a:r>
           </a:p>
           <a:p>
@@ -6332,47 +6445,38 @@
             <a:r>
               <a:rPr sz="1450">
                 <a:solidFill>
+                  <a:srgbClr val="E9EEFB"/>
+                </a:solidFill>
+                <a:latin typeface="Consolas"/>
+              </a:rPr>
+              <a:t>motionManager.</a:t>
+            </a:r>
+            <a:r>
+              <a:rPr sz="1450">
+                <a:solidFill>
+                  <a:srgbClr val="82AAFF"/>
+                </a:solidFill>
+                <a:latin typeface="Consolas"/>
+              </a:rPr>
+              <a:t>startDeviceMotionUpdates</a:t>
+            </a:r>
+            <a:r>
+              <a:rPr sz="1450">
+                <a:solidFill>
+                  <a:srgbClr val="E9EEFB"/>
+                </a:solidFill>
+                <a:latin typeface="Consolas"/>
+              </a:rPr>
+              <a:t>(to: .main) { data, _ </a:t>
+            </a:r>
+            <a:r>
+              <a:rPr sz="1450">
+                <a:solidFill>
                   <a:srgbClr val="FF7AB2"/>
                 </a:solidFill>
                 <a:latin typeface="Consolas"/>
               </a:rPr>
-              <a:t>struct </a:t>
-            </a:r>
-            <a:r>
-              <a:rPr sz="1450">
-                <a:solidFill>
-                  <a:srgbClr val="7EE0C8"/>
-                </a:solidFill>
-                <a:latin typeface="Consolas"/>
-              </a:rPr>
-              <a:t>DroneTelemetry</a:t>
-            </a:r>
-            <a:r>
-              <a:rPr sz="1450">
-                <a:solidFill>
-                  <a:srgbClr val="E9EEFB"/>
-                </a:solidFill>
-                <a:latin typeface="Consolas"/>
-              </a:rPr>
-              <a:t>: </a:t>
-            </a:r>
-            <a:r>
-              <a:rPr sz="1450">
-                <a:solidFill>
-                  <a:srgbClr val="7EE0C8"/>
-                </a:solidFill>
-                <a:latin typeface="Consolas"/>
-              </a:rPr>
-              <a:t>Codable</a:t>
-            </a:r>
-            <a:r>
-              <a:rPr sz="1450">
-                <a:solidFill>
-                  <a:srgbClr val="E9EEFB"/>
-                </a:solidFill>
-                <a:latin typeface="Consolas"/>
-              </a:rPr>
-              <a:t> {</a:t>
+              <a:t>in</a:t>
             </a:r>
           </a:p>
           <a:p>
@@ -6400,16 +6504,25 @@
                 </a:solidFill>
                 <a:latin typeface="Consolas"/>
               </a:rPr>
-              <a:t> roll, pitch, yaw: </a:t>
-            </a:r>
-            <a:r>
-              <a:rPr sz="1450">
-                <a:solidFill>
-                  <a:srgbClr val="7EE0C8"/>
-                </a:solidFill>
-                <a:latin typeface="Consolas"/>
-              </a:rPr>
-              <a:t>Float</a:t>
+              <a:t> r = </a:t>
+            </a:r>
+            <a:r>
+              <a:rPr sz="1450">
+                <a:solidFill>
+                  <a:srgbClr val="F7C873"/>
+                </a:solidFill>
+                <a:latin typeface="Consolas"/>
+              </a:rPr>
+              <a:t>180</a:t>
+            </a:r>
+            <a:r>
+              <a:rPr sz="1450">
+                <a:solidFill>
+                  <a:srgbClr val="E9EEFB"/>
+                </a:solidFill>
+                <a:latin typeface="Consolas"/>
+              </a:rPr>
+              <a:t> / .pi</a:t>
             </a:r>
           </a:p>
           <a:p>
@@ -6428,7 +6541,7 @@
                 </a:solidFill>
                 <a:latin typeface="Consolas"/>
               </a:rPr>
-              <a:t>    let</a:t>
+              <a:t>    self</a:t>
             </a:r>
             <a:r>
               <a:rPr sz="1450">
@@ -6437,25 +6550,7 @@
                 </a:solidFill>
                 <a:latin typeface="Consolas"/>
               </a:rPr>
-              <a:t> m1, m2, m3, m4: </a:t>
-            </a:r>
-            <a:r>
-              <a:rPr sz="1450">
-                <a:solidFill>
-                  <a:srgbClr val="7EE0C8"/>
-                </a:solidFill>
-                <a:latin typeface="Consolas"/>
-              </a:rPr>
-              <a:t>Int</a:t>
-            </a:r>
-            <a:r>
-              <a:rPr sz="1450">
-                <a:solidFill>
-                  <a:srgbClr val="E9EEFB"/>
-                </a:solidFill>
-                <a:latin typeface="Consolas"/>
-              </a:rPr>
-              <a:t>?</a:t>
+              <a:t>.pitch = data.attitude.pitch * r</a:t>
             </a:r>
           </a:p>
           <a:p>
@@ -6474,7 +6569,7 @@
                 </a:solidFill>
                 <a:latin typeface="Consolas"/>
               </a:rPr>
-              <a:t>    let</a:t>
+              <a:t>    self</a:t>
             </a:r>
             <a:r>
               <a:rPr sz="1450">
@@ -6483,61 +6578,7 @@
                 </a:solidFill>
                 <a:latin typeface="Consolas"/>
               </a:rPr>
-              <a:t> voltage: </a:t>
-            </a:r>
-            <a:r>
-              <a:rPr sz="1450">
-                <a:solidFill>
-                  <a:srgbClr val="7EE0C8"/>
-                </a:solidFill>
-                <a:latin typeface="Consolas"/>
-              </a:rPr>
-              <a:t>Float</a:t>
-            </a:r>
-            <a:r>
-              <a:rPr sz="1450">
-                <a:solidFill>
-                  <a:srgbClr val="E9EEFB"/>
-                </a:solidFill>
-                <a:latin typeface="Consolas"/>
-              </a:rPr>
-              <a:t>?, armed: </a:t>
-            </a:r>
-            <a:r>
-              <a:rPr sz="1450">
-                <a:solidFill>
-                  <a:srgbClr val="7EE0C8"/>
-                </a:solidFill>
-                <a:latin typeface="Consolas"/>
-              </a:rPr>
-              <a:t>Bool</a:t>
-            </a:r>
-            <a:r>
-              <a:rPr sz="1450">
-                <a:solidFill>
-                  <a:srgbClr val="E9EEFB"/>
-                </a:solidFill>
-                <a:latin typeface="Consolas"/>
-              </a:rPr>
-              <a:t>?, mode: </a:t>
-            </a:r>
-            <a:r>
-              <a:rPr sz="1450">
-                <a:solidFill>
-                  <a:srgbClr val="7EE0C8"/>
-                </a:solidFill>
-                <a:latin typeface="Consolas"/>
-              </a:rPr>
-              <a:t>String</a:t>
-            </a:r>
-            <a:r>
-              <a:rPr sz="1450">
-                <a:solidFill>
-                  <a:srgbClr val="E9EEFB"/>
-                </a:solidFill>
-                <a:latin typeface="Consolas"/>
-              </a:rPr>
-              <a:t>?</a:t>
+              <a:t>.roll  = data.attitude.roll  * r</a:t>
             </a:r>
           </a:p>
           <a:p>
@@ -6590,47 +6631,11 @@
             <a:r>
               <a:rPr sz="1450">
                 <a:solidFill>
-                  <a:srgbClr val="FF7AB2"/>
-                </a:solidFill>
-                <a:latin typeface="Consolas"/>
-              </a:rPr>
-              <a:t>private func </a:t>
-            </a:r>
-            <a:r>
-              <a:rPr sz="1450">
-                <a:solidFill>
-                  <a:srgbClr val="82AAFF"/>
-                </a:solidFill>
-                <a:latin typeface="Consolas"/>
-              </a:rPr>
-              <a:t>decodeJSON</a:t>
-            </a:r>
-            <a:r>
-              <a:rPr sz="1450">
-                <a:solidFill>
-                  <a:srgbClr val="E9EEFB"/>
-                </a:solidFill>
-                <a:latin typeface="Consolas"/>
-              </a:rPr>
-              <a:t>(_ text: </a:t>
-            </a:r>
-            <a:r>
-              <a:rPr sz="1450">
-                <a:solidFill>
-                  <a:srgbClr val="7EE0C8"/>
-                </a:solidFill>
-                <a:latin typeface="Consolas"/>
-              </a:rPr>
-              <a:t>String</a:t>
-            </a:r>
-            <a:r>
-              <a:rPr sz="1450">
-                <a:solidFill>
-                  <a:srgbClr val="E9EEFB"/>
-                </a:solidFill>
-                <a:latin typeface="Consolas"/>
-              </a:rPr>
-              <a:t>) {</a:t>
+                  <a:srgbClr val="5D6B8F"/>
+                </a:solidFill>
+                <a:latin typeface="Consolas"/>
+              </a:rPr>
+              <a:t>// Type-safe JSON command builder (ControlProfile)</a:t>
             </a:r>
           </a:p>
           <a:p>
@@ -6649,7 +6654,16 @@
                 </a:solidFill>
                 <a:latin typeface="Consolas"/>
               </a:rPr>
-              <a:t>    let</a:t>
+              <a:t>func </a:t>
+            </a:r>
+            <a:r>
+              <a:rPr sz="1450">
+                <a:solidFill>
+                  <a:srgbClr val="82AAFF"/>
+                </a:solidFill>
+                <a:latin typeface="Consolas"/>
+              </a:rPr>
+              <a:t>startBalanceCommand</a:t>
             </a:r>
             <a:r>
               <a:rPr sz="1450">
@@ -6658,16 +6672,16 @@
                 </a:solidFill>
                 <a:latin typeface="Consolas"/>
               </a:rPr>
-              <a:t> decoded = </a:t>
-            </a:r>
-            <a:r>
-              <a:rPr sz="1450">
-                <a:solidFill>
-                  <a:srgbClr val="FF7AB2"/>
-                </a:solidFill>
-                <a:latin typeface="Consolas"/>
-              </a:rPr>
-              <a:t>try</a:t>
+              <a:t>() -&gt; </a:t>
+            </a:r>
+            <a:r>
+              <a:rPr sz="1450">
+                <a:solidFill>
+                  <a:srgbClr val="7EE0C8"/>
+                </a:solidFill>
+                <a:latin typeface="Consolas"/>
+              </a:rPr>
+              <a:t>String</a:t>
             </a:r>
             <a:r>
               <a:rPr sz="1450">
@@ -6676,61 +6690,7 @@
                 </a:solidFill>
                 <a:latin typeface="Consolas"/>
               </a:rPr>
-              <a:t> </a:t>
-            </a:r>
-            <a:r>
-              <a:rPr sz="1450">
-                <a:solidFill>
-                  <a:srgbClr val="7EE0C8"/>
-                </a:solidFill>
-                <a:latin typeface="Consolas"/>
-              </a:rPr>
-              <a:t>JSONDecoder</a:t>
-            </a:r>
-            <a:r>
-              <a:rPr sz="1450">
-                <a:solidFill>
-                  <a:srgbClr val="E9EEFB"/>
-                </a:solidFill>
-                <a:latin typeface="Consolas"/>
-              </a:rPr>
-              <a:t>().</a:t>
-            </a:r>
-            <a:r>
-              <a:rPr sz="1450">
-                <a:solidFill>
-                  <a:srgbClr val="82AAFF"/>
-                </a:solidFill>
-                <a:latin typeface="Consolas"/>
-              </a:rPr>
-              <a:t>decode</a:t>
-            </a:r>
-            <a:r>
-              <a:rPr sz="1450">
-                <a:solidFill>
-                  <a:srgbClr val="E9EEFB"/>
-                </a:solidFill>
-                <a:latin typeface="Consolas"/>
-              </a:rPr>
-              <a:t>(</a:t>
-            </a:r>
-            <a:r>
-              <a:rPr sz="1450">
-                <a:solidFill>
-                  <a:srgbClr val="7EE0C8"/>
-                </a:solidFill>
-                <a:latin typeface="Consolas"/>
-              </a:rPr>
-              <a:t>DroneTelemetry</a:t>
-            </a:r>
-            <a:r>
-              <a:rPr sz="1450">
-                <a:solidFill>
-                  <a:srgbClr val="E9EEFB"/>
-                </a:solidFill>
-                <a:latin typeface="Consolas"/>
-              </a:rPr>
-              <a:t>.self, ...)</a:t>
+              <a:t> {</a:t>
             </a:r>
           </a:p>
           <a:p>
@@ -6754,38 +6714,11 @@
             <a:r>
               <a:rPr sz="1450">
                 <a:solidFill>
-                  <a:srgbClr val="7EE0C8"/>
-                </a:solidFill>
-                <a:latin typeface="Consolas"/>
-              </a:rPr>
-              <a:t>DispatchQueue</a:t>
-            </a:r>
-            <a:r>
-              <a:rPr sz="1450">
-                <a:solidFill>
-                  <a:srgbClr val="E9EEFB"/>
-                </a:solidFill>
-                <a:latin typeface="Consolas"/>
-              </a:rPr>
-              <a:t>.main.</a:t>
-            </a:r>
-            <a:r>
-              <a:rPr sz="1450">
-                <a:solidFill>
-                  <a:srgbClr val="82AAFF"/>
-                </a:solidFill>
-                <a:latin typeface="Consolas"/>
-              </a:rPr>
-              <a:t>async</a:t>
-            </a:r>
-            <a:r>
-              <a:rPr sz="1450">
-                <a:solidFill>
-                  <a:srgbClr val="E9EEFB"/>
-                </a:solidFill>
-                <a:latin typeface="Consolas"/>
-              </a:rPr>
-              <a:t> {</a:t>
+                  <a:srgbClr val="C3E88D"/>
+                </a:solidFill>
+                <a:latin typeface="Consolas"/>
+              </a:rPr>
+              <a:t>"""{"cmd":"START_BALANCE","baseThrottle":\(baseThrottle),</a:t>
             </a:r>
           </a:p>
           <a:p>
@@ -6800,29 +6733,11 @@
             <a:r>
               <a:rPr sz="1450">
                 <a:solidFill>
-                  <a:srgbClr val="FF7AB2"/>
-                </a:solidFill>
-                <a:latin typeface="Consolas"/>
-              </a:rPr>
-              <a:t>        self</a:t>
-            </a:r>
-            <a:r>
-              <a:rPr sz="1450">
-                <a:solidFill>
-                  <a:srgbClr val="E9EEFB"/>
-                </a:solidFill>
-                <a:latin typeface="Consolas"/>
-              </a:rPr>
-              <a:t>.telemetry   = decoded   </a:t>
-            </a:r>
-            <a:r>
-              <a:rPr sz="1450">
-                <a:solidFill>
-                  <a:srgbClr val="5D6B8F"/>
-                </a:solidFill>
-                <a:latin typeface="Consolas"/>
-              </a:rPr>
-              <a:t>// @Published → SwiftUI redraws</a:t>
+                  <a:srgbClr val="C3E88D"/>
+                </a:solidFill>
+                <a:latin typeface="Consolas"/>
+              </a:rPr>
+              <a:t>       "kPRoll":\(kPRoll),"kPPitch":\(kPPitch)}"""</a:t>
             </a:r>
           </a:p>
           <a:p>
@@ -6837,58 +6752,11 @@
             <a:r>
               <a:rPr sz="1450">
                 <a:solidFill>
-                  <a:srgbClr val="FF7AB2"/>
-                </a:solidFill>
-                <a:latin typeface="Consolas"/>
-              </a:rPr>
-              <a:t>        self</a:t>
-            </a:r>
-            <a:r>
-              <a:rPr sz="1450">
-                <a:solidFill>
                   <a:srgbClr val="E9EEFB"/>
                 </a:solidFill>
                 <a:latin typeface="Consolas"/>
               </a:rPr>
-              <a:t>.isConnected = </a:t>
-            </a:r>
-            <a:r>
-              <a:rPr sz="1450">
-                <a:solidFill>
-                  <a:srgbClr val="FF7AB2"/>
-                </a:solidFill>
-                <a:latin typeface="Consolas"/>
-              </a:rPr>
-              <a:t>true</a:t>
-            </a:r>
-          </a:p>
-          <a:p>
-            <a:pPr>
-              <a:lnSpc>
-                <a:spcPct val="100000"/>
-              </a:lnSpc>
-              <a:spcAft>
-                <a:spcPts val="200"/>
-              </a:spcAft>
-            </a:pPr>
-            <a:r>
-              <a:rPr sz="1450">
-                <a:solidFill>
-                  <a:srgbClr val="E9EEFB"/>
-                </a:solidFill>
-                <a:latin typeface="Consolas"/>
-              </a:rPr>
-              <a:t>    }</a:t>
-            </a:r>
-            <a:r>
-              <a:rPr sz="1450">
-                <a:solidFill>
-                  <a:srgbClr val="E9EEFB"/>
-                </a:solidFill>
-                <a:latin typeface="Consolas"/>
-              </a:rPr>
-              <a:t>
-}</a:t>
+              <a:t>}</a:t>
             </a:r>
           </a:p>
         </p:txBody>
@@ -6992,7 +6860,7 @@
                 </a:solidFill>
                 <a:latin typeface="Helvetica Neue"/>
               </a:rPr>
-              <a:t>CODE · SENSORS &amp; COMMANDS</a:t>
+              <a:t>CHALLENGES</a:t>
             </a:r>
           </a:p>
         </p:txBody>
@@ -7034,7 +6902,7 @@
                 </a:solidFill>
                 <a:latin typeface="Helvetica Neue"/>
               </a:rPr>
-              <a:t>Phone tilt → drone command</a:t>
+              <a:t>What was hard — and how we solved it</a:t>
             </a:r>
           </a:p>
         </p:txBody>
@@ -7048,19 +6916,19 @@
         <p:spPr>
           <a:xfrm>
             <a:off x="777240" y="1828800"/>
-            <a:ext cx="10607040" cy="3931920"/>
+            <a:ext cx="5349240" cy="1874519"/>
           </a:xfrm>
           <a:prstGeom prst="roundRect">
             <a:avLst>
-              <a:gd name="adj" fmla="val 3000"/>
+              <a:gd name="adj" fmla="val 6000"/>
             </a:avLst>
           </a:prstGeom>
           <a:solidFill>
-            <a:srgbClr val="0C1326"/>
+            <a:srgbClr val="141C33"/>
           </a:solidFill>
-          <a:ln w="12700">
+          <a:ln w="15875">
             <a:solidFill>
-              <a:srgbClr val="2979FF"/>
+              <a:srgbClr val="33D980"/>
             </a:solidFill>
           </a:ln>
           <a:effectLst/>
@@ -7080,351 +6948,489 @@
           </a:fontRef>
         </p:style>
         <p:txBody>
-          <a:bodyPr rtlCol="0" anchor="ctr" wrap="square" lIns="320040" tIns="228600" rIns="182880"/>
-          <a:lstStyle/>
-          <a:p>
-            <a:pPr algn="ctr">
-              <a:lnSpc>
-                <a:spcPct val="100000"/>
-              </a:lnSpc>
-              <a:spcAft>
-                <a:spcPts val="200"/>
-              </a:spcAft>
-            </a:pPr>
-            <a:r>
-              <a:rPr sz="1450">
-                <a:solidFill>
-                  <a:srgbClr val="5D6B8F"/>
-                </a:solidFill>
-                <a:latin typeface="Consolas"/>
-              </a:rPr>
-              <a:t>// CoreMotion device-motion updates @ 10 Hz</a:t>
-            </a:r>
-          </a:p>
-          <a:p>
-            <a:pPr>
-              <a:lnSpc>
-                <a:spcPct val="100000"/>
-              </a:lnSpc>
-              <a:spcAft>
-                <a:spcPts val="200"/>
-              </a:spcAft>
-            </a:pPr>
-            <a:r>
-              <a:rPr sz="1450">
-                <a:solidFill>
-                  <a:srgbClr val="E9EEFB"/>
-                </a:solidFill>
-                <a:latin typeface="Consolas"/>
-              </a:rPr>
-              <a:t>motionManager.</a:t>
-            </a:r>
-            <a:r>
-              <a:rPr sz="1450">
-                <a:solidFill>
-                  <a:srgbClr val="82AAFF"/>
-                </a:solidFill>
-                <a:latin typeface="Consolas"/>
-              </a:rPr>
-              <a:t>startDeviceMotionUpdates</a:t>
-            </a:r>
-            <a:r>
-              <a:rPr sz="1450">
-                <a:solidFill>
-                  <a:srgbClr val="E9EEFB"/>
-                </a:solidFill>
-                <a:latin typeface="Consolas"/>
-              </a:rPr>
-              <a:t>(to: .main) { data, _ </a:t>
-            </a:r>
-            <a:r>
-              <a:rPr sz="1450">
-                <a:solidFill>
-                  <a:srgbClr val="FF7AB2"/>
-                </a:solidFill>
-                <a:latin typeface="Consolas"/>
-              </a:rPr>
-              <a:t>in</a:t>
-            </a:r>
-          </a:p>
-          <a:p>
-            <a:pPr>
-              <a:lnSpc>
-                <a:spcPct val="100000"/>
-              </a:lnSpc>
-              <a:spcAft>
-                <a:spcPts val="200"/>
-              </a:spcAft>
-            </a:pPr>
-            <a:r>
-              <a:rPr sz="1450">
-                <a:solidFill>
-                  <a:srgbClr val="FF7AB2"/>
-                </a:solidFill>
-                <a:latin typeface="Consolas"/>
-              </a:rPr>
-              <a:t>    let</a:t>
-            </a:r>
-            <a:r>
-              <a:rPr sz="1450">
-                <a:solidFill>
-                  <a:srgbClr val="E9EEFB"/>
-                </a:solidFill>
-                <a:latin typeface="Consolas"/>
-              </a:rPr>
-              <a:t> r = </a:t>
-            </a:r>
-            <a:r>
-              <a:rPr sz="1450">
-                <a:solidFill>
-                  <a:srgbClr val="F7C873"/>
-                </a:solidFill>
-                <a:latin typeface="Consolas"/>
-              </a:rPr>
-              <a:t>180</a:t>
-            </a:r>
-            <a:r>
-              <a:rPr sz="1450">
-                <a:solidFill>
-                  <a:srgbClr val="E9EEFB"/>
-                </a:solidFill>
-                <a:latin typeface="Consolas"/>
-              </a:rPr>
-              <a:t> / .pi</a:t>
-            </a:r>
-          </a:p>
-          <a:p>
-            <a:pPr>
-              <a:lnSpc>
-                <a:spcPct val="100000"/>
-              </a:lnSpc>
-              <a:spcAft>
-                <a:spcPts val="200"/>
-              </a:spcAft>
-            </a:pPr>
-            <a:r>
-              <a:rPr sz="1450">
-                <a:solidFill>
-                  <a:srgbClr val="FF7AB2"/>
-                </a:solidFill>
-                <a:latin typeface="Consolas"/>
-              </a:rPr>
-              <a:t>    self</a:t>
-            </a:r>
-            <a:r>
-              <a:rPr sz="1450">
-                <a:solidFill>
-                  <a:srgbClr val="E9EEFB"/>
-                </a:solidFill>
-                <a:latin typeface="Consolas"/>
-              </a:rPr>
-              <a:t>.pitch = data.attitude.pitch * r</a:t>
-            </a:r>
-          </a:p>
-          <a:p>
-            <a:pPr>
-              <a:lnSpc>
-                <a:spcPct val="100000"/>
-              </a:lnSpc>
-              <a:spcAft>
-                <a:spcPts val="200"/>
-              </a:spcAft>
-            </a:pPr>
-            <a:r>
-              <a:rPr sz="1450">
-                <a:solidFill>
-                  <a:srgbClr val="FF7AB2"/>
-                </a:solidFill>
-                <a:latin typeface="Consolas"/>
-              </a:rPr>
-              <a:t>    self</a:t>
-            </a:r>
-            <a:r>
-              <a:rPr sz="1450">
-                <a:solidFill>
-                  <a:srgbClr val="E9EEFB"/>
-                </a:solidFill>
-                <a:latin typeface="Consolas"/>
-              </a:rPr>
-              <a:t>.roll  = data.attitude.roll  * r</a:t>
-            </a:r>
-          </a:p>
-          <a:p>
-            <a:pPr>
-              <a:lnSpc>
-                <a:spcPct val="100000"/>
-              </a:lnSpc>
-              <a:spcAft>
-                <a:spcPts val="200"/>
-              </a:spcAft>
-            </a:pPr>
-            <a:r>
-              <a:rPr sz="1450">
-                <a:solidFill>
-                  <a:srgbClr val="E9EEFB"/>
-                </a:solidFill>
-                <a:latin typeface="Consolas"/>
-              </a:rPr>
-              <a:t>}</a:t>
-            </a:r>
-          </a:p>
-          <a:p>
-            <a:pPr>
-              <a:lnSpc>
-                <a:spcPct val="100000"/>
-              </a:lnSpc>
-              <a:spcAft>
-                <a:spcPts val="200"/>
-              </a:spcAft>
-            </a:pPr>
-            <a:r>
-              <a:rPr sz="1450">
-                <a:solidFill>
-                  <a:srgbClr val="E9EEFB"/>
-                </a:solidFill>
-                <a:latin typeface="Consolas"/>
-              </a:rPr>
-              <a:t/>
-            </a:r>
-          </a:p>
-          <a:p>
-            <a:pPr>
-              <a:lnSpc>
-                <a:spcPct val="100000"/>
-              </a:lnSpc>
-              <a:spcAft>
-                <a:spcPts val="200"/>
-              </a:spcAft>
-            </a:pPr>
-            <a:r>
-              <a:rPr sz="1450">
-                <a:solidFill>
-                  <a:srgbClr val="5D6B8F"/>
-                </a:solidFill>
-                <a:latin typeface="Consolas"/>
-              </a:rPr>
-              <a:t>// Type-safe JSON command builder (ControlProfile)</a:t>
-            </a:r>
-          </a:p>
-          <a:p>
-            <a:pPr>
-              <a:lnSpc>
-                <a:spcPct val="100000"/>
-              </a:lnSpc>
-              <a:spcAft>
-                <a:spcPts val="200"/>
-              </a:spcAft>
-            </a:pPr>
-            <a:r>
-              <a:rPr sz="1450">
-                <a:solidFill>
-                  <a:srgbClr val="FF7AB2"/>
-                </a:solidFill>
-                <a:latin typeface="Consolas"/>
-              </a:rPr>
-              <a:t>func </a:t>
-            </a:r>
-            <a:r>
-              <a:rPr sz="1450">
-                <a:solidFill>
-                  <a:srgbClr val="82AAFF"/>
-                </a:solidFill>
-                <a:latin typeface="Consolas"/>
-              </a:rPr>
-              <a:t>startBalanceCommand</a:t>
-            </a:r>
-            <a:r>
-              <a:rPr sz="1450">
-                <a:solidFill>
-                  <a:srgbClr val="E9EEFB"/>
-                </a:solidFill>
-                <a:latin typeface="Consolas"/>
-              </a:rPr>
-              <a:t>() -&gt; </a:t>
-            </a:r>
-            <a:r>
-              <a:rPr sz="1450">
-                <a:solidFill>
-                  <a:srgbClr val="7EE0C8"/>
-                </a:solidFill>
-                <a:latin typeface="Consolas"/>
-              </a:rPr>
-              <a:t>String</a:t>
-            </a:r>
-            <a:r>
-              <a:rPr sz="1450">
-                <a:solidFill>
-                  <a:srgbClr val="E9EEFB"/>
-                </a:solidFill>
-                <a:latin typeface="Consolas"/>
-              </a:rPr>
-              <a:t> {</a:t>
-            </a:r>
-          </a:p>
-          <a:p>
-            <a:pPr>
-              <a:lnSpc>
-                <a:spcPct val="100000"/>
-              </a:lnSpc>
-              <a:spcAft>
-                <a:spcPts val="200"/>
-              </a:spcAft>
-            </a:pPr>
-            <a:r>
-              <a:rPr sz="1450">
-                <a:solidFill>
-                  <a:srgbClr val="E9EEFB"/>
-                </a:solidFill>
-                <a:latin typeface="Consolas"/>
-              </a:rPr>
-              <a:t>    </a:t>
-            </a:r>
-            <a:r>
-              <a:rPr sz="1450">
-                <a:solidFill>
-                  <a:srgbClr val="C3E88D"/>
-                </a:solidFill>
-                <a:latin typeface="Consolas"/>
-              </a:rPr>
-              <a:t>"""{"cmd":"START_BALANCE","baseThrottle":\(baseThrottle),</a:t>
-            </a:r>
-          </a:p>
-          <a:p>
-            <a:pPr>
-              <a:lnSpc>
-                <a:spcPct val="100000"/>
-              </a:lnSpc>
-              <a:spcAft>
-                <a:spcPts val="200"/>
-              </a:spcAft>
-            </a:pPr>
-            <a:r>
-              <a:rPr sz="1450">
-                <a:solidFill>
-                  <a:srgbClr val="C3E88D"/>
-                </a:solidFill>
-                <a:latin typeface="Consolas"/>
-              </a:rPr>
-              <a:t>       "kPRoll":\(kPRoll),"kPPitch":\(kPPitch)}"""</a:t>
-            </a:r>
-          </a:p>
-          <a:p>
-            <a:pPr>
-              <a:lnSpc>
-                <a:spcPct val="100000"/>
-              </a:lnSpc>
-              <a:spcAft>
-                <a:spcPts val="200"/>
-              </a:spcAft>
-            </a:pPr>
-            <a:r>
-              <a:rPr sz="1450">
-                <a:solidFill>
-                  <a:srgbClr val="E9EEFB"/>
-                </a:solidFill>
-                <a:latin typeface="Consolas"/>
-              </a:rPr>
-              <a:t>}</a:t>
+          <a:bodyPr rtlCol="0" anchor="ctr"/>
+          <a:lstStyle/>
+          <a:p>
+            <a:pPr algn="ctr"/>
+          </a:p>
+        </p:txBody>
+      </p:sp>
+      <p:sp>
+        <p:nvSpPr>
+          <p:cNvPr id="6" name="TextBox 5"/>
+          <p:cNvSpPr txBox="1"/>
+          <p:nvPr/>
+        </p:nvSpPr>
+        <p:spPr>
+          <a:xfrm>
+            <a:off x="1097280" y="2103120"/>
+            <a:ext cx="4800600" cy="548640"/>
+          </a:xfrm>
+          <a:prstGeom prst="rect">
+            <a:avLst/>
+          </a:prstGeom>
+          <a:noFill/>
+        </p:spPr>
+        <p:txBody>
+          <a:bodyPr wrap="square" anchor="t" lIns="0" rIns="0" tIns="0" bIns="0">
+            <a:spAutoFit/>
+          </a:bodyPr>
+          <a:lstStyle/>
+          <a:p>
+            <a:pPr algn="l">
+              <a:spcBef>
+                <a:spcPts val="0"/>
+              </a:spcBef>
+              <a:spcAft>
+                <a:spcPts val="600"/>
+              </a:spcAft>
+            </a:pPr>
+            <a:r>
+              <a:rPr sz="2100" b="1">
+                <a:solidFill>
+                  <a:srgbClr val="33D980"/>
+                </a:solidFill>
+                <a:latin typeface="Helvetica Neue"/>
+              </a:rPr>
+              <a:t>Finding the drone</a:t>
+            </a:r>
+          </a:p>
+        </p:txBody>
+      </p:sp>
+      <p:sp>
+        <p:nvSpPr>
+          <p:cNvPr id="7" name="TextBox 6"/>
+          <p:cNvSpPr txBox="1"/>
+          <p:nvPr/>
+        </p:nvSpPr>
+        <p:spPr>
+          <a:xfrm>
+            <a:off x="1097280" y="2697480"/>
+            <a:ext cx="4709160" cy="914400"/>
+          </a:xfrm>
+          <a:prstGeom prst="rect">
+            <a:avLst/>
+          </a:prstGeom>
+          <a:noFill/>
+        </p:spPr>
+        <p:txBody>
+          <a:bodyPr wrap="square" anchor="t" lIns="0" rIns="0" tIns="0" bIns="0">
+            <a:spAutoFit/>
+          </a:bodyPr>
+          <a:lstStyle/>
+          <a:p>
+            <a:pPr algn="l">
+              <a:spcBef>
+                <a:spcPts val="0"/>
+              </a:spcBef>
+              <a:spcAft>
+                <a:spcPts val="0"/>
+              </a:spcAft>
+            </a:pPr>
+            <a:r>
+              <a:rPr sz="1450" b="0">
+                <a:solidFill>
+                  <a:srgbClr val="8A97B8"/>
+                </a:solidFill>
+                <a:latin typeface="Helvetica Neue"/>
+              </a:rPr>
+              <a:t>The ESP32 gets a random DHCP IP. A UDP beacon broadcasts the IP every 5 s, so the app auto-connects — no typing.</a:t>
+            </a:r>
+          </a:p>
+        </p:txBody>
+      </p:sp>
+      <p:sp>
+        <p:nvSpPr>
+          <p:cNvPr id="8" name="Rounded Rectangle 7"/>
+          <p:cNvSpPr/>
+          <p:nvPr/>
+        </p:nvSpPr>
+        <p:spPr>
+          <a:xfrm>
+            <a:off x="6400800" y="1828800"/>
+            <a:ext cx="5349240" cy="1874519"/>
+          </a:xfrm>
+          <a:prstGeom prst="roundRect">
+            <a:avLst>
+              <a:gd name="adj" fmla="val 6000"/>
+            </a:avLst>
+          </a:prstGeom>
+          <a:solidFill>
+            <a:srgbClr val="141C33"/>
+          </a:solidFill>
+          <a:ln w="15875">
+            <a:solidFill>
+              <a:srgbClr val="2979FF"/>
+            </a:solidFill>
+          </a:ln>
+          <a:effectLst/>
+        </p:spPr>
+        <p:style>
+          <a:lnRef idx="1">
+            <a:schemeClr val="accent1"/>
+          </a:lnRef>
+          <a:fillRef idx="3">
+            <a:schemeClr val="accent1"/>
+          </a:fillRef>
+          <a:effectRef idx="2">
+            <a:schemeClr val="accent1"/>
+          </a:effectRef>
+          <a:fontRef idx="minor">
+            <a:schemeClr val="lt1"/>
+          </a:fontRef>
+        </p:style>
+        <p:txBody>
+          <a:bodyPr rtlCol="0" anchor="ctr"/>
+          <a:lstStyle/>
+          <a:p>
+            <a:pPr algn="ctr"/>
+          </a:p>
+        </p:txBody>
+      </p:sp>
+      <p:sp>
+        <p:nvSpPr>
+          <p:cNvPr id="9" name="TextBox 8"/>
+          <p:cNvSpPr txBox="1"/>
+          <p:nvPr/>
+        </p:nvSpPr>
+        <p:spPr>
+          <a:xfrm>
+            <a:off x="6720840" y="2103120"/>
+            <a:ext cx="4800600" cy="548640"/>
+          </a:xfrm>
+          <a:prstGeom prst="rect">
+            <a:avLst/>
+          </a:prstGeom>
+          <a:noFill/>
+        </p:spPr>
+        <p:txBody>
+          <a:bodyPr wrap="square" anchor="t" lIns="0" rIns="0" tIns="0" bIns="0">
+            <a:spAutoFit/>
+          </a:bodyPr>
+          <a:lstStyle/>
+          <a:p>
+            <a:pPr algn="l">
+              <a:spcBef>
+                <a:spcPts val="0"/>
+              </a:spcBef>
+              <a:spcAft>
+                <a:spcPts val="600"/>
+              </a:spcAft>
+            </a:pPr>
+            <a:r>
+              <a:rPr sz="2100" b="1">
+                <a:solidFill>
+                  <a:srgbClr val="2979FF"/>
+                </a:solidFill>
+                <a:latin typeface="Helvetica Neue"/>
+              </a:rPr>
+              <a:t>Detecting a dropped link</a:t>
+            </a:r>
+          </a:p>
+        </p:txBody>
+      </p:sp>
+      <p:sp>
+        <p:nvSpPr>
+          <p:cNvPr id="10" name="TextBox 9"/>
+          <p:cNvSpPr txBox="1"/>
+          <p:nvPr/>
+        </p:nvSpPr>
+        <p:spPr>
+          <a:xfrm>
+            <a:off x="6720840" y="2697480"/>
+            <a:ext cx="4709160" cy="914400"/>
+          </a:xfrm>
+          <a:prstGeom prst="rect">
+            <a:avLst/>
+          </a:prstGeom>
+          <a:noFill/>
+        </p:spPr>
+        <p:txBody>
+          <a:bodyPr wrap="square" anchor="t" lIns="0" rIns="0" tIns="0" bIns="0">
+            <a:spAutoFit/>
+          </a:bodyPr>
+          <a:lstStyle/>
+          <a:p>
+            <a:pPr algn="l">
+              <a:spcBef>
+                <a:spcPts val="0"/>
+              </a:spcBef>
+              <a:spcAft>
+                <a:spcPts val="0"/>
+              </a:spcAft>
+            </a:pPr>
+            <a:r>
+              <a:rPr sz="1450" b="0">
+                <a:solidFill>
+                  <a:srgbClr val="8A97B8"/>
+                </a:solidFill>
+                <a:latin typeface="Helvetica Neue"/>
+              </a:rPr>
+              <a:t>WiFi can die silently. A 3 s timeout timer + 5 s WebSocket pings flip isConnected false the instant data stops.</a:t>
+            </a:r>
+          </a:p>
+        </p:txBody>
+      </p:sp>
+      <p:sp>
+        <p:nvSpPr>
+          <p:cNvPr id="11" name="Rounded Rectangle 10"/>
+          <p:cNvSpPr/>
+          <p:nvPr/>
+        </p:nvSpPr>
+        <p:spPr>
+          <a:xfrm>
+            <a:off x="777240" y="3977639"/>
+            <a:ext cx="5349240" cy="1874519"/>
+          </a:xfrm>
+          <a:prstGeom prst="roundRect">
+            <a:avLst>
+              <a:gd name="adj" fmla="val 6000"/>
+            </a:avLst>
+          </a:prstGeom>
+          <a:solidFill>
+            <a:srgbClr val="141C33"/>
+          </a:solidFill>
+          <a:ln w="15875">
+            <a:solidFill>
+              <a:srgbClr val="FF9900"/>
+            </a:solidFill>
+          </a:ln>
+          <a:effectLst/>
+        </p:spPr>
+        <p:style>
+          <a:lnRef idx="1">
+            <a:schemeClr val="accent1"/>
+          </a:lnRef>
+          <a:fillRef idx="3">
+            <a:schemeClr val="accent1"/>
+          </a:fillRef>
+          <a:effectRef idx="2">
+            <a:schemeClr val="accent1"/>
+          </a:effectRef>
+          <a:fontRef idx="minor">
+            <a:schemeClr val="lt1"/>
+          </a:fontRef>
+        </p:style>
+        <p:txBody>
+          <a:bodyPr rtlCol="0" anchor="ctr"/>
+          <a:lstStyle/>
+          <a:p>
+            <a:pPr algn="ctr"/>
+          </a:p>
+        </p:txBody>
+      </p:sp>
+      <p:sp>
+        <p:nvSpPr>
+          <p:cNvPr id="12" name="TextBox 11"/>
+          <p:cNvSpPr txBox="1"/>
+          <p:nvPr/>
+        </p:nvSpPr>
+        <p:spPr>
+          <a:xfrm>
+            <a:off x="1097280" y="4251959"/>
+            <a:ext cx="4800600" cy="548640"/>
+          </a:xfrm>
+          <a:prstGeom prst="rect">
+            <a:avLst/>
+          </a:prstGeom>
+          <a:noFill/>
+        </p:spPr>
+        <p:txBody>
+          <a:bodyPr wrap="square" anchor="t" lIns="0" rIns="0" tIns="0" bIns="0">
+            <a:spAutoFit/>
+          </a:bodyPr>
+          <a:lstStyle/>
+          <a:p>
+            <a:pPr algn="l">
+              <a:spcBef>
+                <a:spcPts val="0"/>
+              </a:spcBef>
+              <a:spcAft>
+                <a:spcPts val="600"/>
+              </a:spcAft>
+            </a:pPr>
+            <a:r>
+              <a:rPr sz="2100" b="1">
+                <a:solidFill>
+                  <a:srgbClr val="FF9900"/>
+                </a:solidFill>
+                <a:latin typeface="Helvetica Neue"/>
+              </a:rPr>
+              <a:t>Thread safety</a:t>
+            </a:r>
+          </a:p>
+        </p:txBody>
+      </p:sp>
+      <p:sp>
+        <p:nvSpPr>
+          <p:cNvPr id="13" name="TextBox 12"/>
+          <p:cNvSpPr txBox="1"/>
+          <p:nvPr/>
+        </p:nvSpPr>
+        <p:spPr>
+          <a:xfrm>
+            <a:off x="1097280" y="4846319"/>
+            <a:ext cx="4709160" cy="914400"/>
+          </a:xfrm>
+          <a:prstGeom prst="rect">
+            <a:avLst/>
+          </a:prstGeom>
+          <a:noFill/>
+        </p:spPr>
+        <p:txBody>
+          <a:bodyPr wrap="square" anchor="t" lIns="0" rIns="0" tIns="0" bIns="0">
+            <a:spAutoFit/>
+          </a:bodyPr>
+          <a:lstStyle/>
+          <a:p>
+            <a:pPr algn="l">
+              <a:spcBef>
+                <a:spcPts val="0"/>
+              </a:spcBef>
+              <a:spcAft>
+                <a:spcPts val="0"/>
+              </a:spcAft>
+            </a:pPr>
+            <a:r>
+              <a:rPr sz="1450" b="0">
+                <a:solidFill>
+                  <a:srgbClr val="8A97B8"/>
+                </a:solidFill>
+                <a:latin typeface="Helvetica Neue"/>
+              </a:rPr>
+              <a:t>SceneKit physics runs on the render thread, SwiftUI only on main. Physics writes _vars, synced to @Published at 20 Hz.</a:t>
+            </a:r>
+          </a:p>
+        </p:txBody>
+      </p:sp>
+      <p:sp>
+        <p:nvSpPr>
+          <p:cNvPr id="14" name="Rounded Rectangle 13"/>
+          <p:cNvSpPr/>
+          <p:nvPr/>
+        </p:nvSpPr>
+        <p:spPr>
+          <a:xfrm>
+            <a:off x="6400800" y="3977639"/>
+            <a:ext cx="5349240" cy="1874519"/>
+          </a:xfrm>
+          <a:prstGeom prst="roundRect">
+            <a:avLst>
+              <a:gd name="adj" fmla="val 6000"/>
+            </a:avLst>
+          </a:prstGeom>
+          <a:solidFill>
+            <a:srgbClr val="141C33"/>
+          </a:solidFill>
+          <a:ln w="15875">
+            <a:solidFill>
+              <a:srgbClr val="FF4545"/>
+            </a:solidFill>
+          </a:ln>
+          <a:effectLst/>
+        </p:spPr>
+        <p:style>
+          <a:lnRef idx="1">
+            <a:schemeClr val="accent1"/>
+          </a:lnRef>
+          <a:fillRef idx="3">
+            <a:schemeClr val="accent1"/>
+          </a:fillRef>
+          <a:effectRef idx="2">
+            <a:schemeClr val="accent1"/>
+          </a:effectRef>
+          <a:fontRef idx="minor">
+            <a:schemeClr val="lt1"/>
+          </a:fontRef>
+        </p:style>
+        <p:txBody>
+          <a:bodyPr rtlCol="0" anchor="ctr"/>
+          <a:lstStyle/>
+          <a:p>
+            <a:pPr algn="ctr"/>
+          </a:p>
+        </p:txBody>
+      </p:sp>
+      <p:sp>
+        <p:nvSpPr>
+          <p:cNvPr id="15" name="TextBox 14"/>
+          <p:cNvSpPr txBox="1"/>
+          <p:nvPr/>
+        </p:nvSpPr>
+        <p:spPr>
+          <a:xfrm>
+            <a:off x="6720840" y="4251959"/>
+            <a:ext cx="4800600" cy="548640"/>
+          </a:xfrm>
+          <a:prstGeom prst="rect">
+            <a:avLst/>
+          </a:prstGeom>
+          <a:noFill/>
+        </p:spPr>
+        <p:txBody>
+          <a:bodyPr wrap="square" anchor="t" lIns="0" rIns="0" tIns="0" bIns="0">
+            <a:spAutoFit/>
+          </a:bodyPr>
+          <a:lstStyle/>
+          <a:p>
+            <a:pPr algn="l">
+              <a:spcBef>
+                <a:spcPts val="0"/>
+              </a:spcBef>
+              <a:spcAft>
+                <a:spcPts val="600"/>
+              </a:spcAft>
+            </a:pPr>
+            <a:r>
+              <a:rPr sz="2100" b="1">
+                <a:solidFill>
+                  <a:srgbClr val="FF4545"/>
+                </a:solidFill>
+                <a:latin typeface="Helvetica Neue"/>
+              </a:rPr>
+              <a:t>Flight safety</a:t>
+            </a:r>
+          </a:p>
+        </p:txBody>
+      </p:sp>
+      <p:sp>
+        <p:nvSpPr>
+          <p:cNvPr id="16" name="TextBox 15"/>
+          <p:cNvSpPr txBox="1"/>
+          <p:nvPr/>
+        </p:nvSpPr>
+        <p:spPr>
+          <a:xfrm>
+            <a:off x="6720840" y="4846319"/>
+            <a:ext cx="4709160" cy="914400"/>
+          </a:xfrm>
+          <a:prstGeom prst="rect">
+            <a:avLst/>
+          </a:prstGeom>
+          <a:noFill/>
+        </p:spPr>
+        <p:txBody>
+          <a:bodyPr wrap="square" anchor="t" lIns="0" rIns="0" tIns="0" bIns="0">
+            <a:spAutoFit/>
+          </a:bodyPr>
+          <a:lstStyle/>
+          <a:p>
+            <a:pPr algn="l">
+              <a:spcBef>
+                <a:spcPts val="0"/>
+              </a:spcBef>
+              <a:spcAft>
+                <a:spcPts val="0"/>
+              </a:spcAft>
+            </a:pPr>
+            <a:r>
+              <a:rPr sz="1450" b="0">
+                <a:solidFill>
+                  <a:srgbClr val="8A97B8"/>
+                </a:solidFill>
+                <a:latin typeface="Helvetica Neue"/>
+              </a:rPr>
+              <a:t>Accidental motor spin is dangerous. 1.5 s hold-to-arm, debounced safe-test, and a tilt-over-60° emergency stop.</a:t>
             </a:r>
           </a:p>
         </p:txBody>
@@ -7528,7 +7534,7 @@
                 </a:solidFill>
                 <a:latin typeface="Helvetica Neue"/>
               </a:rPr>
-              <a:t>CHALLENGES</a:t>
+              <a:t>CODE · THE THREADING CHALLENGE</a:t>
             </a:r>
           </a:p>
         </p:txBody>
@@ -7570,33 +7576,75 @@
                 </a:solidFill>
                 <a:latin typeface="Helvetica Neue"/>
               </a:rPr>
-              <a:t>What was hard — and how we solved it</a:t>
-            </a:r>
-          </a:p>
-        </p:txBody>
-      </p:sp>
-      <p:sp>
-        <p:nvSpPr>
-          <p:cNvPr id="5" name="Rounded Rectangle 4"/>
+              <a:t>Two threads, one drone</a:t>
+            </a:r>
+          </a:p>
+        </p:txBody>
+      </p:sp>
+      <p:sp>
+        <p:nvSpPr>
+          <p:cNvPr id="5" name="TextBox 4"/>
+          <p:cNvSpPr txBox="1"/>
+          <p:nvPr/>
+        </p:nvSpPr>
+        <p:spPr>
+          <a:xfrm>
+            <a:off x="777240" y="1691640"/>
+            <a:ext cx="10607040" cy="640080"/>
+          </a:xfrm>
+          <a:prstGeom prst="rect">
+            <a:avLst/>
+          </a:prstGeom>
+          <a:noFill/>
+        </p:spPr>
+        <p:txBody>
+          <a:bodyPr wrap="square" anchor="t" lIns="0" rIns="0" tIns="0" bIns="0">
+            <a:spAutoFit/>
+          </a:bodyPr>
+          <a:lstStyle/>
+          <a:p>
+            <a:pPr algn="l">
+              <a:spcBef>
+                <a:spcPts val="0"/>
+              </a:spcBef>
+              <a:spcAft>
+                <a:spcPts val="600"/>
+              </a:spcAft>
+            </a:pPr>
+            <a:r>
+              <a:rPr sz="1600" b="0">
+                <a:solidFill>
+                  <a:srgbClr val="8A97B8"/>
+                </a:solidFill>
+                <a:latin typeface="Helvetica Neue"/>
+              </a:rPr>
+              <a:t>Physics on SceneKit's render thread must never touch SwiftUI directly — so internal state is kept separate from published state.</a:t>
+            </a:r>
+          </a:p>
+        </p:txBody>
+      </p:sp>
+      <p:sp>
+        <p:nvSpPr>
+          <p:cNvPr id="6" name="Rounded Rectangle 5"/>
           <p:cNvSpPr/>
           <p:nvPr/>
         </p:nvSpPr>
         <p:spPr>
           <a:xfrm>
-            <a:off x="777240" y="1828800"/>
-            <a:ext cx="5349240" cy="1874519"/>
+            <a:off x="777240" y="2423160"/>
+            <a:ext cx="10607040" cy="3931920"/>
           </a:xfrm>
           <a:prstGeom prst="roundRect">
             <a:avLst>
-              <a:gd name="adj" fmla="val 6000"/>
+              <a:gd name="adj" fmla="val 3000"/>
             </a:avLst>
           </a:prstGeom>
           <a:solidFill>
-            <a:srgbClr val="141C33"/>
+            <a:srgbClr val="0C1326"/>
           </a:solidFill>
-          <a:ln w="15875">
+          <a:ln w="12700">
             <a:solidFill>
-              <a:srgbClr val="33D980"/>
+              <a:srgbClr val="2979FF"/>
             </a:solidFill>
           </a:ln>
           <a:effectLst/>
@@ -7616,489 +7664,495 @@
           </a:fontRef>
         </p:style>
         <p:txBody>
-          <a:bodyPr rtlCol="0" anchor="ctr"/>
-          <a:lstStyle/>
-          <a:p>
-            <a:pPr algn="ctr"/>
-          </a:p>
-        </p:txBody>
-      </p:sp>
-      <p:sp>
-        <p:nvSpPr>
-          <p:cNvPr id="6" name="TextBox 5"/>
-          <p:cNvSpPr txBox="1"/>
-          <p:nvPr/>
-        </p:nvSpPr>
-        <p:spPr>
-          <a:xfrm>
-            <a:off x="1097280" y="2103120"/>
-            <a:ext cx="4800600" cy="548640"/>
-          </a:xfrm>
-          <a:prstGeom prst="rect">
-            <a:avLst/>
-          </a:prstGeom>
-          <a:noFill/>
-        </p:spPr>
-        <p:txBody>
-          <a:bodyPr wrap="square" anchor="t" lIns="0" rIns="0" tIns="0" bIns="0">
-            <a:spAutoFit/>
-          </a:bodyPr>
-          <a:lstStyle/>
-          <a:p>
-            <a:pPr algn="l">
-              <a:spcBef>
-                <a:spcPts val="0"/>
-              </a:spcBef>
-              <a:spcAft>
-                <a:spcPts val="600"/>
-              </a:spcAft>
-            </a:pPr>
-            <a:r>
-              <a:rPr sz="2100" b="1">
-                <a:solidFill>
-                  <a:srgbClr val="33D980"/>
-                </a:solidFill>
-                <a:latin typeface="Helvetica Neue"/>
-              </a:rPr>
-              <a:t>Finding the drone</a:t>
-            </a:r>
-          </a:p>
-        </p:txBody>
-      </p:sp>
-      <p:sp>
-        <p:nvSpPr>
-          <p:cNvPr id="7" name="TextBox 6"/>
-          <p:cNvSpPr txBox="1"/>
-          <p:nvPr/>
-        </p:nvSpPr>
-        <p:spPr>
-          <a:xfrm>
-            <a:off x="1097280" y="2697480"/>
-            <a:ext cx="4709160" cy="914400"/>
-          </a:xfrm>
-          <a:prstGeom prst="rect">
-            <a:avLst/>
-          </a:prstGeom>
-          <a:noFill/>
-        </p:spPr>
-        <p:txBody>
-          <a:bodyPr wrap="square" anchor="t" lIns="0" rIns="0" tIns="0" bIns="0">
-            <a:spAutoFit/>
-          </a:bodyPr>
-          <a:lstStyle/>
-          <a:p>
-            <a:pPr algn="l">
-              <a:spcBef>
-                <a:spcPts val="0"/>
-              </a:spcBef>
-              <a:spcAft>
-                <a:spcPts val="0"/>
-              </a:spcAft>
-            </a:pPr>
-            <a:r>
-              <a:rPr sz="1450" b="0">
-                <a:solidFill>
-                  <a:srgbClr val="8A97B8"/>
-                </a:solidFill>
-                <a:latin typeface="Helvetica Neue"/>
-              </a:rPr>
-              <a:t>The ESP32 gets a random DHCP IP. A UDP beacon broadcasts the IP every 5 s, so the app auto-connects — no typing.</a:t>
-            </a:r>
-          </a:p>
-        </p:txBody>
-      </p:sp>
-      <p:sp>
-        <p:nvSpPr>
-          <p:cNvPr id="8" name="Rounded Rectangle 7"/>
-          <p:cNvSpPr/>
-          <p:nvPr/>
-        </p:nvSpPr>
-        <p:spPr>
-          <a:xfrm>
-            <a:off x="6400800" y="1828800"/>
-            <a:ext cx="5349240" cy="1874519"/>
-          </a:xfrm>
-          <a:prstGeom prst="roundRect">
-            <a:avLst>
-              <a:gd name="adj" fmla="val 6000"/>
-            </a:avLst>
-          </a:prstGeom>
-          <a:solidFill>
-            <a:srgbClr val="141C33"/>
-          </a:solidFill>
-          <a:ln w="15875">
-            <a:solidFill>
-              <a:srgbClr val="2979FF"/>
-            </a:solidFill>
-          </a:ln>
-          <a:effectLst/>
-        </p:spPr>
-        <p:style>
-          <a:lnRef idx="1">
-            <a:schemeClr val="accent1"/>
-          </a:lnRef>
-          <a:fillRef idx="3">
-            <a:schemeClr val="accent1"/>
-          </a:fillRef>
-          <a:effectRef idx="2">
-            <a:schemeClr val="accent1"/>
-          </a:effectRef>
-          <a:fontRef idx="minor">
-            <a:schemeClr val="lt1"/>
-          </a:fontRef>
-        </p:style>
-        <p:txBody>
-          <a:bodyPr rtlCol="0" anchor="ctr"/>
-          <a:lstStyle/>
-          <a:p>
-            <a:pPr algn="ctr"/>
-          </a:p>
-        </p:txBody>
-      </p:sp>
-      <p:sp>
-        <p:nvSpPr>
-          <p:cNvPr id="9" name="TextBox 8"/>
-          <p:cNvSpPr txBox="1"/>
-          <p:nvPr/>
-        </p:nvSpPr>
-        <p:spPr>
-          <a:xfrm>
-            <a:off x="6720840" y="2103120"/>
-            <a:ext cx="4800600" cy="548640"/>
-          </a:xfrm>
-          <a:prstGeom prst="rect">
-            <a:avLst/>
-          </a:prstGeom>
-          <a:noFill/>
-        </p:spPr>
-        <p:txBody>
-          <a:bodyPr wrap="square" anchor="t" lIns="0" rIns="0" tIns="0" bIns="0">
-            <a:spAutoFit/>
-          </a:bodyPr>
-          <a:lstStyle/>
-          <a:p>
-            <a:pPr algn="l">
-              <a:spcBef>
-                <a:spcPts val="0"/>
-              </a:spcBef>
-              <a:spcAft>
-                <a:spcPts val="600"/>
-              </a:spcAft>
-            </a:pPr>
-            <a:r>
-              <a:rPr sz="2100" b="1">
-                <a:solidFill>
-                  <a:srgbClr val="2979FF"/>
-                </a:solidFill>
-                <a:latin typeface="Helvetica Neue"/>
-              </a:rPr>
-              <a:t>Detecting a dropped link</a:t>
-            </a:r>
-          </a:p>
-        </p:txBody>
-      </p:sp>
-      <p:sp>
-        <p:nvSpPr>
-          <p:cNvPr id="10" name="TextBox 9"/>
-          <p:cNvSpPr txBox="1"/>
-          <p:nvPr/>
-        </p:nvSpPr>
-        <p:spPr>
-          <a:xfrm>
-            <a:off x="6720840" y="2697480"/>
-            <a:ext cx="4709160" cy="914400"/>
-          </a:xfrm>
-          <a:prstGeom prst="rect">
-            <a:avLst/>
-          </a:prstGeom>
-          <a:noFill/>
-        </p:spPr>
-        <p:txBody>
-          <a:bodyPr wrap="square" anchor="t" lIns="0" rIns="0" tIns="0" bIns="0">
-            <a:spAutoFit/>
-          </a:bodyPr>
-          <a:lstStyle/>
-          <a:p>
-            <a:pPr algn="l">
-              <a:spcBef>
-                <a:spcPts val="0"/>
-              </a:spcBef>
-              <a:spcAft>
-                <a:spcPts val="0"/>
-              </a:spcAft>
-            </a:pPr>
-            <a:r>
-              <a:rPr sz="1450" b="0">
-                <a:solidFill>
-                  <a:srgbClr val="8A97B8"/>
-                </a:solidFill>
-                <a:latin typeface="Helvetica Neue"/>
-              </a:rPr>
-              <a:t>WiFi can die silently. A 3 s timeout timer + 5 s WebSocket pings flip isConnected false the instant data stops.</a:t>
-            </a:r>
-          </a:p>
-        </p:txBody>
-      </p:sp>
-      <p:sp>
-        <p:nvSpPr>
-          <p:cNvPr id="11" name="Rounded Rectangle 10"/>
-          <p:cNvSpPr/>
-          <p:nvPr/>
-        </p:nvSpPr>
-        <p:spPr>
-          <a:xfrm>
-            <a:off x="777240" y="3977639"/>
-            <a:ext cx="5349240" cy="1874519"/>
-          </a:xfrm>
-          <a:prstGeom prst="roundRect">
-            <a:avLst>
-              <a:gd name="adj" fmla="val 6000"/>
-            </a:avLst>
-          </a:prstGeom>
-          <a:solidFill>
-            <a:srgbClr val="141C33"/>
-          </a:solidFill>
-          <a:ln w="15875">
-            <a:solidFill>
-              <a:srgbClr val="FF9900"/>
-            </a:solidFill>
-          </a:ln>
-          <a:effectLst/>
-        </p:spPr>
-        <p:style>
-          <a:lnRef idx="1">
-            <a:schemeClr val="accent1"/>
-          </a:lnRef>
-          <a:fillRef idx="3">
-            <a:schemeClr val="accent1"/>
-          </a:fillRef>
-          <a:effectRef idx="2">
-            <a:schemeClr val="accent1"/>
-          </a:effectRef>
-          <a:fontRef idx="minor">
-            <a:schemeClr val="lt1"/>
-          </a:fontRef>
-        </p:style>
-        <p:txBody>
-          <a:bodyPr rtlCol="0" anchor="ctr"/>
-          <a:lstStyle/>
-          <a:p>
-            <a:pPr algn="ctr"/>
-          </a:p>
-        </p:txBody>
-      </p:sp>
-      <p:sp>
-        <p:nvSpPr>
-          <p:cNvPr id="12" name="TextBox 11"/>
-          <p:cNvSpPr txBox="1"/>
-          <p:nvPr/>
-        </p:nvSpPr>
-        <p:spPr>
-          <a:xfrm>
-            <a:off x="1097280" y="4251959"/>
-            <a:ext cx="4800600" cy="548640"/>
-          </a:xfrm>
-          <a:prstGeom prst="rect">
-            <a:avLst/>
-          </a:prstGeom>
-          <a:noFill/>
-        </p:spPr>
-        <p:txBody>
-          <a:bodyPr wrap="square" anchor="t" lIns="0" rIns="0" tIns="0" bIns="0">
-            <a:spAutoFit/>
-          </a:bodyPr>
-          <a:lstStyle/>
-          <a:p>
-            <a:pPr algn="l">
-              <a:spcBef>
-                <a:spcPts val="0"/>
-              </a:spcBef>
-              <a:spcAft>
-                <a:spcPts val="600"/>
-              </a:spcAft>
-            </a:pPr>
-            <a:r>
-              <a:rPr sz="2100" b="1">
-                <a:solidFill>
-                  <a:srgbClr val="FF9900"/>
-                </a:solidFill>
-                <a:latin typeface="Helvetica Neue"/>
-              </a:rPr>
-              <a:t>Thread safety</a:t>
-            </a:r>
-          </a:p>
-        </p:txBody>
-      </p:sp>
-      <p:sp>
-        <p:nvSpPr>
-          <p:cNvPr id="13" name="TextBox 12"/>
-          <p:cNvSpPr txBox="1"/>
-          <p:nvPr/>
-        </p:nvSpPr>
-        <p:spPr>
-          <a:xfrm>
-            <a:off x="1097280" y="4846319"/>
-            <a:ext cx="4709160" cy="914400"/>
-          </a:xfrm>
-          <a:prstGeom prst="rect">
-            <a:avLst/>
-          </a:prstGeom>
-          <a:noFill/>
-        </p:spPr>
-        <p:txBody>
-          <a:bodyPr wrap="square" anchor="t" lIns="0" rIns="0" tIns="0" bIns="0">
-            <a:spAutoFit/>
-          </a:bodyPr>
-          <a:lstStyle/>
-          <a:p>
-            <a:pPr algn="l">
-              <a:spcBef>
-                <a:spcPts val="0"/>
-              </a:spcBef>
-              <a:spcAft>
-                <a:spcPts val="0"/>
-              </a:spcAft>
-            </a:pPr>
-            <a:r>
-              <a:rPr sz="1450" b="0">
-                <a:solidFill>
-                  <a:srgbClr val="8A97B8"/>
-                </a:solidFill>
-                <a:latin typeface="Helvetica Neue"/>
-              </a:rPr>
-              <a:t>SceneKit physics runs on the render thread, SwiftUI only on main. Physics writes _vars, synced to @Published at 20 Hz.</a:t>
-            </a:r>
-          </a:p>
-        </p:txBody>
-      </p:sp>
-      <p:sp>
-        <p:nvSpPr>
-          <p:cNvPr id="14" name="Rounded Rectangle 13"/>
-          <p:cNvSpPr/>
-          <p:nvPr/>
-        </p:nvSpPr>
-        <p:spPr>
-          <a:xfrm>
-            <a:off x="6400800" y="3977639"/>
-            <a:ext cx="5349240" cy="1874519"/>
-          </a:xfrm>
-          <a:prstGeom prst="roundRect">
-            <a:avLst>
-              <a:gd name="adj" fmla="val 6000"/>
-            </a:avLst>
-          </a:prstGeom>
-          <a:solidFill>
-            <a:srgbClr val="141C33"/>
-          </a:solidFill>
-          <a:ln w="15875">
-            <a:solidFill>
-              <a:srgbClr val="FF4545"/>
-            </a:solidFill>
-          </a:ln>
-          <a:effectLst/>
-        </p:spPr>
-        <p:style>
-          <a:lnRef idx="1">
-            <a:schemeClr val="accent1"/>
-          </a:lnRef>
-          <a:fillRef idx="3">
-            <a:schemeClr val="accent1"/>
-          </a:fillRef>
-          <a:effectRef idx="2">
-            <a:schemeClr val="accent1"/>
-          </a:effectRef>
-          <a:fontRef idx="minor">
-            <a:schemeClr val="lt1"/>
-          </a:fontRef>
-        </p:style>
-        <p:txBody>
-          <a:bodyPr rtlCol="0" anchor="ctr"/>
-          <a:lstStyle/>
-          <a:p>
-            <a:pPr algn="ctr"/>
-          </a:p>
-        </p:txBody>
-      </p:sp>
-      <p:sp>
-        <p:nvSpPr>
-          <p:cNvPr id="15" name="TextBox 14"/>
-          <p:cNvSpPr txBox="1"/>
-          <p:nvPr/>
-        </p:nvSpPr>
-        <p:spPr>
-          <a:xfrm>
-            <a:off x="6720840" y="4251959"/>
-            <a:ext cx="4800600" cy="548640"/>
-          </a:xfrm>
-          <a:prstGeom prst="rect">
-            <a:avLst/>
-          </a:prstGeom>
-          <a:noFill/>
-        </p:spPr>
-        <p:txBody>
-          <a:bodyPr wrap="square" anchor="t" lIns="0" rIns="0" tIns="0" bIns="0">
-            <a:spAutoFit/>
-          </a:bodyPr>
-          <a:lstStyle/>
-          <a:p>
-            <a:pPr algn="l">
-              <a:spcBef>
-                <a:spcPts val="0"/>
-              </a:spcBef>
-              <a:spcAft>
-                <a:spcPts val="600"/>
-              </a:spcAft>
-            </a:pPr>
-            <a:r>
-              <a:rPr sz="2100" b="1">
-                <a:solidFill>
-                  <a:srgbClr val="FF4545"/>
-                </a:solidFill>
-                <a:latin typeface="Helvetica Neue"/>
-              </a:rPr>
-              <a:t>Flight safety</a:t>
-            </a:r>
-          </a:p>
-        </p:txBody>
-      </p:sp>
-      <p:sp>
-        <p:nvSpPr>
-          <p:cNvPr id="16" name="TextBox 15"/>
-          <p:cNvSpPr txBox="1"/>
-          <p:nvPr/>
-        </p:nvSpPr>
-        <p:spPr>
-          <a:xfrm>
-            <a:off x="6720840" y="4846319"/>
-            <a:ext cx="4709160" cy="914400"/>
-          </a:xfrm>
-          <a:prstGeom prst="rect">
-            <a:avLst/>
-          </a:prstGeom>
-          <a:noFill/>
-        </p:spPr>
-        <p:txBody>
-          <a:bodyPr wrap="square" anchor="t" lIns="0" rIns="0" tIns="0" bIns="0">
-            <a:spAutoFit/>
-          </a:bodyPr>
-          <a:lstStyle/>
-          <a:p>
-            <a:pPr algn="l">
-              <a:spcBef>
-                <a:spcPts val="0"/>
-              </a:spcBef>
-              <a:spcAft>
-                <a:spcPts val="0"/>
-              </a:spcAft>
-            </a:pPr>
-            <a:r>
-              <a:rPr sz="1450" b="0">
-                <a:solidFill>
-                  <a:srgbClr val="8A97B8"/>
-                </a:solidFill>
-                <a:latin typeface="Helvetica Neue"/>
-              </a:rPr>
-              <a:t>Accidental motor spin is dangerous. 1.5 s hold-to-arm, debounced safe-test, and a tilt-over-60° emergency stop.</a:t>
+          <a:bodyPr rtlCol="0" anchor="ctr" wrap="square" lIns="320040" tIns="228600" rIns="182880"/>
+          <a:lstStyle/>
+          <a:p>
+            <a:pPr algn="ctr">
+              <a:lnSpc>
+                <a:spcPct val="100000"/>
+              </a:lnSpc>
+              <a:spcAft>
+                <a:spcPts val="200"/>
+              </a:spcAft>
+            </a:pPr>
+            <a:r>
+              <a:rPr sz="1450">
+                <a:solidFill>
+                  <a:srgbClr val="FF7AB2"/>
+                </a:solidFill>
+                <a:latin typeface="Consolas"/>
+              </a:rPr>
+              <a:t>class </a:t>
+            </a:r>
+            <a:r>
+              <a:rPr sz="1450">
+                <a:solidFill>
+                  <a:srgbClr val="7EE0C8"/>
+                </a:solidFill>
+                <a:latin typeface="Consolas"/>
+              </a:rPr>
+              <a:t>DroneSimulator</a:t>
+            </a:r>
+            <a:r>
+              <a:rPr sz="1450">
+                <a:solidFill>
+                  <a:srgbClr val="E9EEFB"/>
+                </a:solidFill>
+                <a:latin typeface="Consolas"/>
+              </a:rPr>
+              <a:t>: </a:t>
+            </a:r>
+            <a:r>
+              <a:rPr sz="1450">
+                <a:solidFill>
+                  <a:srgbClr val="7EE0C8"/>
+                </a:solidFill>
+                <a:latin typeface="Consolas"/>
+              </a:rPr>
+              <a:t>ObservableObject</a:t>
+            </a:r>
+            <a:r>
+              <a:rPr sz="1450">
+                <a:solidFill>
+                  <a:srgbClr val="E9EEFB"/>
+                </a:solidFill>
+                <a:latin typeface="Consolas"/>
+              </a:rPr>
+              <a:t> {</a:t>
+            </a:r>
+          </a:p>
+          <a:p>
+            <a:pPr>
+              <a:lnSpc>
+                <a:spcPct val="100000"/>
+              </a:lnSpc>
+              <a:spcAft>
+                <a:spcPts val="200"/>
+              </a:spcAft>
+            </a:pPr>
+            <a:r>
+              <a:rPr sz="1450">
+                <a:solidFill>
+                  <a:srgbClr val="5D6B8F"/>
+                </a:solidFill>
+                <a:latin typeface="Consolas"/>
+              </a:rPr>
+              <a:t>    // Main thread only — drives SwiftUI</a:t>
+            </a:r>
+          </a:p>
+          <a:p>
+            <a:pPr>
+              <a:lnSpc>
+                <a:spcPct val="100000"/>
+              </a:lnSpc>
+              <a:spcAft>
+                <a:spcPts val="200"/>
+              </a:spcAft>
+            </a:pPr>
+            <a:r>
+              <a:rPr sz="1450">
+                <a:solidFill>
+                  <a:srgbClr val="E9EEFB"/>
+                </a:solidFill>
+                <a:latin typeface="Consolas"/>
+              </a:rPr>
+              <a:t>    @</a:t>
+            </a:r>
+            <a:r>
+              <a:rPr sz="1450">
+                <a:solidFill>
+                  <a:srgbClr val="7EE0C8"/>
+                </a:solidFill>
+                <a:latin typeface="Consolas"/>
+              </a:rPr>
+              <a:t>Published</a:t>
+            </a:r>
+            <a:r>
+              <a:rPr sz="1450">
+                <a:solidFill>
+                  <a:srgbClr val="FF7AB2"/>
+                </a:solidFill>
+                <a:latin typeface="Consolas"/>
+              </a:rPr>
+              <a:t> var</a:t>
+            </a:r>
+            <a:r>
+              <a:rPr sz="1450">
+                <a:solidFill>
+                  <a:srgbClr val="E9EEFB"/>
+                </a:solidFill>
+                <a:latin typeface="Consolas"/>
+              </a:rPr>
+              <a:t> simRoll = </a:t>
+            </a:r>
+            <a:r>
+              <a:rPr sz="1450">
+                <a:solidFill>
+                  <a:srgbClr val="F7C873"/>
+                </a:solidFill>
+                <a:latin typeface="Consolas"/>
+              </a:rPr>
+              <a:t>0.0</a:t>
+            </a:r>
+          </a:p>
+          <a:p>
+            <a:pPr>
+              <a:lnSpc>
+                <a:spcPct val="100000"/>
+              </a:lnSpc>
+              <a:spcAft>
+                <a:spcPts val="200"/>
+              </a:spcAft>
+            </a:pPr>
+            <a:r>
+              <a:rPr sz="1450">
+                <a:solidFill>
+                  <a:srgbClr val="E9EEFB"/>
+                </a:solidFill>
+                <a:latin typeface="Consolas"/>
+              </a:rPr>
+              <a:t>    @</a:t>
+            </a:r>
+            <a:r>
+              <a:rPr sz="1450">
+                <a:solidFill>
+                  <a:srgbClr val="7EE0C8"/>
+                </a:solidFill>
+                <a:latin typeface="Consolas"/>
+              </a:rPr>
+              <a:t>Published</a:t>
+            </a:r>
+            <a:r>
+              <a:rPr sz="1450">
+                <a:solidFill>
+                  <a:srgbClr val="FF7AB2"/>
+                </a:solidFill>
+                <a:latin typeface="Consolas"/>
+              </a:rPr>
+              <a:t> var</a:t>
+            </a:r>
+            <a:r>
+              <a:rPr sz="1450">
+                <a:solidFill>
+                  <a:srgbClr val="E9EEFB"/>
+                </a:solidFill>
+                <a:latin typeface="Consolas"/>
+              </a:rPr>
+              <a:t> isCrashed = </a:t>
+            </a:r>
+            <a:r>
+              <a:rPr sz="1450">
+                <a:solidFill>
+                  <a:srgbClr val="FF7AB2"/>
+                </a:solidFill>
+                <a:latin typeface="Consolas"/>
+              </a:rPr>
+              <a:t>false</a:t>
+            </a:r>
+          </a:p>
+          <a:p>
+            <a:pPr>
+              <a:lnSpc>
+                <a:spcPct val="100000"/>
+              </a:lnSpc>
+              <a:spcAft>
+                <a:spcPts val="200"/>
+              </a:spcAft>
+            </a:pPr>
+            <a:r>
+              <a:rPr sz="1450">
+                <a:solidFill>
+                  <a:srgbClr val="E9EEFB"/>
+                </a:solidFill>
+                <a:latin typeface="Consolas"/>
+              </a:rPr>
+              <a:t/>
+            </a:r>
+          </a:p>
+          <a:p>
+            <a:pPr>
+              <a:lnSpc>
+                <a:spcPct val="100000"/>
+              </a:lnSpc>
+              <a:spcAft>
+                <a:spcPts val="200"/>
+              </a:spcAft>
+            </a:pPr>
+            <a:r>
+              <a:rPr sz="1450">
+                <a:solidFill>
+                  <a:srgbClr val="5D6B8F"/>
+                </a:solidFill>
+                <a:latin typeface="Consolas"/>
+              </a:rPr>
+              <a:t>    // Render thread only — raw physics integration</a:t>
+            </a:r>
+          </a:p>
+          <a:p>
+            <a:pPr>
+              <a:lnSpc>
+                <a:spcPct val="100000"/>
+              </a:lnSpc>
+              <a:spcAft>
+                <a:spcPts val="200"/>
+              </a:spcAft>
+            </a:pPr>
+            <a:r>
+              <a:rPr sz="1450">
+                <a:solidFill>
+                  <a:srgbClr val="FF7AB2"/>
+                </a:solidFill>
+                <a:latin typeface="Consolas"/>
+              </a:rPr>
+              <a:t>    var</a:t>
+            </a:r>
+            <a:r>
+              <a:rPr sz="1450">
+                <a:solidFill>
+                  <a:srgbClr val="E9EEFB"/>
+                </a:solidFill>
+                <a:latin typeface="Consolas"/>
+              </a:rPr>
+              <a:t> _roll = </a:t>
+            </a:r>
+            <a:r>
+              <a:rPr sz="1450">
+                <a:solidFill>
+                  <a:srgbClr val="F7C873"/>
+                </a:solidFill>
+                <a:latin typeface="Consolas"/>
+              </a:rPr>
+              <a:t>0.0</a:t>
+            </a:r>
+          </a:p>
+          <a:p>
+            <a:pPr>
+              <a:lnSpc>
+                <a:spcPct val="100000"/>
+              </a:lnSpc>
+              <a:spcAft>
+                <a:spcPts val="200"/>
+              </a:spcAft>
+            </a:pPr>
+            <a:r>
+              <a:rPr sz="1450">
+                <a:solidFill>
+                  <a:srgbClr val="FF7AB2"/>
+                </a:solidFill>
+                <a:latin typeface="Consolas"/>
+              </a:rPr>
+              <a:t>    var</a:t>
+            </a:r>
+            <a:r>
+              <a:rPr sz="1450">
+                <a:solidFill>
+                  <a:srgbClr val="E9EEFB"/>
+                </a:solidFill>
+                <a:latin typeface="Consolas"/>
+              </a:rPr>
+              <a:t> _vel: </a:t>
+            </a:r>
+            <a:r>
+              <a:rPr sz="1450">
+                <a:solidFill>
+                  <a:srgbClr val="7EE0C8"/>
+                </a:solidFill>
+                <a:latin typeface="Consolas"/>
+              </a:rPr>
+              <a:t>SIMD3</a:t>
+            </a:r>
+            <a:r>
+              <a:rPr sz="1450">
+                <a:solidFill>
+                  <a:srgbClr val="E9EEFB"/>
+                </a:solidFill>
+                <a:latin typeface="Consolas"/>
+              </a:rPr>
+              <a:t>&lt;</a:t>
+            </a:r>
+            <a:r>
+              <a:rPr sz="1450">
+                <a:solidFill>
+                  <a:srgbClr val="7EE0C8"/>
+                </a:solidFill>
+                <a:latin typeface="Consolas"/>
+              </a:rPr>
+              <a:t>Float</a:t>
+            </a:r>
+            <a:r>
+              <a:rPr sz="1450">
+                <a:solidFill>
+                  <a:srgbClr val="E9EEFB"/>
+                </a:solidFill>
+                <a:latin typeface="Consolas"/>
+              </a:rPr>
+              <a:t>&gt; = .zero</a:t>
+            </a:r>
+          </a:p>
+          <a:p>
+            <a:pPr>
+              <a:lnSpc>
+                <a:spcPct val="100000"/>
+              </a:lnSpc>
+              <a:spcAft>
+                <a:spcPts val="200"/>
+              </a:spcAft>
+            </a:pPr>
+            <a:r>
+              <a:rPr sz="1450">
+                <a:solidFill>
+                  <a:srgbClr val="E9EEFB"/>
+                </a:solidFill>
+                <a:latin typeface="Consolas"/>
+              </a:rPr>
+              <a:t/>
+            </a:r>
+          </a:p>
+          <a:p>
+            <a:pPr>
+              <a:lnSpc>
+                <a:spcPct val="100000"/>
+              </a:lnSpc>
+              <a:spcAft>
+                <a:spcPts val="200"/>
+              </a:spcAft>
+            </a:pPr>
+            <a:r>
+              <a:rPr sz="1450">
+                <a:solidFill>
+                  <a:srgbClr val="FF7AB2"/>
+                </a:solidFill>
+                <a:latin typeface="Consolas"/>
+              </a:rPr>
+              <a:t>    func </a:t>
+            </a:r>
+            <a:r>
+              <a:rPr sz="1450">
+                <a:solidFill>
+                  <a:srgbClr val="82AAFF"/>
+                </a:solidFill>
+                <a:latin typeface="Consolas"/>
+              </a:rPr>
+              <a:t>tick</a:t>
+            </a:r>
+            <a:r>
+              <a:rPr sz="1450">
+                <a:solidFill>
+                  <a:srgbClr val="E9EEFB"/>
+                </a:solidFill>
+                <a:latin typeface="Consolas"/>
+              </a:rPr>
+              <a:t>(dt: </a:t>
+            </a:r>
+            <a:r>
+              <a:rPr sz="1450">
+                <a:solidFill>
+                  <a:srgbClr val="7EE0C8"/>
+                </a:solidFill>
+                <a:latin typeface="Consolas"/>
+              </a:rPr>
+              <a:t>Double</a:t>
+            </a:r>
+            <a:r>
+              <a:rPr sz="1450">
+                <a:solidFill>
+                  <a:srgbClr val="E9EEFB"/>
+                </a:solidFill>
+                <a:latin typeface="Consolas"/>
+              </a:rPr>
+              <a:t>) { </a:t>
+            </a:r>
+            <a:r>
+              <a:rPr sz="1450">
+                <a:solidFill>
+                  <a:srgbClr val="5D6B8F"/>
+                </a:solidFill>
+                <a:latin typeface="Consolas"/>
+              </a:rPr>
+              <a:t>/* render thread: physics */</a:t>
+            </a:r>
+            <a:r>
+              <a:rPr sz="1450">
+                <a:solidFill>
+                  <a:srgbClr val="E9EEFB"/>
+                </a:solidFill>
+                <a:latin typeface="Consolas"/>
+              </a:rPr>
+              <a:t> }</a:t>
+            </a:r>
+          </a:p>
+          <a:p>
+            <a:pPr>
+              <a:lnSpc>
+                <a:spcPct val="100000"/>
+              </a:lnSpc>
+              <a:spcAft>
+                <a:spcPts val="200"/>
+              </a:spcAft>
+            </a:pPr>
+            <a:r>
+              <a:rPr sz="1450">
+                <a:solidFill>
+                  <a:srgbClr val="FF7AB2"/>
+                </a:solidFill>
+                <a:latin typeface="Consolas"/>
+              </a:rPr>
+              <a:t>    func </a:t>
+            </a:r>
+            <a:r>
+              <a:rPr sz="1450">
+                <a:solidFill>
+                  <a:srgbClr val="82AAFF"/>
+                </a:solidFill>
+                <a:latin typeface="Consolas"/>
+              </a:rPr>
+              <a:t>syncPublished</a:t>
+            </a:r>
+            <a:r>
+              <a:rPr sz="1450">
+                <a:solidFill>
+                  <a:srgbClr val="E9EEFB"/>
+                </a:solidFill>
+                <a:latin typeface="Consolas"/>
+              </a:rPr>
+              <a:t>() { </a:t>
+            </a:r>
+            <a:r>
+              <a:rPr sz="1450">
+                <a:solidFill>
+                  <a:srgbClr val="5D6B8F"/>
+                </a:solidFill>
+                <a:latin typeface="Consolas"/>
+              </a:rPr>
+              <a:t>/* main: _vars → @Published */</a:t>
+            </a:r>
+            <a:r>
+              <a:rPr sz="1450">
+                <a:solidFill>
+                  <a:srgbClr val="E9EEFB"/>
+                </a:solidFill>
+                <a:latin typeface="Consolas"/>
+              </a:rPr>
+              <a:t> }</a:t>
+            </a:r>
+          </a:p>
+          <a:p>
+            <a:pPr>
+              <a:lnSpc>
+                <a:spcPct val="100000"/>
+              </a:lnSpc>
+              <a:spcAft>
+                <a:spcPts val="200"/>
+              </a:spcAft>
+            </a:pPr>
+            <a:r>
+              <a:rPr sz="1450">
+                <a:solidFill>
+                  <a:srgbClr val="E9EEFB"/>
+                </a:solidFill>
+                <a:latin typeface="Consolas"/>
+              </a:rPr>
+              <a:t>}</a:t>
             </a:r>
           </a:p>
         </p:txBody>
@@ -8112,728 +8166,6 @@
 </file>
 
 <file path=ppt/slides/slide8.xml><?xml version="1.0" encoding="utf-8"?>
-<p:sld xmlns:a="http://schemas.openxmlformats.org/drawingml/2006/main" xmlns:p="http://schemas.openxmlformats.org/presentationml/2006/main" xmlns:r="http://schemas.openxmlformats.org/officeDocument/2006/relationships">
-  <p:cSld>
-    <p:spTree>
-      <p:nvGrpSpPr>
-        <p:cNvPr id="1" name=""/>
-        <p:cNvGrpSpPr/>
-        <p:nvPr/>
-      </p:nvGrpSpPr>
-      <p:grpSpPr/>
-      <p:sp>
-        <p:nvSpPr>
-          <p:cNvPr id="2" name="Rectangle 1"/>
-          <p:cNvSpPr/>
-          <p:nvPr/>
-        </p:nvSpPr>
-        <p:spPr>
-          <a:xfrm>
-            <a:off x="0" y="0"/>
-            <a:ext cx="12191695" cy="6858000"/>
-          </a:xfrm>
-          <a:prstGeom prst="rect">
-            <a:avLst/>
-          </a:prstGeom>
-          <a:solidFill>
-            <a:srgbClr val="0A0F1E"/>
-          </a:solidFill>
-          <a:ln>
-            <a:noFill/>
-          </a:ln>
-          <a:effectLst/>
-        </p:spPr>
-        <p:style>
-          <a:lnRef idx="1">
-            <a:schemeClr val="accent1"/>
-          </a:lnRef>
-          <a:fillRef idx="3">
-            <a:schemeClr val="accent1"/>
-          </a:fillRef>
-          <a:effectRef idx="2">
-            <a:schemeClr val="accent1"/>
-          </a:effectRef>
-          <a:fontRef idx="minor">
-            <a:schemeClr val="lt1"/>
-          </a:fontRef>
-        </p:style>
-        <p:txBody>
-          <a:bodyPr rtlCol="0" anchor="ctr"/>
-          <a:lstStyle/>
-          <a:p>
-            <a:pPr algn="ctr"/>
-          </a:p>
-        </p:txBody>
-      </p:sp>
-      <p:sp>
-        <p:nvSpPr>
-          <p:cNvPr id="3" name="TextBox 2"/>
-          <p:cNvSpPr txBox="1"/>
-          <p:nvPr/>
-        </p:nvSpPr>
-        <p:spPr>
-          <a:xfrm>
-            <a:off x="777240" y="502920"/>
-            <a:ext cx="10058400" cy="457200"/>
-          </a:xfrm>
-          <a:prstGeom prst="rect">
-            <a:avLst/>
-          </a:prstGeom>
-          <a:noFill/>
-        </p:spPr>
-        <p:txBody>
-          <a:bodyPr wrap="square" anchor="t" lIns="0" rIns="0" tIns="0" bIns="0">
-            <a:spAutoFit/>
-          </a:bodyPr>
-          <a:lstStyle/>
-          <a:p>
-            <a:pPr algn="l">
-              <a:spcBef>
-                <a:spcPts val="0"/>
-              </a:spcBef>
-              <a:spcAft>
-                <a:spcPts val="600"/>
-              </a:spcAft>
-            </a:pPr>
-            <a:r>
-              <a:rPr sz="1500" b="1">
-                <a:solidFill>
-                  <a:srgbClr val="2979FF"/>
-                </a:solidFill>
-                <a:latin typeface="Helvetica Neue"/>
-              </a:rPr>
-              <a:t>CODE · THE THREADING CHALLENGE</a:t>
-            </a:r>
-          </a:p>
-        </p:txBody>
-      </p:sp>
-      <p:sp>
-        <p:nvSpPr>
-          <p:cNvPr id="4" name="TextBox 3"/>
-          <p:cNvSpPr txBox="1"/>
-          <p:nvPr/>
-        </p:nvSpPr>
-        <p:spPr>
-          <a:xfrm>
-            <a:off x="777240" y="868680"/>
-            <a:ext cx="10607040" cy="1005840"/>
-          </a:xfrm>
-          <a:prstGeom prst="rect">
-            <a:avLst/>
-          </a:prstGeom>
-          <a:noFill/>
-        </p:spPr>
-        <p:txBody>
-          <a:bodyPr wrap="square" anchor="t" lIns="0" rIns="0" tIns="0" bIns="0">
-            <a:spAutoFit/>
-          </a:bodyPr>
-          <a:lstStyle/>
-          <a:p>
-            <a:pPr algn="l">
-              <a:spcBef>
-                <a:spcPts val="0"/>
-              </a:spcBef>
-              <a:spcAft>
-                <a:spcPts val="600"/>
-              </a:spcAft>
-            </a:pPr>
-            <a:r>
-              <a:rPr sz="4000" b="1">
-                <a:solidFill>
-                  <a:srgbClr val="E9EEFB"/>
-                </a:solidFill>
-                <a:latin typeface="Helvetica Neue"/>
-              </a:rPr>
-              <a:t>Two threads, one drone</a:t>
-            </a:r>
-          </a:p>
-        </p:txBody>
-      </p:sp>
-      <p:sp>
-        <p:nvSpPr>
-          <p:cNvPr id="5" name="TextBox 4"/>
-          <p:cNvSpPr txBox="1"/>
-          <p:nvPr/>
-        </p:nvSpPr>
-        <p:spPr>
-          <a:xfrm>
-            <a:off x="777240" y="1691640"/>
-            <a:ext cx="10607040" cy="640080"/>
-          </a:xfrm>
-          <a:prstGeom prst="rect">
-            <a:avLst/>
-          </a:prstGeom>
-          <a:noFill/>
-        </p:spPr>
-        <p:txBody>
-          <a:bodyPr wrap="square" anchor="t" lIns="0" rIns="0" tIns="0" bIns="0">
-            <a:spAutoFit/>
-          </a:bodyPr>
-          <a:lstStyle/>
-          <a:p>
-            <a:pPr algn="l">
-              <a:spcBef>
-                <a:spcPts val="0"/>
-              </a:spcBef>
-              <a:spcAft>
-                <a:spcPts val="600"/>
-              </a:spcAft>
-            </a:pPr>
-            <a:r>
-              <a:rPr sz="1600" b="0">
-                <a:solidFill>
-                  <a:srgbClr val="8A97B8"/>
-                </a:solidFill>
-                <a:latin typeface="Helvetica Neue"/>
-              </a:rPr>
-              <a:t>Physics on SceneKit's render thread must never touch SwiftUI directly — so internal state is kept separate from published state.</a:t>
-            </a:r>
-          </a:p>
-        </p:txBody>
-      </p:sp>
-      <p:sp>
-        <p:nvSpPr>
-          <p:cNvPr id="6" name="Rounded Rectangle 5"/>
-          <p:cNvSpPr/>
-          <p:nvPr/>
-        </p:nvSpPr>
-        <p:spPr>
-          <a:xfrm>
-            <a:off x="777240" y="2423160"/>
-            <a:ext cx="10607040" cy="3931920"/>
-          </a:xfrm>
-          <a:prstGeom prst="roundRect">
-            <a:avLst>
-              <a:gd name="adj" fmla="val 3000"/>
-            </a:avLst>
-          </a:prstGeom>
-          <a:solidFill>
-            <a:srgbClr val="0C1326"/>
-          </a:solidFill>
-          <a:ln w="12700">
-            <a:solidFill>
-              <a:srgbClr val="2979FF"/>
-            </a:solidFill>
-          </a:ln>
-          <a:effectLst/>
-        </p:spPr>
-        <p:style>
-          <a:lnRef idx="1">
-            <a:schemeClr val="accent1"/>
-          </a:lnRef>
-          <a:fillRef idx="3">
-            <a:schemeClr val="accent1"/>
-          </a:fillRef>
-          <a:effectRef idx="2">
-            <a:schemeClr val="accent1"/>
-          </a:effectRef>
-          <a:fontRef idx="minor">
-            <a:schemeClr val="lt1"/>
-          </a:fontRef>
-        </p:style>
-        <p:txBody>
-          <a:bodyPr rtlCol="0" anchor="ctr" wrap="square" lIns="320040" tIns="228600" rIns="182880"/>
-          <a:lstStyle/>
-          <a:p>
-            <a:pPr algn="ctr">
-              <a:lnSpc>
-                <a:spcPct val="100000"/>
-              </a:lnSpc>
-              <a:spcAft>
-                <a:spcPts val="200"/>
-              </a:spcAft>
-            </a:pPr>
-            <a:r>
-              <a:rPr sz="1450">
-                <a:solidFill>
-                  <a:srgbClr val="FF7AB2"/>
-                </a:solidFill>
-                <a:latin typeface="Consolas"/>
-              </a:rPr>
-              <a:t>class </a:t>
-            </a:r>
-            <a:r>
-              <a:rPr sz="1450">
-                <a:solidFill>
-                  <a:srgbClr val="7EE0C8"/>
-                </a:solidFill>
-                <a:latin typeface="Consolas"/>
-              </a:rPr>
-              <a:t>DroneSimulator</a:t>
-            </a:r>
-            <a:r>
-              <a:rPr sz="1450">
-                <a:solidFill>
-                  <a:srgbClr val="E9EEFB"/>
-                </a:solidFill>
-                <a:latin typeface="Consolas"/>
-              </a:rPr>
-              <a:t>: </a:t>
-            </a:r>
-            <a:r>
-              <a:rPr sz="1450">
-                <a:solidFill>
-                  <a:srgbClr val="7EE0C8"/>
-                </a:solidFill>
-                <a:latin typeface="Consolas"/>
-              </a:rPr>
-              <a:t>ObservableObject</a:t>
-            </a:r>
-            <a:r>
-              <a:rPr sz="1450">
-                <a:solidFill>
-                  <a:srgbClr val="E9EEFB"/>
-                </a:solidFill>
-                <a:latin typeface="Consolas"/>
-              </a:rPr>
-              <a:t> {</a:t>
-            </a:r>
-          </a:p>
-          <a:p>
-            <a:pPr>
-              <a:lnSpc>
-                <a:spcPct val="100000"/>
-              </a:lnSpc>
-              <a:spcAft>
-                <a:spcPts val="200"/>
-              </a:spcAft>
-            </a:pPr>
-            <a:r>
-              <a:rPr sz="1450">
-                <a:solidFill>
-                  <a:srgbClr val="5D6B8F"/>
-                </a:solidFill>
-                <a:latin typeface="Consolas"/>
-              </a:rPr>
-              <a:t>    // Main thread only — drives SwiftUI</a:t>
-            </a:r>
-          </a:p>
-          <a:p>
-            <a:pPr>
-              <a:lnSpc>
-                <a:spcPct val="100000"/>
-              </a:lnSpc>
-              <a:spcAft>
-                <a:spcPts val="200"/>
-              </a:spcAft>
-            </a:pPr>
-            <a:r>
-              <a:rPr sz="1450">
-                <a:solidFill>
-                  <a:srgbClr val="E9EEFB"/>
-                </a:solidFill>
-                <a:latin typeface="Consolas"/>
-              </a:rPr>
-              <a:t>    @</a:t>
-            </a:r>
-            <a:r>
-              <a:rPr sz="1450">
-                <a:solidFill>
-                  <a:srgbClr val="7EE0C8"/>
-                </a:solidFill>
-                <a:latin typeface="Consolas"/>
-              </a:rPr>
-              <a:t>Published</a:t>
-            </a:r>
-            <a:r>
-              <a:rPr sz="1450">
-                <a:solidFill>
-                  <a:srgbClr val="FF7AB2"/>
-                </a:solidFill>
-                <a:latin typeface="Consolas"/>
-              </a:rPr>
-              <a:t> var</a:t>
-            </a:r>
-            <a:r>
-              <a:rPr sz="1450">
-                <a:solidFill>
-                  <a:srgbClr val="E9EEFB"/>
-                </a:solidFill>
-                <a:latin typeface="Consolas"/>
-              </a:rPr>
-              <a:t> simRoll = </a:t>
-            </a:r>
-            <a:r>
-              <a:rPr sz="1450">
-                <a:solidFill>
-                  <a:srgbClr val="F7C873"/>
-                </a:solidFill>
-                <a:latin typeface="Consolas"/>
-              </a:rPr>
-              <a:t>0.0</a:t>
-            </a:r>
-          </a:p>
-          <a:p>
-            <a:pPr>
-              <a:lnSpc>
-                <a:spcPct val="100000"/>
-              </a:lnSpc>
-              <a:spcAft>
-                <a:spcPts val="200"/>
-              </a:spcAft>
-            </a:pPr>
-            <a:r>
-              <a:rPr sz="1450">
-                <a:solidFill>
-                  <a:srgbClr val="E9EEFB"/>
-                </a:solidFill>
-                <a:latin typeface="Consolas"/>
-              </a:rPr>
-              <a:t>    @</a:t>
-            </a:r>
-            <a:r>
-              <a:rPr sz="1450">
-                <a:solidFill>
-                  <a:srgbClr val="7EE0C8"/>
-                </a:solidFill>
-                <a:latin typeface="Consolas"/>
-              </a:rPr>
-              <a:t>Published</a:t>
-            </a:r>
-            <a:r>
-              <a:rPr sz="1450">
-                <a:solidFill>
-                  <a:srgbClr val="FF7AB2"/>
-                </a:solidFill>
-                <a:latin typeface="Consolas"/>
-              </a:rPr>
-              <a:t> var</a:t>
-            </a:r>
-            <a:r>
-              <a:rPr sz="1450">
-                <a:solidFill>
-                  <a:srgbClr val="E9EEFB"/>
-                </a:solidFill>
-                <a:latin typeface="Consolas"/>
-              </a:rPr>
-              <a:t> isCrashed = </a:t>
-            </a:r>
-            <a:r>
-              <a:rPr sz="1450">
-                <a:solidFill>
-                  <a:srgbClr val="FF7AB2"/>
-                </a:solidFill>
-                <a:latin typeface="Consolas"/>
-              </a:rPr>
-              <a:t>false</a:t>
-            </a:r>
-          </a:p>
-          <a:p>
-            <a:pPr>
-              <a:lnSpc>
-                <a:spcPct val="100000"/>
-              </a:lnSpc>
-              <a:spcAft>
-                <a:spcPts val="200"/>
-              </a:spcAft>
-            </a:pPr>
-            <a:r>
-              <a:rPr sz="1450">
-                <a:solidFill>
-                  <a:srgbClr val="E9EEFB"/>
-                </a:solidFill>
-                <a:latin typeface="Consolas"/>
-              </a:rPr>
-              <a:t/>
-            </a:r>
-          </a:p>
-          <a:p>
-            <a:pPr>
-              <a:lnSpc>
-                <a:spcPct val="100000"/>
-              </a:lnSpc>
-              <a:spcAft>
-                <a:spcPts val="200"/>
-              </a:spcAft>
-            </a:pPr>
-            <a:r>
-              <a:rPr sz="1450">
-                <a:solidFill>
-                  <a:srgbClr val="5D6B8F"/>
-                </a:solidFill>
-                <a:latin typeface="Consolas"/>
-              </a:rPr>
-              <a:t>    // Render thread only — raw physics integration</a:t>
-            </a:r>
-          </a:p>
-          <a:p>
-            <a:pPr>
-              <a:lnSpc>
-                <a:spcPct val="100000"/>
-              </a:lnSpc>
-              <a:spcAft>
-                <a:spcPts val="200"/>
-              </a:spcAft>
-            </a:pPr>
-            <a:r>
-              <a:rPr sz="1450">
-                <a:solidFill>
-                  <a:srgbClr val="FF7AB2"/>
-                </a:solidFill>
-                <a:latin typeface="Consolas"/>
-              </a:rPr>
-              <a:t>    var</a:t>
-            </a:r>
-            <a:r>
-              <a:rPr sz="1450">
-                <a:solidFill>
-                  <a:srgbClr val="E9EEFB"/>
-                </a:solidFill>
-                <a:latin typeface="Consolas"/>
-              </a:rPr>
-              <a:t> _roll = </a:t>
-            </a:r>
-            <a:r>
-              <a:rPr sz="1450">
-                <a:solidFill>
-                  <a:srgbClr val="F7C873"/>
-                </a:solidFill>
-                <a:latin typeface="Consolas"/>
-              </a:rPr>
-              <a:t>0.0</a:t>
-            </a:r>
-          </a:p>
-          <a:p>
-            <a:pPr>
-              <a:lnSpc>
-                <a:spcPct val="100000"/>
-              </a:lnSpc>
-              <a:spcAft>
-                <a:spcPts val="200"/>
-              </a:spcAft>
-            </a:pPr>
-            <a:r>
-              <a:rPr sz="1450">
-                <a:solidFill>
-                  <a:srgbClr val="FF7AB2"/>
-                </a:solidFill>
-                <a:latin typeface="Consolas"/>
-              </a:rPr>
-              <a:t>    var</a:t>
-            </a:r>
-            <a:r>
-              <a:rPr sz="1450">
-                <a:solidFill>
-                  <a:srgbClr val="E9EEFB"/>
-                </a:solidFill>
-                <a:latin typeface="Consolas"/>
-              </a:rPr>
-              <a:t> _vel: </a:t>
-            </a:r>
-            <a:r>
-              <a:rPr sz="1450">
-                <a:solidFill>
-                  <a:srgbClr val="7EE0C8"/>
-                </a:solidFill>
-                <a:latin typeface="Consolas"/>
-              </a:rPr>
-              <a:t>SIMD3</a:t>
-            </a:r>
-            <a:r>
-              <a:rPr sz="1450">
-                <a:solidFill>
-                  <a:srgbClr val="E9EEFB"/>
-                </a:solidFill>
-                <a:latin typeface="Consolas"/>
-              </a:rPr>
-              <a:t>&lt;</a:t>
-            </a:r>
-            <a:r>
-              <a:rPr sz="1450">
-                <a:solidFill>
-                  <a:srgbClr val="7EE0C8"/>
-                </a:solidFill>
-                <a:latin typeface="Consolas"/>
-              </a:rPr>
-              <a:t>Float</a:t>
-            </a:r>
-            <a:r>
-              <a:rPr sz="1450">
-                <a:solidFill>
-                  <a:srgbClr val="E9EEFB"/>
-                </a:solidFill>
-                <a:latin typeface="Consolas"/>
-              </a:rPr>
-              <a:t>&gt; = .zero</a:t>
-            </a:r>
-          </a:p>
-          <a:p>
-            <a:pPr>
-              <a:lnSpc>
-                <a:spcPct val="100000"/>
-              </a:lnSpc>
-              <a:spcAft>
-                <a:spcPts val="200"/>
-              </a:spcAft>
-            </a:pPr>
-            <a:r>
-              <a:rPr sz="1450">
-                <a:solidFill>
-                  <a:srgbClr val="E9EEFB"/>
-                </a:solidFill>
-                <a:latin typeface="Consolas"/>
-              </a:rPr>
-              <a:t/>
-            </a:r>
-          </a:p>
-          <a:p>
-            <a:pPr>
-              <a:lnSpc>
-                <a:spcPct val="100000"/>
-              </a:lnSpc>
-              <a:spcAft>
-                <a:spcPts val="200"/>
-              </a:spcAft>
-            </a:pPr>
-            <a:r>
-              <a:rPr sz="1450">
-                <a:solidFill>
-                  <a:srgbClr val="FF7AB2"/>
-                </a:solidFill>
-                <a:latin typeface="Consolas"/>
-              </a:rPr>
-              <a:t>    func </a:t>
-            </a:r>
-            <a:r>
-              <a:rPr sz="1450">
-                <a:solidFill>
-                  <a:srgbClr val="82AAFF"/>
-                </a:solidFill>
-                <a:latin typeface="Consolas"/>
-              </a:rPr>
-              <a:t>tick</a:t>
-            </a:r>
-            <a:r>
-              <a:rPr sz="1450">
-                <a:solidFill>
-                  <a:srgbClr val="E9EEFB"/>
-                </a:solidFill>
-                <a:latin typeface="Consolas"/>
-              </a:rPr>
-              <a:t>(dt: </a:t>
-            </a:r>
-            <a:r>
-              <a:rPr sz="1450">
-                <a:solidFill>
-                  <a:srgbClr val="7EE0C8"/>
-                </a:solidFill>
-                <a:latin typeface="Consolas"/>
-              </a:rPr>
-              <a:t>Double</a:t>
-            </a:r>
-            <a:r>
-              <a:rPr sz="1450">
-                <a:solidFill>
-                  <a:srgbClr val="E9EEFB"/>
-                </a:solidFill>
-                <a:latin typeface="Consolas"/>
-              </a:rPr>
-              <a:t>) { </a:t>
-            </a:r>
-            <a:r>
-              <a:rPr sz="1450">
-                <a:solidFill>
-                  <a:srgbClr val="5D6B8F"/>
-                </a:solidFill>
-                <a:latin typeface="Consolas"/>
-              </a:rPr>
-              <a:t>/* render thread: physics */</a:t>
-            </a:r>
-            <a:r>
-              <a:rPr sz="1450">
-                <a:solidFill>
-                  <a:srgbClr val="E9EEFB"/>
-                </a:solidFill>
-                <a:latin typeface="Consolas"/>
-              </a:rPr>
-              <a:t> }</a:t>
-            </a:r>
-          </a:p>
-          <a:p>
-            <a:pPr>
-              <a:lnSpc>
-                <a:spcPct val="100000"/>
-              </a:lnSpc>
-              <a:spcAft>
-                <a:spcPts val="200"/>
-              </a:spcAft>
-            </a:pPr>
-            <a:r>
-              <a:rPr sz="1450">
-                <a:solidFill>
-                  <a:srgbClr val="FF7AB2"/>
-                </a:solidFill>
-                <a:latin typeface="Consolas"/>
-              </a:rPr>
-              <a:t>    func </a:t>
-            </a:r>
-            <a:r>
-              <a:rPr sz="1450">
-                <a:solidFill>
-                  <a:srgbClr val="82AAFF"/>
-                </a:solidFill>
-                <a:latin typeface="Consolas"/>
-              </a:rPr>
-              <a:t>syncPublished</a:t>
-            </a:r>
-            <a:r>
-              <a:rPr sz="1450">
-                <a:solidFill>
-                  <a:srgbClr val="E9EEFB"/>
-                </a:solidFill>
-                <a:latin typeface="Consolas"/>
-              </a:rPr>
-              <a:t>() { </a:t>
-            </a:r>
-            <a:r>
-              <a:rPr sz="1450">
-                <a:solidFill>
-                  <a:srgbClr val="5D6B8F"/>
-                </a:solidFill>
-                <a:latin typeface="Consolas"/>
-              </a:rPr>
-              <a:t>/* main: _vars → @Published */</a:t>
-            </a:r>
-            <a:r>
-              <a:rPr sz="1450">
-                <a:solidFill>
-                  <a:srgbClr val="E9EEFB"/>
-                </a:solidFill>
-                <a:latin typeface="Consolas"/>
-              </a:rPr>
-              <a:t> }</a:t>
-            </a:r>
-          </a:p>
-          <a:p>
-            <a:pPr>
-              <a:lnSpc>
-                <a:spcPct val="100000"/>
-              </a:lnSpc>
-              <a:spcAft>
-                <a:spcPts val="200"/>
-              </a:spcAft>
-            </a:pPr>
-            <a:r>
-              <a:rPr sz="1450">
-                <a:solidFill>
-                  <a:srgbClr val="E9EEFB"/>
-                </a:solidFill>
-                <a:latin typeface="Consolas"/>
-              </a:rPr>
-              <a:t>}</a:t>
-            </a:r>
-          </a:p>
-        </p:txBody>
-      </p:sp>
-    </p:spTree>
-  </p:cSld>
-  <p:clrMapOvr>
-    <a:masterClrMapping/>
-  </p:clrMapOvr>
-</p:sld>
-</file>
-
-<file path=ppt/slides/slide9.xml><?xml version="1.0" encoding="utf-8"?>
 <p:sld xmlns:a="http://schemas.openxmlformats.org/drawingml/2006/main" xmlns:p="http://schemas.openxmlformats.org/presentationml/2006/main" xmlns:r="http://schemas.openxmlformats.org/officeDocument/2006/relationships">
   <p:cSld>
     <p:spTree>

</xml_diff>

<commit_message>
docs(ios): lokale Präsentations-Entwürfe sichern
Uncommittete Stände von pptx, build_deck-Skripten, Logos und Speaker Notes vom Mac, gesichert vor dem Rechnerwechsel. origin/ep7-ios-app hat neuere Commits an denselben Dateien; vor einer Übernahme abgleichen.
</commit_message>
<xml_diff>
--- a/docs/presentation-ios/EasyPilot-iOS-Overview.pptx
+++ b/docs/presentation-ios/EasyPilot-iOS-Overview.pptx
@@ -10,9 +10,6 @@
     <p:sldId id="258" r:id="rId9"/>
     <p:sldId id="259" r:id="rId10"/>
     <p:sldId id="260" r:id="rId11"/>
-    <p:sldId id="261" r:id="rId12"/>
-    <p:sldId id="262" r:id="rId13"/>
-    <p:sldId id="263" r:id="rId14"/>
   </p:sldIdLst>
   <p:sldSz cx="12191695" cy="6858000" type="screen4x3"/>
   <p:notesSz cx="6858000" cy="9144000"/>
@@ -3599,7 +3596,7 @@
                 </a:solidFill>
                 <a:latin typeface="Helvetica Neue"/>
               </a:rPr>
-              <a:t>SYSTEM OVERVIEW</a:t>
+              <a:t>TECHNOLOGIES USED</a:t>
             </a:r>
           </a:p>
         </p:txBody>
@@ -3641,7 +3638,7 @@
                 </a:solidFill>
                 <a:latin typeface="Helvetica Neue"/>
               </a:rPr>
-              <a:t>How the app talks to the drone</a:t>
+              <a:t>The iOS stack</a:t>
             </a:r>
           </a:p>
         </p:txBody>
@@ -3654,8 +3651,8 @@
         </p:nvSpPr>
         <p:spPr>
           <a:xfrm>
-            <a:off x="777240" y="1783080"/>
-            <a:ext cx="3291840" cy="868680"/>
+            <a:off x="777240" y="1828800"/>
+            <a:ext cx="3520440" cy="1965960"/>
           </a:xfrm>
           <a:prstGeom prst="roundRect">
             <a:avLst>
@@ -3667,7 +3664,7 @@
           </a:solidFill>
           <a:ln w="15875">
             <a:solidFill>
-              <a:srgbClr val="33D980"/>
+              <a:srgbClr val="2979FF"/>
             </a:solidFill>
           </a:ln>
           <a:effectLst/>
@@ -3694,16 +3691,40 @@
           </a:p>
         </p:txBody>
       </p:sp>
-      <p:sp>
-        <p:nvSpPr>
-          <p:cNvPr id="6" name="TextBox 5"/>
+      <p:pic>
+        <p:nvPicPr>
+          <p:cNvPr id="6" name="Picture 5" descr="swift.png"/>
+          <p:cNvPicPr>
+            <a:picLocks noChangeAspect="1"/>
+          </p:cNvPicPr>
+          <p:nvPr/>
+        </p:nvPicPr>
+        <p:blipFill>
+          <a:blip r:embed="rId2"/>
+          <a:stretch>
+            <a:fillRect/>
+          </a:stretch>
+        </p:blipFill>
+        <p:spPr>
+          <a:xfrm>
+            <a:off x="1051560" y="2121408"/>
+            <a:ext cx="822957" cy="253745"/>
+          </a:xfrm>
+          <a:prstGeom prst="rect">
+            <a:avLst/>
+          </a:prstGeom>
+        </p:spPr>
+      </p:pic>
+      <p:sp>
+        <p:nvSpPr>
+          <p:cNvPr id="7" name="TextBox 6"/>
           <p:cNvSpPr txBox="1"/>
           <p:nvPr/>
         </p:nvSpPr>
         <p:spPr>
           <a:xfrm>
-            <a:off x="777240" y="1783080"/>
-            <a:ext cx="3291840" cy="868680"/>
+            <a:off x="2103120" y="2121408"/>
+            <a:ext cx="1965960" cy="822960"/>
           </a:xfrm>
           <a:prstGeom prst="rect">
             <a:avLst/>
@@ -3716,7 +3737,7 @@
           </a:bodyPr>
           <a:lstStyle/>
           <a:p>
-            <a:pPr algn="ctr">
+            <a:pPr algn="l">
               <a:spcBef>
                 <a:spcPts val="0"/>
               </a:spcBef>
@@ -3725,27 +3746,27 @@
               </a:spcAft>
             </a:pPr>
             <a:r>
-              <a:rPr sz="1900" b="1">
+              <a:rPr sz="1700" b="1">
                 <a:solidFill>
                   <a:srgbClr val="E9EEFB"/>
                 </a:solidFill>
                 <a:latin typeface="Helvetica Neue"/>
               </a:rPr>
-              <a:t>ESP32-C3  ·  WiFi</a:t>
-            </a:r>
-          </a:p>
-        </p:txBody>
-      </p:sp>
-      <p:sp>
-        <p:nvSpPr>
-          <p:cNvPr id="7" name="TextBox 6"/>
+              <a:t>Swift 5</a:t>
+            </a:r>
+          </a:p>
+        </p:txBody>
+      </p:sp>
+      <p:sp>
+        <p:nvSpPr>
+          <p:cNvPr id="8" name="TextBox 7"/>
           <p:cNvSpPr txBox="1"/>
           <p:nvPr/>
         </p:nvSpPr>
         <p:spPr>
           <a:xfrm>
-            <a:off x="4572000" y="1828800"/>
-            <a:ext cx="6949440" cy="822960"/>
+            <a:off x="1051560" y="3127248"/>
+            <a:ext cx="2971800" cy="566928"/>
           </a:xfrm>
           <a:prstGeom prst="rect">
             <a:avLst/>
@@ -3763,115 +3784,17 @@
                 <a:spcPts val="0"/>
               </a:spcBef>
               <a:spcAft>
-                <a:spcPts val="200"/>
+                <a:spcPts val="0"/>
               </a:spcAft>
             </a:pPr>
             <a:r>
-              <a:rPr sz="1600" b="0">
+              <a:rPr sz="1300" b="0">
                 <a:solidFill>
                   <a:srgbClr val="8A97B8"/>
                 </a:solidFill>
                 <a:latin typeface="Helvetica Neue"/>
               </a:rPr>
-              <a:t>└─ UDP broadcast  </a:t>
-            </a:r>
-            <a:r>
-              <a:rPr sz="1600" b="1">
-                <a:solidFill>
-                  <a:srgbClr val="33D980"/>
-                </a:solidFill>
-                <a:latin typeface="Consolas"/>
-              </a:rPr>
-              <a:t>"EASYPILOT:&lt;IP&gt;"</a:t>
-            </a:r>
-            <a:r>
-              <a:rPr sz="1600" b="0">
-                <a:solidFill>
-                  <a:srgbClr val="8A97B8"/>
-                </a:solidFill>
-                <a:latin typeface="Helvetica Neue"/>
-              </a:rPr>
-              <a:t>  every 5 s · port 4242</a:t>
-            </a:r>
-          </a:p>
-          <a:p>
-            <a:pPr algn="l">
-              <a:spcBef>
-                <a:spcPts val="0"/>
-              </a:spcBef>
-              <a:spcAft>
-                <a:spcPts val="200"/>
-              </a:spcAft>
-            </a:pPr>
-            <a:r>
-              <a:rPr sz="1500" b="0">
-                <a:solidFill>
-                  <a:srgbClr val="8A97B8"/>
-                </a:solidFill>
-                <a:latin typeface="Helvetica Neue"/>
-              </a:rPr>
-              <a:t>     → iOS auto-discovers the IP, no typing</a:t>
-            </a:r>
-          </a:p>
-        </p:txBody>
-      </p:sp>
-      <p:sp>
-        <p:nvSpPr>
-          <p:cNvPr id="8" name="TextBox 7"/>
-          <p:cNvSpPr txBox="1"/>
-          <p:nvPr/>
-        </p:nvSpPr>
-        <p:spPr>
-          <a:xfrm>
-            <a:off x="4572000" y="2788920"/>
-            <a:ext cx="6949440" cy="822960"/>
-          </a:xfrm>
-          <a:prstGeom prst="rect">
-            <a:avLst/>
-          </a:prstGeom>
-          <a:noFill/>
-        </p:spPr>
-        <p:txBody>
-          <a:bodyPr wrap="square" anchor="t" lIns="0" rIns="0" tIns="0" bIns="0">
-            <a:spAutoFit/>
-          </a:bodyPr>
-          <a:lstStyle/>
-          <a:p>
-            <a:pPr algn="l">
-              <a:spcBef>
-                <a:spcPts val="0"/>
-              </a:spcBef>
-              <a:spcAft>
-                <a:spcPts val="200"/>
-              </a:spcAft>
-            </a:pPr>
-            <a:r>
-              <a:rPr sz="1600" b="1">
-                <a:solidFill>
-                  <a:srgbClr val="2979FF"/>
-                </a:solidFill>
-                <a:latin typeface="Helvetica Neue"/>
-              </a:rPr>
-              <a:t>└─ WebSocket server · port 81</a:t>
-            </a:r>
-          </a:p>
-          <a:p>
-            <a:pPr algn="l">
-              <a:spcBef>
-                <a:spcPts val="0"/>
-              </a:spcBef>
-              <a:spcAft>
-                <a:spcPts val="200"/>
-              </a:spcAft>
-            </a:pPr>
-            <a:r>
-              <a:rPr sz="1500" b="0">
-                <a:solidFill>
-                  <a:srgbClr val="8A97B8"/>
-                </a:solidFill>
-                <a:latin typeface="Helvetica Neue"/>
-              </a:rPr>
-              <a:t>     ←→ commands out · telemetry JSON in @ 10 Hz</a:t>
+              <a:t>Apple's modern, type-safe language for the whole app.</a:t>
             </a:r>
           </a:p>
         </p:txBody>
@@ -3884,8 +3807,8 @@
         </p:nvSpPr>
         <p:spPr>
           <a:xfrm>
-            <a:off x="777240" y="3840480"/>
-            <a:ext cx="3291840" cy="868680"/>
+            <a:off x="4572000" y="1828800"/>
+            <a:ext cx="3520440" cy="1965960"/>
           </a:xfrm>
           <a:prstGeom prst="roundRect">
             <a:avLst>
@@ -3924,16 +3847,40 @@
           </a:p>
         </p:txBody>
       </p:sp>
-      <p:sp>
-        <p:nvSpPr>
-          <p:cNvPr id="10" name="TextBox 9"/>
+      <p:pic>
+        <p:nvPicPr>
+          <p:cNvPr id="10" name="Picture 9" descr="swiftui.png"/>
+          <p:cNvPicPr>
+            <a:picLocks noChangeAspect="1"/>
+          </p:cNvPicPr>
+          <p:nvPr/>
+        </p:nvPicPr>
+        <p:blipFill>
+          <a:blip r:embed="rId3"/>
+          <a:stretch>
+            <a:fillRect/>
+          </a:stretch>
+        </p:blipFill>
+        <p:spPr>
+          <a:xfrm>
+            <a:off x="4846320" y="2121408"/>
+            <a:ext cx="822960" cy="822960"/>
+          </a:xfrm>
+          <a:prstGeom prst="rect">
+            <a:avLst/>
+          </a:prstGeom>
+        </p:spPr>
+      </p:pic>
+      <p:sp>
+        <p:nvSpPr>
+          <p:cNvPr id="11" name="TextBox 10"/>
           <p:cNvSpPr txBox="1"/>
           <p:nvPr/>
         </p:nvSpPr>
         <p:spPr>
           <a:xfrm>
-            <a:off x="777240" y="3840480"/>
-            <a:ext cx="3291840" cy="868680"/>
+            <a:off x="5897880" y="2121408"/>
+            <a:ext cx="1965960" cy="822960"/>
           </a:xfrm>
           <a:prstGeom prst="rect">
             <a:avLst/>
@@ -3946,7 +3893,7 @@
           </a:bodyPr>
           <a:lstStyle/>
           <a:p>
-            <a:pPr algn="ctr">
+            <a:pPr algn="l">
               <a:spcBef>
                 <a:spcPts val="0"/>
               </a:spcBef>
@@ -3955,27 +3902,69 @@
               </a:spcAft>
             </a:pPr>
             <a:r>
-              <a:rPr sz="1800" b="1">
+              <a:rPr sz="1700" b="1">
                 <a:solidFill>
                   <a:srgbClr val="E9EEFB"/>
                 </a:solidFill>
                 <a:latin typeface="Helvetica Neue"/>
               </a:rPr>
-              <a:t>iPhone — EasyPilot App</a:t>
-            </a:r>
-          </a:p>
-        </p:txBody>
-      </p:sp>
-      <p:sp>
-        <p:nvSpPr>
-          <p:cNvPr id="11" name="Rounded Rectangle 10"/>
+              <a:t>SwiftUI</a:t>
+            </a:r>
+          </a:p>
+        </p:txBody>
+      </p:sp>
+      <p:sp>
+        <p:nvSpPr>
+          <p:cNvPr id="12" name="TextBox 11"/>
+          <p:cNvSpPr txBox="1"/>
+          <p:nvPr/>
+        </p:nvSpPr>
+        <p:spPr>
+          <a:xfrm>
+            <a:off x="4846320" y="3127248"/>
+            <a:ext cx="2971800" cy="566928"/>
+          </a:xfrm>
+          <a:prstGeom prst="rect">
+            <a:avLst/>
+          </a:prstGeom>
+          <a:noFill/>
+        </p:spPr>
+        <p:txBody>
+          <a:bodyPr wrap="square" anchor="t" lIns="0" rIns="0" tIns="0" bIns="0">
+            <a:spAutoFit/>
+          </a:bodyPr>
+          <a:lstStyle/>
+          <a:p>
+            <a:pPr algn="l">
+              <a:spcBef>
+                <a:spcPts val="0"/>
+              </a:spcBef>
+              <a:spcAft>
+                <a:spcPts val="0"/>
+              </a:spcAft>
+            </a:pPr>
+            <a:r>
+              <a:rPr sz="1300" b="0">
+                <a:solidFill>
+                  <a:srgbClr val="8A97B8"/>
+                </a:solidFill>
+                <a:latin typeface="Helvetica Neue"/>
+              </a:rPr>
+              <a:t>Declarative UI — TabView, glass cards, live bindings.</a:t>
+            </a:r>
+          </a:p>
+        </p:txBody>
+      </p:sp>
+      <p:sp>
+        <p:nvSpPr>
+          <p:cNvPr id="13" name="Rounded Rectangle 12"/>
           <p:cNvSpPr/>
           <p:nvPr/>
         </p:nvSpPr>
         <p:spPr>
           <a:xfrm>
-            <a:off x="777240" y="5074920"/>
-            <a:ext cx="3474720" cy="1188720"/>
+            <a:off x="8366760" y="1828800"/>
+            <a:ext cx="3520440" cy="1965960"/>
           </a:xfrm>
           <a:prstGeom prst="roundRect">
             <a:avLst>
@@ -4014,16 +4003,40 @@
           </a:p>
         </p:txBody>
       </p:sp>
-      <p:sp>
-        <p:nvSpPr>
-          <p:cNvPr id="12" name="TextBox 11"/>
+      <p:pic>
+        <p:nvPicPr>
+          <p:cNvPr id="14" name="Picture 13" descr="network.png"/>
+          <p:cNvPicPr>
+            <a:picLocks noChangeAspect="1"/>
+          </p:cNvPicPr>
+          <p:nvPr/>
+        </p:nvPicPr>
+        <p:blipFill>
+          <a:blip r:embed="rId4"/>
+          <a:stretch>
+            <a:fillRect/>
+          </a:stretch>
+        </p:blipFill>
+        <p:spPr>
+          <a:xfrm>
+            <a:off x="8641080" y="2121408"/>
+            <a:ext cx="822960" cy="822960"/>
+          </a:xfrm>
+          <a:prstGeom prst="rect">
+            <a:avLst/>
+          </a:prstGeom>
+        </p:spPr>
+      </p:pic>
+      <p:sp>
+        <p:nvSpPr>
+          <p:cNvPr id="15" name="TextBox 14"/>
           <p:cNvSpPr txBox="1"/>
           <p:nvPr/>
         </p:nvSpPr>
         <p:spPr>
           <a:xfrm>
-            <a:off x="777240" y="5166360"/>
-            <a:ext cx="3474720" cy="640080"/>
+            <a:off x="9692640" y="2121408"/>
+            <a:ext cx="1965960" cy="822960"/>
           </a:xfrm>
           <a:prstGeom prst="rect">
             <a:avLst/>
@@ -4031,12 +4044,12 @@
           <a:noFill/>
         </p:spPr>
         <p:txBody>
-          <a:bodyPr wrap="square" anchor="t" lIns="0" rIns="0" tIns="0" bIns="0">
+          <a:bodyPr wrap="square" anchor="ctr" lIns="0" rIns="0" tIns="0" bIns="0">
             <a:spAutoFit/>
           </a:bodyPr>
           <a:lstStyle/>
           <a:p>
-            <a:pPr algn="ctr">
+            <a:pPr algn="l">
               <a:spcBef>
                 <a:spcPts val="0"/>
               </a:spcBef>
@@ -4045,27 +4058,27 @@
               </a:spcAft>
             </a:pPr>
             <a:r>
-              <a:rPr sz="3200" b="1">
-                <a:solidFill>
-                  <a:srgbClr val="2979FF"/>
+              <a:rPr sz="1700" b="1">
+                <a:solidFill>
+                  <a:srgbClr val="E9EEFB"/>
                 </a:solidFill>
                 <a:latin typeface="Helvetica Neue"/>
               </a:rPr>
-              <a:t>3</a:t>
-            </a:r>
-          </a:p>
-        </p:txBody>
-      </p:sp>
-      <p:sp>
-        <p:nvSpPr>
-          <p:cNvPr id="13" name="TextBox 12"/>
+              <a:t>Network.framework</a:t>
+            </a:r>
+          </a:p>
+        </p:txBody>
+      </p:sp>
+      <p:sp>
+        <p:nvSpPr>
+          <p:cNvPr id="16" name="TextBox 15"/>
           <p:cNvSpPr txBox="1"/>
           <p:nvPr/>
         </p:nvSpPr>
         <p:spPr>
           <a:xfrm>
-            <a:off x="960120" y="5806440"/>
-            <a:ext cx="3108960" cy="502920"/>
+            <a:off x="8641080" y="3127248"/>
+            <a:ext cx="2971800" cy="566928"/>
           </a:xfrm>
           <a:prstGeom prst="rect">
             <a:avLst/>
@@ -4078,12 +4091,12 @@
           </a:bodyPr>
           <a:lstStyle/>
           <a:p>
-            <a:pPr algn="ctr">
+            <a:pPr algn="l">
               <a:spcBef>
                 <a:spcPts val="0"/>
               </a:spcBef>
               <a:spcAft>
-                <a:spcPts val="600"/>
+                <a:spcPts val="0"/>
               </a:spcAft>
             </a:pPr>
             <a:r>
@@ -4093,21 +4106,21 @@
                 </a:solidFill>
                 <a:latin typeface="Helvetica Neue"/>
               </a:rPr>
-              <a:t>tabs: Dashboard · Simulator · Algorithms</a:t>
-            </a:r>
-          </a:p>
-        </p:txBody>
-      </p:sp>
-      <p:sp>
-        <p:nvSpPr>
-          <p:cNvPr id="14" name="Rounded Rectangle 13"/>
+              <a:t>NWListener UDP discovery + WebSocket data link.</a:t>
+            </a:r>
+          </a:p>
+        </p:txBody>
+      </p:sp>
+      <p:sp>
+        <p:nvSpPr>
+          <p:cNvPr id="17" name="Rounded Rectangle 16"/>
           <p:cNvSpPr/>
           <p:nvPr/>
         </p:nvSpPr>
         <p:spPr>
           <a:xfrm>
-            <a:off x="4526280" y="5074920"/>
-            <a:ext cx="3474720" cy="1188720"/>
+            <a:off x="777240" y="4069080"/>
+            <a:ext cx="3520440" cy="1965960"/>
           </a:xfrm>
           <a:prstGeom prst="roundRect">
             <a:avLst>
@@ -4146,16 +4159,40 @@
           </a:p>
         </p:txBody>
       </p:sp>
-      <p:sp>
-        <p:nvSpPr>
-          <p:cNvPr id="15" name="TextBox 14"/>
+      <p:pic>
+        <p:nvPicPr>
+          <p:cNvPr id="18" name="Picture 17" descr="scenekit.png"/>
+          <p:cNvPicPr>
+            <a:picLocks noChangeAspect="1"/>
+          </p:cNvPicPr>
+          <p:nvPr/>
+        </p:nvPicPr>
+        <p:blipFill>
+          <a:blip r:embed="rId5"/>
+          <a:stretch>
+            <a:fillRect/>
+          </a:stretch>
+        </p:blipFill>
+        <p:spPr>
+          <a:xfrm>
+            <a:off x="1051560" y="4361688"/>
+            <a:ext cx="822960" cy="822960"/>
+          </a:xfrm>
+          <a:prstGeom prst="rect">
+            <a:avLst/>
+          </a:prstGeom>
+        </p:spPr>
+      </p:pic>
+      <p:sp>
+        <p:nvSpPr>
+          <p:cNvPr id="19" name="TextBox 18"/>
           <p:cNvSpPr txBox="1"/>
           <p:nvPr/>
         </p:nvSpPr>
         <p:spPr>
           <a:xfrm>
-            <a:off x="4526280" y="5166360"/>
-            <a:ext cx="3474720" cy="640080"/>
+            <a:off x="2103120" y="4361688"/>
+            <a:ext cx="1965960" cy="822960"/>
           </a:xfrm>
           <a:prstGeom prst="rect">
             <a:avLst/>
@@ -4163,12 +4200,12 @@
           <a:noFill/>
         </p:spPr>
         <p:txBody>
-          <a:bodyPr wrap="square" anchor="t" lIns="0" rIns="0" tIns="0" bIns="0">
+          <a:bodyPr wrap="square" anchor="ctr" lIns="0" rIns="0" tIns="0" bIns="0">
             <a:spAutoFit/>
           </a:bodyPr>
           <a:lstStyle/>
           <a:p>
-            <a:pPr algn="ctr">
+            <a:pPr algn="l">
               <a:spcBef>
                 <a:spcPts val="0"/>
               </a:spcBef>
@@ -4177,27 +4214,27 @@
               </a:spcAft>
             </a:pPr>
             <a:r>
-              <a:rPr sz="3200" b="1">
-                <a:solidFill>
-                  <a:srgbClr val="2979FF"/>
+              <a:rPr sz="1700" b="1">
+                <a:solidFill>
+                  <a:srgbClr val="E9EEFB"/>
                 </a:solidFill>
                 <a:latin typeface="Helvetica Neue"/>
               </a:rPr>
-              <a:t>10 Hz</a:t>
-            </a:r>
-          </a:p>
-        </p:txBody>
-      </p:sp>
-      <p:sp>
-        <p:nvSpPr>
-          <p:cNvPr id="16" name="TextBox 15"/>
+              <a:t>SceneKit</a:t>
+            </a:r>
+          </a:p>
+        </p:txBody>
+      </p:sp>
+      <p:sp>
+        <p:nvSpPr>
+          <p:cNvPr id="20" name="TextBox 19"/>
           <p:cNvSpPr txBox="1"/>
           <p:nvPr/>
         </p:nvSpPr>
         <p:spPr>
           <a:xfrm>
-            <a:off x="4709160" y="5806440"/>
-            <a:ext cx="3108960" cy="502920"/>
+            <a:off x="1051560" y="5367528"/>
+            <a:ext cx="2971800" cy="566928"/>
           </a:xfrm>
           <a:prstGeom prst="rect">
             <a:avLst/>
@@ -4210,12 +4247,12 @@
           </a:bodyPr>
           <a:lstStyle/>
           <a:p>
-            <a:pPr algn="ctr">
+            <a:pPr algn="l">
               <a:spcBef>
                 <a:spcPts val="0"/>
               </a:spcBef>
               <a:spcAft>
-                <a:spcPts val="600"/>
+                <a:spcPts val="0"/>
               </a:spcAft>
             </a:pPr>
             <a:r>
@@ -4225,21 +4262,21 @@
                 </a:solidFill>
                 <a:latin typeface="Helvetica Neue"/>
               </a:rPr>
-              <a:t>telemetry &amp; motion update rate</a:t>
-            </a:r>
-          </a:p>
-        </p:txBody>
-      </p:sp>
-      <p:sp>
-        <p:nvSpPr>
-          <p:cNvPr id="17" name="Rounded Rectangle 16"/>
+              <a:t>Real-time 3D flight simulator with .usdz drone model.</a:t>
+            </a:r>
+          </a:p>
+        </p:txBody>
+      </p:sp>
+      <p:sp>
+        <p:nvSpPr>
+          <p:cNvPr id="21" name="Rounded Rectangle 20"/>
           <p:cNvSpPr/>
           <p:nvPr/>
         </p:nvSpPr>
         <p:spPr>
           <a:xfrm>
-            <a:off x="8275320" y="5074920"/>
-            <a:ext cx="3474720" cy="1188720"/>
+            <a:off x="4572000" y="4069080"/>
+            <a:ext cx="3520440" cy="1965960"/>
           </a:xfrm>
           <a:prstGeom prst="roundRect">
             <a:avLst>
@@ -4278,16 +4315,40 @@
           </a:p>
         </p:txBody>
       </p:sp>
-      <p:sp>
-        <p:nvSpPr>
-          <p:cNvPr id="18" name="TextBox 17"/>
+      <p:pic>
+        <p:nvPicPr>
+          <p:cNvPr id="22" name="Picture 21" descr="coremotion.png"/>
+          <p:cNvPicPr>
+            <a:picLocks noChangeAspect="1"/>
+          </p:cNvPicPr>
+          <p:nvPr/>
+        </p:nvPicPr>
+        <p:blipFill>
+          <a:blip r:embed="rId6"/>
+          <a:stretch>
+            <a:fillRect/>
+          </a:stretch>
+        </p:blipFill>
+        <p:spPr>
+          <a:xfrm>
+            <a:off x="4846320" y="4361688"/>
+            <a:ext cx="822960" cy="822960"/>
+          </a:xfrm>
+          <a:prstGeom prst="rect">
+            <a:avLst/>
+          </a:prstGeom>
+        </p:spPr>
+      </p:pic>
+      <p:sp>
+        <p:nvSpPr>
+          <p:cNvPr id="23" name="TextBox 22"/>
           <p:cNvSpPr txBox="1"/>
           <p:nvPr/>
         </p:nvSpPr>
         <p:spPr>
           <a:xfrm>
-            <a:off x="8275320" y="5166360"/>
-            <a:ext cx="3474720" cy="640080"/>
+            <a:off x="5897880" y="4361688"/>
+            <a:ext cx="1965960" cy="822960"/>
           </a:xfrm>
           <a:prstGeom prst="rect">
             <a:avLst/>
@@ -4295,12 +4356,12 @@
           <a:noFill/>
         </p:spPr>
         <p:txBody>
-          <a:bodyPr wrap="square" anchor="t" lIns="0" rIns="0" tIns="0" bIns="0">
+          <a:bodyPr wrap="square" anchor="ctr" lIns="0" rIns="0" tIns="0" bIns="0">
             <a:spAutoFit/>
           </a:bodyPr>
           <a:lstStyle/>
           <a:p>
-            <a:pPr algn="ctr">
+            <a:pPr algn="l">
               <a:spcBef>
                 <a:spcPts val="0"/>
               </a:spcBef>
@@ -4309,27 +4370,27 @@
               </a:spcAft>
             </a:pPr>
             <a:r>
-              <a:rPr sz="3200" b="1">
-                <a:solidFill>
-                  <a:srgbClr val="2979FF"/>
+              <a:rPr sz="1700" b="1">
+                <a:solidFill>
+                  <a:srgbClr val="E9EEFB"/>
                 </a:solidFill>
                 <a:latin typeface="Helvetica Neue"/>
               </a:rPr>
-              <a:t>~3,400</a:t>
-            </a:r>
-          </a:p>
-        </p:txBody>
-      </p:sp>
-      <p:sp>
-        <p:nvSpPr>
-          <p:cNvPr id="19" name="TextBox 18"/>
+              <a:t>CoreMotion</a:t>
+            </a:r>
+          </a:p>
+        </p:txBody>
+      </p:sp>
+      <p:sp>
+        <p:nvSpPr>
+          <p:cNvPr id="24" name="TextBox 23"/>
           <p:cNvSpPr txBox="1"/>
           <p:nvPr/>
         </p:nvSpPr>
         <p:spPr>
           <a:xfrm>
-            <a:off x="8458200" y="5806440"/>
-            <a:ext cx="3108960" cy="502920"/>
+            <a:off x="4846320" y="5367528"/>
+            <a:ext cx="2971800" cy="566928"/>
           </a:xfrm>
           <a:prstGeom prst="rect">
             <a:avLst/>
@@ -4342,7 +4403,121 @@
           </a:bodyPr>
           <a:lstStyle/>
           <a:p>
-            <a:pPr algn="ctr">
+            <a:pPr algn="l">
+              <a:spcBef>
+                <a:spcPts val="0"/>
+              </a:spcBef>
+              <a:spcAft>
+                <a:spcPts val="0"/>
+              </a:spcAft>
+            </a:pPr>
+            <a:r>
+              <a:rPr sz="1300" b="0">
+                <a:solidFill>
+                  <a:srgbClr val="8A97B8"/>
+                </a:solidFill>
+                <a:latin typeface="Helvetica Neue"/>
+              </a:rPr>
+              <a:t>Gyro / accelerometer read at 10 Hz for tilt control.</a:t>
+            </a:r>
+          </a:p>
+        </p:txBody>
+      </p:sp>
+      <p:sp>
+        <p:nvSpPr>
+          <p:cNvPr id="25" name="Rounded Rectangle 24"/>
+          <p:cNvSpPr/>
+          <p:nvPr/>
+        </p:nvSpPr>
+        <p:spPr>
+          <a:xfrm>
+            <a:off x="8366760" y="4069080"/>
+            <a:ext cx="3520440" cy="1965960"/>
+          </a:xfrm>
+          <a:prstGeom prst="roundRect">
+            <a:avLst>
+              <a:gd name="adj" fmla="val 6000"/>
+            </a:avLst>
+          </a:prstGeom>
+          <a:solidFill>
+            <a:srgbClr val="141C33"/>
+          </a:solidFill>
+          <a:ln w="15875">
+            <a:solidFill>
+              <a:srgbClr val="2979FF"/>
+            </a:solidFill>
+          </a:ln>
+          <a:effectLst/>
+        </p:spPr>
+        <p:style>
+          <a:lnRef idx="1">
+            <a:schemeClr val="accent1"/>
+          </a:lnRef>
+          <a:fillRef idx="3">
+            <a:schemeClr val="accent1"/>
+          </a:fillRef>
+          <a:effectRef idx="2">
+            <a:schemeClr val="accent1"/>
+          </a:effectRef>
+          <a:fontRef idx="minor">
+            <a:schemeClr val="lt1"/>
+          </a:fontRef>
+        </p:style>
+        <p:txBody>
+          <a:bodyPr rtlCol="0" anchor="ctr"/>
+          <a:lstStyle/>
+          <a:p>
+            <a:pPr algn="ctr"/>
+          </a:p>
+        </p:txBody>
+      </p:sp>
+      <p:pic>
+        <p:nvPicPr>
+          <p:cNvPr id="26" name="Picture 25" descr="esp.png"/>
+          <p:cNvPicPr>
+            <a:picLocks noChangeAspect="1"/>
+          </p:cNvPicPr>
+          <p:nvPr/>
+        </p:nvPicPr>
+        <p:blipFill>
+          <a:blip r:embed="rId7"/>
+          <a:stretch>
+            <a:fillRect/>
+          </a:stretch>
+        </p:blipFill>
+        <p:spPr>
+          <a:xfrm>
+            <a:off x="8641080" y="4361688"/>
+            <a:ext cx="822960" cy="185166"/>
+          </a:xfrm>
+          <a:prstGeom prst="rect">
+            <a:avLst/>
+          </a:prstGeom>
+        </p:spPr>
+      </p:pic>
+      <p:sp>
+        <p:nvSpPr>
+          <p:cNvPr id="27" name="TextBox 26"/>
+          <p:cNvSpPr txBox="1"/>
+          <p:nvPr/>
+        </p:nvSpPr>
+        <p:spPr>
+          <a:xfrm>
+            <a:off x="9692640" y="4361688"/>
+            <a:ext cx="1965960" cy="822960"/>
+          </a:xfrm>
+          <a:prstGeom prst="rect">
+            <a:avLst/>
+          </a:prstGeom>
+          <a:noFill/>
+        </p:spPr>
+        <p:txBody>
+          <a:bodyPr wrap="square" anchor="ctr" lIns="0" rIns="0" tIns="0" bIns="0">
+            <a:spAutoFit/>
+          </a:bodyPr>
+          <a:lstStyle/>
+          <a:p>
+            <a:pPr algn="l">
               <a:spcBef>
                 <a:spcPts val="0"/>
               </a:spcBef>
@@ -4351,13 +4526,55 @@
               </a:spcAft>
             </a:pPr>
             <a:r>
+              <a:rPr sz="1700" b="1">
+                <a:solidFill>
+                  <a:srgbClr val="E9EEFB"/>
+                </a:solidFill>
+                <a:latin typeface="Helvetica Neue"/>
+              </a:rPr>
+              <a:t>Espressif ESP32</a:t>
+            </a:r>
+          </a:p>
+        </p:txBody>
+      </p:sp>
+      <p:sp>
+        <p:nvSpPr>
+          <p:cNvPr id="28" name="TextBox 27"/>
+          <p:cNvSpPr txBox="1"/>
+          <p:nvPr/>
+        </p:nvSpPr>
+        <p:spPr>
+          <a:xfrm>
+            <a:off x="8641080" y="5367528"/>
+            <a:ext cx="2971800" cy="566928"/>
+          </a:xfrm>
+          <a:prstGeom prst="rect">
+            <a:avLst/>
+          </a:prstGeom>
+          <a:noFill/>
+        </p:spPr>
+        <p:txBody>
+          <a:bodyPr wrap="square" anchor="t" lIns="0" rIns="0" tIns="0" bIns="0">
+            <a:spAutoFit/>
+          </a:bodyPr>
+          <a:lstStyle/>
+          <a:p>
+            <a:pPr algn="l">
+              <a:spcBef>
+                <a:spcPts val="0"/>
+              </a:spcBef>
+              <a:spcAft>
+                <a:spcPts val="0"/>
+              </a:spcAft>
+            </a:pPr>
+            <a:r>
               <a:rPr sz="1300" b="0">
                 <a:solidFill>
                   <a:srgbClr val="8A97B8"/>
                 </a:solidFill>
                 <a:latin typeface="Helvetica Neue"/>
               </a:rPr>
-              <a:t>lines of Swift across 18 files</a:t>
+              <a:t>On-drone firmware: WiFi, WebSocket server, beacon.</a:t>
             </a:r>
           </a:p>
         </p:txBody>
@@ -4461,7 +4678,7 @@
                 </a:solidFill>
                 <a:latin typeface="Helvetica Neue"/>
               </a:rPr>
-              <a:t>TECHNOLOGIES USED</a:t>
+              <a:t>CODE · SENSORS &amp; COMMANDS</a:t>
             </a:r>
           </a:p>
         </p:txBody>
@@ -4503,7 +4720,7 @@
                 </a:solidFill>
                 <a:latin typeface="Helvetica Neue"/>
               </a:rPr>
-              <a:t>The iOS stack</a:t>
+              <a:t>Phone tilt → drone command</a:t>
             </a:r>
           </a:p>
         </p:txBody>
@@ -4517,17 +4734,17 @@
         <p:spPr>
           <a:xfrm>
             <a:off x="777240" y="1828800"/>
-            <a:ext cx="3520440" cy="1965960"/>
+            <a:ext cx="10607040" cy="3931920"/>
           </a:xfrm>
           <a:prstGeom prst="roundRect">
             <a:avLst>
-              <a:gd name="adj" fmla="val 6000"/>
+              <a:gd name="adj" fmla="val 3000"/>
             </a:avLst>
           </a:prstGeom>
           <a:solidFill>
-            <a:srgbClr val="141C33"/>
+            <a:srgbClr val="0C1326"/>
           </a:solidFill>
-          <a:ln w="15875">
+          <a:ln w="12700">
             <a:solidFill>
               <a:srgbClr val="2979FF"/>
             </a:solidFill>
@@ -4549,897 +4766,351 @@
           </a:fontRef>
         </p:style>
         <p:txBody>
-          <a:bodyPr rtlCol="0" anchor="ctr"/>
-          <a:lstStyle/>
-          <a:p>
-            <a:pPr algn="ctr"/>
-          </a:p>
-        </p:txBody>
-      </p:sp>
-      <p:pic>
-        <p:nvPicPr>
-          <p:cNvPr id="6" name="Picture 5" descr="swift.png"/>
-          <p:cNvPicPr>
-            <a:picLocks noChangeAspect="1"/>
-          </p:cNvPicPr>
-          <p:nvPr/>
-        </p:nvPicPr>
-        <p:blipFill>
-          <a:blip r:embed="rId2"/>
-          <a:stretch>
-            <a:fillRect/>
-          </a:stretch>
-        </p:blipFill>
-        <p:spPr>
-          <a:xfrm>
-            <a:off x="1051560" y="2121408"/>
-            <a:ext cx="822957" cy="253745"/>
-          </a:xfrm>
-          <a:prstGeom prst="rect">
-            <a:avLst/>
-          </a:prstGeom>
-        </p:spPr>
-      </p:pic>
-      <p:sp>
-        <p:nvSpPr>
-          <p:cNvPr id="7" name="TextBox 6"/>
-          <p:cNvSpPr txBox="1"/>
-          <p:nvPr/>
-        </p:nvSpPr>
-        <p:spPr>
-          <a:xfrm>
-            <a:off x="2103120" y="2121408"/>
-            <a:ext cx="1965960" cy="822960"/>
-          </a:xfrm>
-          <a:prstGeom prst="rect">
-            <a:avLst/>
-          </a:prstGeom>
-          <a:noFill/>
-        </p:spPr>
-        <p:txBody>
-          <a:bodyPr wrap="square" anchor="ctr" lIns="0" rIns="0" tIns="0" bIns="0">
-            <a:spAutoFit/>
-          </a:bodyPr>
-          <a:lstStyle/>
-          <a:p>
-            <a:pPr algn="l">
-              <a:spcBef>
-                <a:spcPts val="0"/>
-              </a:spcBef>
+          <a:bodyPr rtlCol="0" anchor="ctr" wrap="square" lIns="320040" tIns="228600" rIns="182880"/>
+          <a:lstStyle/>
+          <a:p>
+            <a:pPr algn="ctr">
+              <a:lnSpc>
+                <a:spcPct val="100000"/>
+              </a:lnSpc>
               <a:spcAft>
-                <a:spcPts val="600"/>
+                <a:spcPts val="200"/>
               </a:spcAft>
             </a:pPr>
             <a:r>
-              <a:rPr sz="1700" b="1">
-                <a:solidFill>
-                  <a:srgbClr val="E9EEFB"/>
-                </a:solidFill>
-                <a:latin typeface="Helvetica Neue"/>
-              </a:rPr>
-              <a:t>Swift 5</a:t>
-            </a:r>
-          </a:p>
-        </p:txBody>
-      </p:sp>
-      <p:sp>
-        <p:nvSpPr>
-          <p:cNvPr id="8" name="TextBox 7"/>
-          <p:cNvSpPr txBox="1"/>
-          <p:nvPr/>
-        </p:nvSpPr>
-        <p:spPr>
-          <a:xfrm>
-            <a:off x="1051560" y="3127248"/>
-            <a:ext cx="2971800" cy="566928"/>
-          </a:xfrm>
-          <a:prstGeom prst="rect">
-            <a:avLst/>
-          </a:prstGeom>
-          <a:noFill/>
-        </p:spPr>
-        <p:txBody>
-          <a:bodyPr wrap="square" anchor="t" lIns="0" rIns="0" tIns="0" bIns="0">
-            <a:spAutoFit/>
-          </a:bodyPr>
-          <a:lstStyle/>
-          <a:p>
-            <a:pPr algn="l">
-              <a:spcBef>
-                <a:spcPts val="0"/>
-              </a:spcBef>
+              <a:rPr sz="1450">
+                <a:solidFill>
+                  <a:srgbClr val="5D6B8F"/>
+                </a:solidFill>
+                <a:latin typeface="Consolas"/>
+              </a:rPr>
+              <a:t>// CoreMotion device-motion updates @ 10 Hz</a:t>
+            </a:r>
+          </a:p>
+          <a:p>
+            <a:pPr>
+              <a:lnSpc>
+                <a:spcPct val="100000"/>
+              </a:lnSpc>
               <a:spcAft>
-                <a:spcPts val="0"/>
+                <a:spcPts val="200"/>
               </a:spcAft>
             </a:pPr>
             <a:r>
-              <a:rPr sz="1300" b="0">
-                <a:solidFill>
-                  <a:srgbClr val="8A97B8"/>
-                </a:solidFill>
-                <a:latin typeface="Helvetica Neue"/>
-              </a:rPr>
-              <a:t>Apple's modern, type-safe language for the whole app.</a:t>
-            </a:r>
-          </a:p>
-        </p:txBody>
-      </p:sp>
-      <p:sp>
-        <p:nvSpPr>
-          <p:cNvPr id="9" name="Rounded Rectangle 8"/>
-          <p:cNvSpPr/>
-          <p:nvPr/>
-        </p:nvSpPr>
-        <p:spPr>
-          <a:xfrm>
-            <a:off x="4572000" y="1828800"/>
-            <a:ext cx="3520440" cy="1965960"/>
-          </a:xfrm>
-          <a:prstGeom prst="roundRect">
-            <a:avLst>
-              <a:gd name="adj" fmla="val 6000"/>
-            </a:avLst>
-          </a:prstGeom>
-          <a:solidFill>
-            <a:srgbClr val="141C33"/>
-          </a:solidFill>
-          <a:ln w="15875">
-            <a:solidFill>
-              <a:srgbClr val="2979FF"/>
-            </a:solidFill>
-          </a:ln>
-          <a:effectLst/>
-        </p:spPr>
-        <p:style>
-          <a:lnRef idx="1">
-            <a:schemeClr val="accent1"/>
-          </a:lnRef>
-          <a:fillRef idx="3">
-            <a:schemeClr val="accent1"/>
-          </a:fillRef>
-          <a:effectRef idx="2">
-            <a:schemeClr val="accent1"/>
-          </a:effectRef>
-          <a:fontRef idx="minor">
-            <a:schemeClr val="lt1"/>
-          </a:fontRef>
-        </p:style>
-        <p:txBody>
-          <a:bodyPr rtlCol="0" anchor="ctr"/>
-          <a:lstStyle/>
-          <a:p>
-            <a:pPr algn="ctr"/>
-          </a:p>
-        </p:txBody>
-      </p:sp>
-      <p:pic>
-        <p:nvPicPr>
-          <p:cNvPr id="10" name="Picture 9" descr="swiftui.png"/>
-          <p:cNvPicPr>
-            <a:picLocks noChangeAspect="1"/>
-          </p:cNvPicPr>
-          <p:nvPr/>
-        </p:nvPicPr>
-        <p:blipFill>
-          <a:blip r:embed="rId3"/>
-          <a:stretch>
-            <a:fillRect/>
-          </a:stretch>
-        </p:blipFill>
-        <p:spPr>
-          <a:xfrm>
-            <a:off x="4846320" y="2121408"/>
-            <a:ext cx="822960" cy="822960"/>
-          </a:xfrm>
-          <a:prstGeom prst="rect">
-            <a:avLst/>
-          </a:prstGeom>
-        </p:spPr>
-      </p:pic>
-      <p:sp>
-        <p:nvSpPr>
-          <p:cNvPr id="11" name="TextBox 10"/>
-          <p:cNvSpPr txBox="1"/>
-          <p:nvPr/>
-        </p:nvSpPr>
-        <p:spPr>
-          <a:xfrm>
-            <a:off x="5897880" y="2121408"/>
-            <a:ext cx="1965960" cy="822960"/>
-          </a:xfrm>
-          <a:prstGeom prst="rect">
-            <a:avLst/>
-          </a:prstGeom>
-          <a:noFill/>
-        </p:spPr>
-        <p:txBody>
-          <a:bodyPr wrap="square" anchor="ctr" lIns="0" rIns="0" tIns="0" bIns="0">
-            <a:spAutoFit/>
-          </a:bodyPr>
-          <a:lstStyle/>
-          <a:p>
-            <a:pPr algn="l">
-              <a:spcBef>
-                <a:spcPts val="0"/>
-              </a:spcBef>
+              <a:rPr sz="1450">
+                <a:solidFill>
+                  <a:srgbClr val="E9EEFB"/>
+                </a:solidFill>
+                <a:latin typeface="Consolas"/>
+              </a:rPr>
+              <a:t>motionManager.</a:t>
+            </a:r>
+            <a:r>
+              <a:rPr sz="1450">
+                <a:solidFill>
+                  <a:srgbClr val="82AAFF"/>
+                </a:solidFill>
+                <a:latin typeface="Consolas"/>
+              </a:rPr>
+              <a:t>startDeviceMotionUpdates</a:t>
+            </a:r>
+            <a:r>
+              <a:rPr sz="1450">
+                <a:solidFill>
+                  <a:srgbClr val="E9EEFB"/>
+                </a:solidFill>
+                <a:latin typeface="Consolas"/>
+              </a:rPr>
+              <a:t>(to: .main) { data, _ </a:t>
+            </a:r>
+            <a:r>
+              <a:rPr sz="1450">
+                <a:solidFill>
+                  <a:srgbClr val="FF7AB2"/>
+                </a:solidFill>
+                <a:latin typeface="Consolas"/>
+              </a:rPr>
+              <a:t>in</a:t>
+            </a:r>
+          </a:p>
+          <a:p>
+            <a:pPr>
+              <a:lnSpc>
+                <a:spcPct val="100000"/>
+              </a:lnSpc>
               <a:spcAft>
-                <a:spcPts val="600"/>
+                <a:spcPts val="200"/>
               </a:spcAft>
             </a:pPr>
             <a:r>
-              <a:rPr sz="1700" b="1">
+              <a:rPr sz="1450">
+                <a:solidFill>
+                  <a:srgbClr val="FF7AB2"/>
+                </a:solidFill>
+                <a:latin typeface="Consolas"/>
+              </a:rPr>
+              <a:t>    let</a:t>
+            </a:r>
+            <a:r>
+              <a:rPr sz="1450">
                 <a:solidFill>
                   <a:srgbClr val="E9EEFB"/>
                 </a:solidFill>
-                <a:latin typeface="Helvetica Neue"/>
-              </a:rPr>
-              <a:t>SwiftUI</a:t>
-            </a:r>
-          </a:p>
-        </p:txBody>
-      </p:sp>
-      <p:sp>
-        <p:nvSpPr>
-          <p:cNvPr id="12" name="TextBox 11"/>
-          <p:cNvSpPr txBox="1"/>
-          <p:nvPr/>
-        </p:nvSpPr>
-        <p:spPr>
-          <a:xfrm>
-            <a:off x="4846320" y="3127248"/>
-            <a:ext cx="2971800" cy="566928"/>
-          </a:xfrm>
-          <a:prstGeom prst="rect">
-            <a:avLst/>
-          </a:prstGeom>
-          <a:noFill/>
-        </p:spPr>
-        <p:txBody>
-          <a:bodyPr wrap="square" anchor="t" lIns="0" rIns="0" tIns="0" bIns="0">
-            <a:spAutoFit/>
-          </a:bodyPr>
-          <a:lstStyle/>
-          <a:p>
-            <a:pPr algn="l">
-              <a:spcBef>
-                <a:spcPts val="0"/>
-              </a:spcBef>
+                <a:latin typeface="Consolas"/>
+              </a:rPr>
+              <a:t> r = </a:t>
+            </a:r>
+            <a:r>
+              <a:rPr sz="1450">
+                <a:solidFill>
+                  <a:srgbClr val="F7C873"/>
+                </a:solidFill>
+                <a:latin typeface="Consolas"/>
+              </a:rPr>
+              <a:t>180</a:t>
+            </a:r>
+            <a:r>
+              <a:rPr sz="1450">
+                <a:solidFill>
+                  <a:srgbClr val="E9EEFB"/>
+                </a:solidFill>
+                <a:latin typeface="Consolas"/>
+              </a:rPr>
+              <a:t> / .pi</a:t>
+            </a:r>
+          </a:p>
+          <a:p>
+            <a:pPr>
+              <a:lnSpc>
+                <a:spcPct val="100000"/>
+              </a:lnSpc>
               <a:spcAft>
-                <a:spcPts val="0"/>
+                <a:spcPts val="200"/>
               </a:spcAft>
             </a:pPr>
             <a:r>
-              <a:rPr sz="1300" b="0">
-                <a:solidFill>
-                  <a:srgbClr val="8A97B8"/>
-                </a:solidFill>
-                <a:latin typeface="Helvetica Neue"/>
-              </a:rPr>
-              <a:t>Declarative UI — TabView, glass cards, live bindings.</a:t>
-            </a:r>
-          </a:p>
-        </p:txBody>
-      </p:sp>
-      <p:sp>
-        <p:nvSpPr>
-          <p:cNvPr id="13" name="Rounded Rectangle 12"/>
-          <p:cNvSpPr/>
-          <p:nvPr/>
-        </p:nvSpPr>
-        <p:spPr>
-          <a:xfrm>
-            <a:off x="8366760" y="1828800"/>
-            <a:ext cx="3520440" cy="1965960"/>
-          </a:xfrm>
-          <a:prstGeom prst="roundRect">
-            <a:avLst>
-              <a:gd name="adj" fmla="val 6000"/>
-            </a:avLst>
-          </a:prstGeom>
-          <a:solidFill>
-            <a:srgbClr val="141C33"/>
-          </a:solidFill>
-          <a:ln w="15875">
-            <a:solidFill>
-              <a:srgbClr val="2979FF"/>
-            </a:solidFill>
-          </a:ln>
-          <a:effectLst/>
-        </p:spPr>
-        <p:style>
-          <a:lnRef idx="1">
-            <a:schemeClr val="accent1"/>
-          </a:lnRef>
-          <a:fillRef idx="3">
-            <a:schemeClr val="accent1"/>
-          </a:fillRef>
-          <a:effectRef idx="2">
-            <a:schemeClr val="accent1"/>
-          </a:effectRef>
-          <a:fontRef idx="minor">
-            <a:schemeClr val="lt1"/>
-          </a:fontRef>
-        </p:style>
-        <p:txBody>
-          <a:bodyPr rtlCol="0" anchor="ctr"/>
-          <a:lstStyle/>
-          <a:p>
-            <a:pPr algn="ctr"/>
-          </a:p>
-        </p:txBody>
-      </p:sp>
-      <p:pic>
-        <p:nvPicPr>
-          <p:cNvPr id="14" name="Picture 13" descr="network.png"/>
-          <p:cNvPicPr>
-            <a:picLocks noChangeAspect="1"/>
-          </p:cNvPicPr>
-          <p:nvPr/>
-        </p:nvPicPr>
-        <p:blipFill>
-          <a:blip r:embed="rId4"/>
-          <a:stretch>
-            <a:fillRect/>
-          </a:stretch>
-        </p:blipFill>
-        <p:spPr>
-          <a:xfrm>
-            <a:off x="8641080" y="2121408"/>
-            <a:ext cx="822960" cy="822960"/>
-          </a:xfrm>
-          <a:prstGeom prst="rect">
-            <a:avLst/>
-          </a:prstGeom>
-        </p:spPr>
-      </p:pic>
-      <p:sp>
-        <p:nvSpPr>
-          <p:cNvPr id="15" name="TextBox 14"/>
-          <p:cNvSpPr txBox="1"/>
-          <p:nvPr/>
-        </p:nvSpPr>
-        <p:spPr>
-          <a:xfrm>
-            <a:off x="9692640" y="2121408"/>
-            <a:ext cx="1965960" cy="822960"/>
-          </a:xfrm>
-          <a:prstGeom prst="rect">
-            <a:avLst/>
-          </a:prstGeom>
-          <a:noFill/>
-        </p:spPr>
-        <p:txBody>
-          <a:bodyPr wrap="square" anchor="ctr" lIns="0" rIns="0" tIns="0" bIns="0">
-            <a:spAutoFit/>
-          </a:bodyPr>
-          <a:lstStyle/>
-          <a:p>
-            <a:pPr algn="l">
-              <a:spcBef>
-                <a:spcPts val="0"/>
-              </a:spcBef>
+              <a:rPr sz="1450">
+                <a:solidFill>
+                  <a:srgbClr val="FF7AB2"/>
+                </a:solidFill>
+                <a:latin typeface="Consolas"/>
+              </a:rPr>
+              <a:t>    self</a:t>
+            </a:r>
+            <a:r>
+              <a:rPr sz="1450">
+                <a:solidFill>
+                  <a:srgbClr val="E9EEFB"/>
+                </a:solidFill>
+                <a:latin typeface="Consolas"/>
+              </a:rPr>
+              <a:t>.pitch = data.attitude.pitch * r</a:t>
+            </a:r>
+          </a:p>
+          <a:p>
+            <a:pPr>
+              <a:lnSpc>
+                <a:spcPct val="100000"/>
+              </a:lnSpc>
               <a:spcAft>
-                <a:spcPts val="600"/>
+                <a:spcPts val="200"/>
               </a:spcAft>
             </a:pPr>
             <a:r>
-              <a:rPr sz="1700" b="1">
+              <a:rPr sz="1450">
+                <a:solidFill>
+                  <a:srgbClr val="FF7AB2"/>
+                </a:solidFill>
+                <a:latin typeface="Consolas"/>
+              </a:rPr>
+              <a:t>    self</a:t>
+            </a:r>
+            <a:r>
+              <a:rPr sz="1450">
                 <a:solidFill>
                   <a:srgbClr val="E9EEFB"/>
                 </a:solidFill>
-                <a:latin typeface="Helvetica Neue"/>
-              </a:rPr>
-              <a:t>Network.framework</a:t>
-            </a:r>
-          </a:p>
-        </p:txBody>
-      </p:sp>
-      <p:sp>
-        <p:nvSpPr>
-          <p:cNvPr id="16" name="TextBox 15"/>
-          <p:cNvSpPr txBox="1"/>
-          <p:nvPr/>
-        </p:nvSpPr>
-        <p:spPr>
-          <a:xfrm>
-            <a:off x="8641080" y="3127248"/>
-            <a:ext cx="2971800" cy="566928"/>
-          </a:xfrm>
-          <a:prstGeom prst="rect">
-            <a:avLst/>
-          </a:prstGeom>
-          <a:noFill/>
-        </p:spPr>
-        <p:txBody>
-          <a:bodyPr wrap="square" anchor="t" lIns="0" rIns="0" tIns="0" bIns="0">
-            <a:spAutoFit/>
-          </a:bodyPr>
-          <a:lstStyle/>
-          <a:p>
-            <a:pPr algn="l">
-              <a:spcBef>
-                <a:spcPts val="0"/>
-              </a:spcBef>
+                <a:latin typeface="Consolas"/>
+              </a:rPr>
+              <a:t>.roll  = data.attitude.roll  * r</a:t>
+            </a:r>
+          </a:p>
+          <a:p>
+            <a:pPr>
+              <a:lnSpc>
+                <a:spcPct val="100000"/>
+              </a:lnSpc>
               <a:spcAft>
-                <a:spcPts val="0"/>
+                <a:spcPts val="200"/>
               </a:spcAft>
             </a:pPr>
             <a:r>
-              <a:rPr sz="1300" b="0">
-                <a:solidFill>
-                  <a:srgbClr val="8A97B8"/>
-                </a:solidFill>
-                <a:latin typeface="Helvetica Neue"/>
-              </a:rPr>
-              <a:t>NWListener UDP discovery + WebSocket data link.</a:t>
-            </a:r>
-          </a:p>
-        </p:txBody>
-      </p:sp>
-      <p:sp>
-        <p:nvSpPr>
-          <p:cNvPr id="17" name="Rounded Rectangle 16"/>
-          <p:cNvSpPr/>
-          <p:nvPr/>
-        </p:nvSpPr>
-        <p:spPr>
-          <a:xfrm>
-            <a:off x="777240" y="4069080"/>
-            <a:ext cx="3520440" cy="1965960"/>
-          </a:xfrm>
-          <a:prstGeom prst="roundRect">
-            <a:avLst>
-              <a:gd name="adj" fmla="val 6000"/>
-            </a:avLst>
-          </a:prstGeom>
-          <a:solidFill>
-            <a:srgbClr val="141C33"/>
-          </a:solidFill>
-          <a:ln w="15875">
-            <a:solidFill>
-              <a:srgbClr val="2979FF"/>
-            </a:solidFill>
-          </a:ln>
-          <a:effectLst/>
-        </p:spPr>
-        <p:style>
-          <a:lnRef idx="1">
-            <a:schemeClr val="accent1"/>
-          </a:lnRef>
-          <a:fillRef idx="3">
-            <a:schemeClr val="accent1"/>
-          </a:fillRef>
-          <a:effectRef idx="2">
-            <a:schemeClr val="accent1"/>
-          </a:effectRef>
-          <a:fontRef idx="minor">
-            <a:schemeClr val="lt1"/>
-          </a:fontRef>
-        </p:style>
-        <p:txBody>
-          <a:bodyPr rtlCol="0" anchor="ctr"/>
-          <a:lstStyle/>
-          <a:p>
-            <a:pPr algn="ctr"/>
-          </a:p>
-        </p:txBody>
-      </p:sp>
-      <p:pic>
-        <p:nvPicPr>
-          <p:cNvPr id="18" name="Picture 17" descr="scenekit.png"/>
-          <p:cNvPicPr>
-            <a:picLocks noChangeAspect="1"/>
-          </p:cNvPicPr>
-          <p:nvPr/>
-        </p:nvPicPr>
-        <p:blipFill>
-          <a:blip r:embed="rId5"/>
-          <a:stretch>
-            <a:fillRect/>
-          </a:stretch>
-        </p:blipFill>
-        <p:spPr>
-          <a:xfrm>
-            <a:off x="1051560" y="4361688"/>
-            <a:ext cx="822960" cy="822960"/>
-          </a:xfrm>
-          <a:prstGeom prst="rect">
-            <a:avLst/>
-          </a:prstGeom>
-        </p:spPr>
-      </p:pic>
-      <p:sp>
-        <p:nvSpPr>
-          <p:cNvPr id="19" name="TextBox 18"/>
-          <p:cNvSpPr txBox="1"/>
-          <p:nvPr/>
-        </p:nvSpPr>
-        <p:spPr>
-          <a:xfrm>
-            <a:off x="2103120" y="4361688"/>
-            <a:ext cx="1965960" cy="822960"/>
-          </a:xfrm>
-          <a:prstGeom prst="rect">
-            <a:avLst/>
-          </a:prstGeom>
-          <a:noFill/>
-        </p:spPr>
-        <p:txBody>
-          <a:bodyPr wrap="square" anchor="ctr" lIns="0" rIns="0" tIns="0" bIns="0">
-            <a:spAutoFit/>
-          </a:bodyPr>
-          <a:lstStyle/>
-          <a:p>
-            <a:pPr algn="l">
-              <a:spcBef>
-                <a:spcPts val="0"/>
-              </a:spcBef>
+              <a:rPr sz="1450">
+                <a:solidFill>
+                  <a:srgbClr val="E9EEFB"/>
+                </a:solidFill>
+                <a:latin typeface="Consolas"/>
+              </a:rPr>
+              <a:t>}</a:t>
+            </a:r>
+          </a:p>
+          <a:p>
+            <a:pPr>
+              <a:lnSpc>
+                <a:spcPct val="100000"/>
+              </a:lnSpc>
               <a:spcAft>
-                <a:spcPts val="600"/>
+                <a:spcPts val="200"/>
               </a:spcAft>
             </a:pPr>
             <a:r>
-              <a:rPr sz="1700" b="1">
+              <a:rPr sz="1450">
                 <a:solidFill>
                   <a:srgbClr val="E9EEFB"/>
                 </a:solidFill>
-                <a:latin typeface="Helvetica Neue"/>
-              </a:rPr>
-              <a:t>SceneKit</a:t>
-            </a:r>
-          </a:p>
-        </p:txBody>
-      </p:sp>
-      <p:sp>
-        <p:nvSpPr>
-          <p:cNvPr id="20" name="TextBox 19"/>
-          <p:cNvSpPr txBox="1"/>
-          <p:nvPr/>
-        </p:nvSpPr>
-        <p:spPr>
-          <a:xfrm>
-            <a:off x="1051560" y="5367528"/>
-            <a:ext cx="2971800" cy="566928"/>
-          </a:xfrm>
-          <a:prstGeom prst="rect">
-            <a:avLst/>
-          </a:prstGeom>
-          <a:noFill/>
-        </p:spPr>
-        <p:txBody>
-          <a:bodyPr wrap="square" anchor="t" lIns="0" rIns="0" tIns="0" bIns="0">
-            <a:spAutoFit/>
-          </a:bodyPr>
-          <a:lstStyle/>
-          <a:p>
-            <a:pPr algn="l">
-              <a:spcBef>
-                <a:spcPts val="0"/>
-              </a:spcBef>
+                <a:latin typeface="Consolas"/>
+              </a:rPr>
+              <a:t/>
+            </a:r>
+          </a:p>
+          <a:p>
+            <a:pPr>
+              <a:lnSpc>
+                <a:spcPct val="100000"/>
+              </a:lnSpc>
               <a:spcAft>
-                <a:spcPts val="0"/>
+                <a:spcPts val="200"/>
               </a:spcAft>
             </a:pPr>
             <a:r>
-              <a:rPr sz="1300" b="0">
-                <a:solidFill>
-                  <a:srgbClr val="8A97B8"/>
-                </a:solidFill>
-                <a:latin typeface="Helvetica Neue"/>
-              </a:rPr>
-              <a:t>Real-time 3D flight simulator with .usdz drone model.</a:t>
-            </a:r>
-          </a:p>
-        </p:txBody>
-      </p:sp>
-      <p:sp>
-        <p:nvSpPr>
-          <p:cNvPr id="21" name="Rounded Rectangle 20"/>
-          <p:cNvSpPr/>
-          <p:nvPr/>
-        </p:nvSpPr>
-        <p:spPr>
-          <a:xfrm>
-            <a:off x="4572000" y="4069080"/>
-            <a:ext cx="3520440" cy="1965960"/>
-          </a:xfrm>
-          <a:prstGeom prst="roundRect">
-            <a:avLst>
-              <a:gd name="adj" fmla="val 6000"/>
-            </a:avLst>
-          </a:prstGeom>
-          <a:solidFill>
-            <a:srgbClr val="141C33"/>
-          </a:solidFill>
-          <a:ln w="15875">
-            <a:solidFill>
-              <a:srgbClr val="2979FF"/>
-            </a:solidFill>
-          </a:ln>
-          <a:effectLst/>
-        </p:spPr>
-        <p:style>
-          <a:lnRef idx="1">
-            <a:schemeClr val="accent1"/>
-          </a:lnRef>
-          <a:fillRef idx="3">
-            <a:schemeClr val="accent1"/>
-          </a:fillRef>
-          <a:effectRef idx="2">
-            <a:schemeClr val="accent1"/>
-          </a:effectRef>
-          <a:fontRef idx="minor">
-            <a:schemeClr val="lt1"/>
-          </a:fontRef>
-        </p:style>
-        <p:txBody>
-          <a:bodyPr rtlCol="0" anchor="ctr"/>
-          <a:lstStyle/>
-          <a:p>
-            <a:pPr algn="ctr"/>
-          </a:p>
-        </p:txBody>
-      </p:sp>
-      <p:pic>
-        <p:nvPicPr>
-          <p:cNvPr id="22" name="Picture 21" descr="coremotion.png"/>
-          <p:cNvPicPr>
-            <a:picLocks noChangeAspect="1"/>
-          </p:cNvPicPr>
-          <p:nvPr/>
-        </p:nvPicPr>
-        <p:blipFill>
-          <a:blip r:embed="rId6"/>
-          <a:stretch>
-            <a:fillRect/>
-          </a:stretch>
-        </p:blipFill>
-        <p:spPr>
-          <a:xfrm>
-            <a:off x="4846320" y="4361688"/>
-            <a:ext cx="822960" cy="822960"/>
-          </a:xfrm>
-          <a:prstGeom prst="rect">
-            <a:avLst/>
-          </a:prstGeom>
-        </p:spPr>
-      </p:pic>
-      <p:sp>
-        <p:nvSpPr>
-          <p:cNvPr id="23" name="TextBox 22"/>
-          <p:cNvSpPr txBox="1"/>
-          <p:nvPr/>
-        </p:nvSpPr>
-        <p:spPr>
-          <a:xfrm>
-            <a:off x="5897880" y="4361688"/>
-            <a:ext cx="1965960" cy="822960"/>
-          </a:xfrm>
-          <a:prstGeom prst="rect">
-            <a:avLst/>
-          </a:prstGeom>
-          <a:noFill/>
-        </p:spPr>
-        <p:txBody>
-          <a:bodyPr wrap="square" anchor="ctr" lIns="0" rIns="0" tIns="0" bIns="0">
-            <a:spAutoFit/>
-          </a:bodyPr>
-          <a:lstStyle/>
-          <a:p>
-            <a:pPr algn="l">
-              <a:spcBef>
-                <a:spcPts val="0"/>
-              </a:spcBef>
+              <a:rPr sz="1450">
+                <a:solidFill>
+                  <a:srgbClr val="5D6B8F"/>
+                </a:solidFill>
+                <a:latin typeface="Consolas"/>
+              </a:rPr>
+              <a:t>// Type-safe JSON command builder (ControlProfile)</a:t>
+            </a:r>
+          </a:p>
+          <a:p>
+            <a:pPr>
+              <a:lnSpc>
+                <a:spcPct val="100000"/>
+              </a:lnSpc>
               <a:spcAft>
-                <a:spcPts val="600"/>
+                <a:spcPts val="200"/>
               </a:spcAft>
             </a:pPr>
             <a:r>
-              <a:rPr sz="1700" b="1">
+              <a:rPr sz="1450">
+                <a:solidFill>
+                  <a:srgbClr val="FF7AB2"/>
+                </a:solidFill>
+                <a:latin typeface="Consolas"/>
+              </a:rPr>
+              <a:t>func </a:t>
+            </a:r>
+            <a:r>
+              <a:rPr sz="1450">
+                <a:solidFill>
+                  <a:srgbClr val="82AAFF"/>
+                </a:solidFill>
+                <a:latin typeface="Consolas"/>
+              </a:rPr>
+              <a:t>startBalanceCommand</a:t>
+            </a:r>
+            <a:r>
+              <a:rPr sz="1450">
                 <a:solidFill>
                   <a:srgbClr val="E9EEFB"/>
                 </a:solidFill>
-                <a:latin typeface="Helvetica Neue"/>
-              </a:rPr>
-              <a:t>CoreMotion</a:t>
-            </a:r>
-          </a:p>
-        </p:txBody>
-      </p:sp>
-      <p:sp>
-        <p:nvSpPr>
-          <p:cNvPr id="24" name="TextBox 23"/>
-          <p:cNvSpPr txBox="1"/>
-          <p:nvPr/>
-        </p:nvSpPr>
-        <p:spPr>
-          <a:xfrm>
-            <a:off x="4846320" y="5367528"/>
-            <a:ext cx="2971800" cy="566928"/>
-          </a:xfrm>
-          <a:prstGeom prst="rect">
-            <a:avLst/>
-          </a:prstGeom>
-          <a:noFill/>
-        </p:spPr>
-        <p:txBody>
-          <a:bodyPr wrap="square" anchor="t" lIns="0" rIns="0" tIns="0" bIns="0">
-            <a:spAutoFit/>
-          </a:bodyPr>
-          <a:lstStyle/>
-          <a:p>
-            <a:pPr algn="l">
-              <a:spcBef>
-                <a:spcPts val="0"/>
-              </a:spcBef>
+                <a:latin typeface="Consolas"/>
+              </a:rPr>
+              <a:t>() -&gt; </a:t>
+            </a:r>
+            <a:r>
+              <a:rPr sz="1450">
+                <a:solidFill>
+                  <a:srgbClr val="7EE0C8"/>
+                </a:solidFill>
+                <a:latin typeface="Consolas"/>
+              </a:rPr>
+              <a:t>String</a:t>
+            </a:r>
+            <a:r>
+              <a:rPr sz="1450">
+                <a:solidFill>
+                  <a:srgbClr val="E9EEFB"/>
+                </a:solidFill>
+                <a:latin typeface="Consolas"/>
+              </a:rPr>
+              <a:t> {</a:t>
+            </a:r>
+          </a:p>
+          <a:p>
+            <a:pPr>
+              <a:lnSpc>
+                <a:spcPct val="100000"/>
+              </a:lnSpc>
               <a:spcAft>
-                <a:spcPts val="0"/>
+                <a:spcPts val="200"/>
               </a:spcAft>
             </a:pPr>
             <a:r>
-              <a:rPr sz="1300" b="0">
-                <a:solidFill>
-                  <a:srgbClr val="8A97B8"/>
-                </a:solidFill>
-                <a:latin typeface="Helvetica Neue"/>
-              </a:rPr>
-              <a:t>Gyro / accelerometer read at 10 Hz for tilt control.</a:t>
-            </a:r>
-          </a:p>
-        </p:txBody>
-      </p:sp>
-      <p:sp>
-        <p:nvSpPr>
-          <p:cNvPr id="25" name="Rounded Rectangle 24"/>
-          <p:cNvSpPr/>
-          <p:nvPr/>
-        </p:nvSpPr>
-        <p:spPr>
-          <a:xfrm>
-            <a:off x="8366760" y="4069080"/>
-            <a:ext cx="3520440" cy="1965960"/>
-          </a:xfrm>
-          <a:prstGeom prst="roundRect">
-            <a:avLst>
-              <a:gd name="adj" fmla="val 6000"/>
-            </a:avLst>
-          </a:prstGeom>
-          <a:solidFill>
-            <a:srgbClr val="141C33"/>
-          </a:solidFill>
-          <a:ln w="15875">
-            <a:solidFill>
-              <a:srgbClr val="2979FF"/>
-            </a:solidFill>
-          </a:ln>
-          <a:effectLst/>
-        </p:spPr>
-        <p:style>
-          <a:lnRef idx="1">
-            <a:schemeClr val="accent1"/>
-          </a:lnRef>
-          <a:fillRef idx="3">
-            <a:schemeClr val="accent1"/>
-          </a:fillRef>
-          <a:effectRef idx="2">
-            <a:schemeClr val="accent1"/>
-          </a:effectRef>
-          <a:fontRef idx="minor">
-            <a:schemeClr val="lt1"/>
-          </a:fontRef>
-        </p:style>
-        <p:txBody>
-          <a:bodyPr rtlCol="0" anchor="ctr"/>
-          <a:lstStyle/>
-          <a:p>
-            <a:pPr algn="ctr"/>
-          </a:p>
-        </p:txBody>
-      </p:sp>
-      <p:pic>
-        <p:nvPicPr>
-          <p:cNvPr id="26" name="Picture 25" descr="esp.png"/>
-          <p:cNvPicPr>
-            <a:picLocks noChangeAspect="1"/>
-          </p:cNvPicPr>
-          <p:nvPr/>
-        </p:nvPicPr>
-        <p:blipFill>
-          <a:blip r:embed="rId7"/>
-          <a:stretch>
-            <a:fillRect/>
-          </a:stretch>
-        </p:blipFill>
-        <p:spPr>
-          <a:xfrm>
-            <a:off x="8641080" y="4361688"/>
-            <a:ext cx="822960" cy="185166"/>
-          </a:xfrm>
-          <a:prstGeom prst="rect">
-            <a:avLst/>
-          </a:prstGeom>
-        </p:spPr>
-      </p:pic>
-      <p:sp>
-        <p:nvSpPr>
-          <p:cNvPr id="27" name="TextBox 26"/>
-          <p:cNvSpPr txBox="1"/>
-          <p:nvPr/>
-        </p:nvSpPr>
-        <p:spPr>
-          <a:xfrm>
-            <a:off x="9692640" y="4361688"/>
-            <a:ext cx="1965960" cy="822960"/>
-          </a:xfrm>
-          <a:prstGeom prst="rect">
-            <a:avLst/>
-          </a:prstGeom>
-          <a:noFill/>
-        </p:spPr>
-        <p:txBody>
-          <a:bodyPr wrap="square" anchor="ctr" lIns="0" rIns="0" tIns="0" bIns="0">
-            <a:spAutoFit/>
-          </a:bodyPr>
-          <a:lstStyle/>
-          <a:p>
-            <a:pPr algn="l">
-              <a:spcBef>
-                <a:spcPts val="0"/>
-              </a:spcBef>
+              <a:rPr sz="1450">
+                <a:solidFill>
+                  <a:srgbClr val="E9EEFB"/>
+                </a:solidFill>
+                <a:latin typeface="Consolas"/>
+              </a:rPr>
+              <a:t>    </a:t>
+            </a:r>
+            <a:r>
+              <a:rPr sz="1450">
+                <a:solidFill>
+                  <a:srgbClr val="C3E88D"/>
+                </a:solidFill>
+                <a:latin typeface="Consolas"/>
+              </a:rPr>
+              <a:t>"""{"cmd":"START_BALANCE","baseThrottle":\(baseThrottle),</a:t>
+            </a:r>
+          </a:p>
+          <a:p>
+            <a:pPr>
+              <a:lnSpc>
+                <a:spcPct val="100000"/>
+              </a:lnSpc>
               <a:spcAft>
-                <a:spcPts val="600"/>
+                <a:spcPts val="200"/>
               </a:spcAft>
             </a:pPr>
             <a:r>
-              <a:rPr sz="1700" b="1">
-                <a:solidFill>
-                  <a:srgbClr val="E9EEFB"/>
-                </a:solidFill>
-                <a:latin typeface="Helvetica Neue"/>
-              </a:rPr>
-              <a:t>Espressif ESP32</a:t>
-            </a:r>
-          </a:p>
-        </p:txBody>
-      </p:sp>
-      <p:sp>
-        <p:nvSpPr>
-          <p:cNvPr id="28" name="TextBox 27"/>
-          <p:cNvSpPr txBox="1"/>
-          <p:nvPr/>
-        </p:nvSpPr>
-        <p:spPr>
-          <a:xfrm>
-            <a:off x="8641080" y="5367528"/>
-            <a:ext cx="2971800" cy="566928"/>
-          </a:xfrm>
-          <a:prstGeom prst="rect">
-            <a:avLst/>
-          </a:prstGeom>
-          <a:noFill/>
-        </p:spPr>
-        <p:txBody>
-          <a:bodyPr wrap="square" anchor="t" lIns="0" rIns="0" tIns="0" bIns="0">
-            <a:spAutoFit/>
-          </a:bodyPr>
-          <a:lstStyle/>
-          <a:p>
-            <a:pPr algn="l">
-              <a:spcBef>
-                <a:spcPts val="0"/>
-              </a:spcBef>
+              <a:rPr sz="1450">
+                <a:solidFill>
+                  <a:srgbClr val="C3E88D"/>
+                </a:solidFill>
+                <a:latin typeface="Consolas"/>
+              </a:rPr>
+              <a:t>       "kPRoll":\(kPRoll),"kPPitch":\(kPPitch)}"""</a:t>
+            </a:r>
+          </a:p>
+          <a:p>
+            <a:pPr>
+              <a:lnSpc>
+                <a:spcPct val="100000"/>
+              </a:lnSpc>
               <a:spcAft>
-                <a:spcPts val="0"/>
+                <a:spcPts val="200"/>
               </a:spcAft>
             </a:pPr>
             <a:r>
-              <a:rPr sz="1300" b="0">
-                <a:solidFill>
-                  <a:srgbClr val="8A97B8"/>
-                </a:solidFill>
-                <a:latin typeface="Helvetica Neue"/>
-              </a:rPr>
-              <a:t>On-drone firmware: WiFi, WebSocket server, beacon.</a:t>
+              <a:rPr sz="1450">
+                <a:solidFill>
+                  <a:srgbClr val="E9EEFB"/>
+                </a:solidFill>
+                <a:latin typeface="Consolas"/>
+              </a:rPr>
+              <a:t>}</a:t>
             </a:r>
           </a:p>
         </p:txBody>
@@ -5543,7 +5214,7 @@
                 </a:solidFill>
                 <a:latin typeface="Helvetica Neue"/>
               </a:rPr>
-              <a:t>CODE · LIVE TELEMETRY</a:t>
+              <a:t>CODE · THE THREADING CHALLENGE</a:t>
             </a:r>
           </a:p>
         </p:txBody>
@@ -5585,20 +5256,62 @@
                 </a:solidFill>
                 <a:latin typeface="Helvetica Neue"/>
               </a:rPr>
-              <a:t>Decoding 10 Hz telemetry into the UI</a:t>
-            </a:r>
-          </a:p>
-        </p:txBody>
-      </p:sp>
-      <p:sp>
-        <p:nvSpPr>
-          <p:cNvPr id="5" name="Rounded Rectangle 4"/>
+              <a:t>Two threads, one drone</a:t>
+            </a:r>
+          </a:p>
+        </p:txBody>
+      </p:sp>
+      <p:sp>
+        <p:nvSpPr>
+          <p:cNvPr id="5" name="TextBox 4"/>
+          <p:cNvSpPr txBox="1"/>
+          <p:nvPr/>
+        </p:nvSpPr>
+        <p:spPr>
+          <a:xfrm>
+            <a:off x="777240" y="1691640"/>
+            <a:ext cx="10607040" cy="640080"/>
+          </a:xfrm>
+          <a:prstGeom prst="rect">
+            <a:avLst/>
+          </a:prstGeom>
+          <a:noFill/>
+        </p:spPr>
+        <p:txBody>
+          <a:bodyPr wrap="square" anchor="t" lIns="0" rIns="0" tIns="0" bIns="0">
+            <a:spAutoFit/>
+          </a:bodyPr>
+          <a:lstStyle/>
+          <a:p>
+            <a:pPr algn="l">
+              <a:spcBef>
+                <a:spcPts val="0"/>
+              </a:spcBef>
+              <a:spcAft>
+                <a:spcPts val="600"/>
+              </a:spcAft>
+            </a:pPr>
+            <a:r>
+              <a:rPr sz="1600" b="0">
+                <a:solidFill>
+                  <a:srgbClr val="8A97B8"/>
+                </a:solidFill>
+                <a:latin typeface="Helvetica Neue"/>
+              </a:rPr>
+              <a:t>Physics on SceneKit's render thread must never touch SwiftUI directly — so internal state is kept separate from published state.</a:t>
+            </a:r>
+          </a:p>
+        </p:txBody>
+      </p:sp>
+      <p:sp>
+        <p:nvSpPr>
+          <p:cNvPr id="6" name="Rounded Rectangle 5"/>
           <p:cNvSpPr/>
           <p:nvPr/>
         </p:nvSpPr>
         <p:spPr>
           <a:xfrm>
-            <a:off x="777240" y="1828800"/>
+            <a:off x="777240" y="2423160"/>
             <a:ext cx="10607040" cy="3931920"/>
           </a:xfrm>
           <a:prstGeom prst="roundRect">
@@ -5645,11 +5358,47 @@
             <a:r>
               <a:rPr sz="1450">
                 <a:solidFill>
-                  <a:srgbClr val="5D6B8F"/>
+                  <a:srgbClr val="FF7AB2"/>
                 </a:solidFill>
                 <a:latin typeface="Consolas"/>
               </a:rPr>
-              <a:t>// Codable struct mirrors the ESP32 JSON exactly</a:t>
+              <a:t>class </a:t>
+            </a:r>
+            <a:r>
+              <a:rPr sz="1450">
+                <a:solidFill>
+                  <a:srgbClr val="7EE0C8"/>
+                </a:solidFill>
+                <a:latin typeface="Consolas"/>
+              </a:rPr>
+              <a:t>DroneSimulator</a:t>
+            </a:r>
+            <a:r>
+              <a:rPr sz="1450">
+                <a:solidFill>
+                  <a:srgbClr val="E9EEFB"/>
+                </a:solidFill>
+                <a:latin typeface="Consolas"/>
+              </a:rPr>
+              <a:t>: </a:t>
+            </a:r>
+            <a:r>
+              <a:rPr sz="1450">
+                <a:solidFill>
+                  <a:srgbClr val="7EE0C8"/>
+                </a:solidFill>
+                <a:latin typeface="Consolas"/>
+              </a:rPr>
+              <a:t>ObservableObject</a:t>
+            </a:r>
+            <a:r>
+              <a:rPr sz="1450">
+                <a:solidFill>
+                  <a:srgbClr val="E9EEFB"/>
+                </a:solidFill>
+                <a:latin typeface="Consolas"/>
+              </a:rPr>
+              <a:t> {</a:t>
             </a:r>
           </a:p>
           <a:p>
@@ -5664,47 +5413,11 @@
             <a:r>
               <a:rPr sz="1450">
                 <a:solidFill>
-                  <a:srgbClr val="FF7AB2"/>
+                  <a:srgbClr val="5D6B8F"/>
                 </a:solidFill>
                 <a:latin typeface="Consolas"/>
               </a:rPr>
-              <a:t>struct </a:t>
-            </a:r>
-            <a:r>
-              <a:rPr sz="1450">
-                <a:solidFill>
-                  <a:srgbClr val="7EE0C8"/>
-                </a:solidFill>
-                <a:latin typeface="Consolas"/>
-              </a:rPr>
-              <a:t>DroneTelemetry</a:t>
-            </a:r>
-            <a:r>
-              <a:rPr sz="1450">
-                <a:solidFill>
-                  <a:srgbClr val="E9EEFB"/>
-                </a:solidFill>
-                <a:latin typeface="Consolas"/>
-              </a:rPr>
-              <a:t>: </a:t>
-            </a:r>
-            <a:r>
-              <a:rPr sz="1450">
-                <a:solidFill>
-                  <a:srgbClr val="7EE0C8"/>
-                </a:solidFill>
-                <a:latin typeface="Consolas"/>
-              </a:rPr>
-              <a:t>Codable</a:t>
-            </a:r>
-            <a:r>
-              <a:rPr sz="1450">
-                <a:solidFill>
-                  <a:srgbClr val="E9EEFB"/>
-                </a:solidFill>
-                <a:latin typeface="Consolas"/>
-              </a:rPr>
-              <a:t> {</a:t>
+              <a:t>    // Main thread only — drives SwiftUI</a:t>
             </a:r>
           </a:p>
           <a:p>
@@ -5719,11 +5432,29 @@
             <a:r>
               <a:rPr sz="1450">
                 <a:solidFill>
+                  <a:srgbClr val="E9EEFB"/>
+                </a:solidFill>
+                <a:latin typeface="Consolas"/>
+              </a:rPr>
+              <a:t>    @</a:t>
+            </a:r>
+            <a:r>
+              <a:rPr sz="1450">
+                <a:solidFill>
+                  <a:srgbClr val="7EE0C8"/>
+                </a:solidFill>
+                <a:latin typeface="Consolas"/>
+              </a:rPr>
+              <a:t>Published</a:t>
+            </a:r>
+            <a:r>
+              <a:rPr sz="1450">
+                <a:solidFill>
                   <a:srgbClr val="FF7AB2"/>
                 </a:solidFill>
                 <a:latin typeface="Consolas"/>
               </a:rPr>
-              <a:t>    let</a:t>
+              <a:t> var</a:t>
             </a:r>
             <a:r>
               <a:rPr sz="1450">
@@ -5732,16 +5463,16 @@
                 </a:solidFill>
                 <a:latin typeface="Consolas"/>
               </a:rPr>
-              <a:t> roll, pitch, yaw: </a:t>
+              <a:t> simRoll = </a:t>
             </a:r>
             <a:r>
               <a:rPr sz="1450">
                 <a:solidFill>
-                  <a:srgbClr val="7EE0C8"/>
+                  <a:srgbClr val="F7C873"/>
                 </a:solidFill>
                 <a:latin typeface="Consolas"/>
               </a:rPr>
-              <a:t>Float</a:t>
+              <a:t>0.0</a:t>
             </a:r>
           </a:p>
           <a:p>
@@ -5756,11 +5487,29 @@
             <a:r>
               <a:rPr sz="1450">
                 <a:solidFill>
+                  <a:srgbClr val="E9EEFB"/>
+                </a:solidFill>
+                <a:latin typeface="Consolas"/>
+              </a:rPr>
+              <a:t>    @</a:t>
+            </a:r>
+            <a:r>
+              <a:rPr sz="1450">
+                <a:solidFill>
+                  <a:srgbClr val="7EE0C8"/>
+                </a:solidFill>
+                <a:latin typeface="Consolas"/>
+              </a:rPr>
+              <a:t>Published</a:t>
+            </a:r>
+            <a:r>
+              <a:rPr sz="1450">
+                <a:solidFill>
                   <a:srgbClr val="FF7AB2"/>
                 </a:solidFill>
                 <a:latin typeface="Consolas"/>
               </a:rPr>
-              <a:t>    let</a:t>
+              <a:t> var</a:t>
             </a:r>
             <a:r>
               <a:rPr sz="1450">
@@ -5769,25 +5518,16 @@
                 </a:solidFill>
                 <a:latin typeface="Consolas"/>
               </a:rPr>
-              <a:t> m1, m2, m3, m4: </a:t>
+              <a:t> isCrashed = </a:t>
             </a:r>
             <a:r>
               <a:rPr sz="1450">
                 <a:solidFill>
-                  <a:srgbClr val="7EE0C8"/>
+                  <a:srgbClr val="FF7AB2"/>
                 </a:solidFill>
                 <a:latin typeface="Consolas"/>
               </a:rPr>
-              <a:t>Int</a:t>
-            </a:r>
-            <a:r>
-              <a:rPr sz="1450">
-                <a:solidFill>
-                  <a:srgbClr val="E9EEFB"/>
-                </a:solidFill>
-                <a:latin typeface="Consolas"/>
-              </a:rPr>
-              <a:t>?</a:t>
+              <a:t>false</a:t>
             </a:r>
           </a:p>
           <a:p>
@@ -5802,74 +5542,11 @@
             <a:r>
               <a:rPr sz="1450">
                 <a:solidFill>
-                  <a:srgbClr val="FF7AB2"/>
+                  <a:srgbClr val="E9EEFB"/>
                 </a:solidFill>
                 <a:latin typeface="Consolas"/>
               </a:rPr>
-              <a:t>    let</a:t>
-            </a:r>
-            <a:r>
-              <a:rPr sz="1450">
-                <a:solidFill>
-                  <a:srgbClr val="E9EEFB"/>
-                </a:solidFill>
-                <a:latin typeface="Consolas"/>
-              </a:rPr>
-              <a:t> voltage: </a:t>
-            </a:r>
-            <a:r>
-              <a:rPr sz="1450">
-                <a:solidFill>
-                  <a:srgbClr val="7EE0C8"/>
-                </a:solidFill>
-                <a:latin typeface="Consolas"/>
-              </a:rPr>
-              <a:t>Float</a:t>
-            </a:r>
-            <a:r>
-              <a:rPr sz="1450">
-                <a:solidFill>
-                  <a:srgbClr val="E9EEFB"/>
-                </a:solidFill>
-                <a:latin typeface="Consolas"/>
-              </a:rPr>
-              <a:t>?, armed: </a:t>
-            </a:r>
-            <a:r>
-              <a:rPr sz="1450">
-                <a:solidFill>
-                  <a:srgbClr val="7EE0C8"/>
-                </a:solidFill>
-                <a:latin typeface="Consolas"/>
-              </a:rPr>
-              <a:t>Bool</a:t>
-            </a:r>
-            <a:r>
-              <a:rPr sz="1450">
-                <a:solidFill>
-                  <a:srgbClr val="E9EEFB"/>
-                </a:solidFill>
-                <a:latin typeface="Consolas"/>
-              </a:rPr>
-              <a:t>?, mode: </a:t>
-            </a:r>
-            <a:r>
-              <a:rPr sz="1450">
-                <a:solidFill>
-                  <a:srgbClr val="7EE0C8"/>
-                </a:solidFill>
-                <a:latin typeface="Consolas"/>
-              </a:rPr>
-              <a:t>String</a:t>
-            </a:r>
-            <a:r>
-              <a:rPr sz="1450">
-                <a:solidFill>
-                  <a:srgbClr val="E9EEFB"/>
-                </a:solidFill>
-                <a:latin typeface="Consolas"/>
-              </a:rPr>
-              <a:t>?</a:t>
+              <a:t/>
             </a:r>
           </a:p>
           <a:p>
@@ -5884,11 +5561,11 @@
             <a:r>
               <a:rPr sz="1450">
                 <a:solidFill>
-                  <a:srgbClr val="E9EEFB"/>
+                  <a:srgbClr val="5D6B8F"/>
                 </a:solidFill>
                 <a:latin typeface="Consolas"/>
               </a:rPr>
-              <a:t>}</a:t>
+              <a:t>    // Render thread only — raw physics integration</a:t>
             </a:r>
           </a:p>
           <a:p>
@@ -5903,11 +5580,29 @@
             <a:r>
               <a:rPr sz="1450">
                 <a:solidFill>
+                  <a:srgbClr val="FF7AB2"/>
+                </a:solidFill>
+                <a:latin typeface="Consolas"/>
+              </a:rPr>
+              <a:t>    var</a:t>
+            </a:r>
+            <a:r>
+              <a:rPr sz="1450">
+                <a:solidFill>
                   <a:srgbClr val="E9EEFB"/>
                 </a:solidFill>
                 <a:latin typeface="Consolas"/>
               </a:rPr>
-              <a:t/>
+              <a:t> _roll = </a:t>
+            </a:r>
+            <a:r>
+              <a:rPr sz="1450">
+                <a:solidFill>
+                  <a:srgbClr val="F7C873"/>
+                </a:solidFill>
+                <a:latin typeface="Consolas"/>
+              </a:rPr>
+              <a:t>0.0</a:t>
             </a:r>
           </a:p>
           <a:p>
@@ -5926,25 +5621,34 @@
                 </a:solidFill>
                 <a:latin typeface="Consolas"/>
               </a:rPr>
-              <a:t>private func </a:t>
+              <a:t>    var</a:t>
             </a:r>
             <a:r>
               <a:rPr sz="1450">
                 <a:solidFill>
-                  <a:srgbClr val="82AAFF"/>
+                  <a:srgbClr val="E9EEFB"/>
                 </a:solidFill>
                 <a:latin typeface="Consolas"/>
               </a:rPr>
-              <a:t>decodeJSON</a:t>
+              <a:t> _vel: </a:t>
             </a:r>
             <a:r>
               <a:rPr sz="1450">
                 <a:solidFill>
+                  <a:srgbClr val="7EE0C8"/>
+                </a:solidFill>
+                <a:latin typeface="Consolas"/>
+              </a:rPr>
+              <a:t>SIMD3</a:t>
+            </a:r>
+            <a:r>
+              <a:rPr sz="1450">
+                <a:solidFill>
                   <a:srgbClr val="E9EEFB"/>
                 </a:solidFill>
                 <a:latin typeface="Consolas"/>
               </a:rPr>
-              <a:t>(_ text: </a:t>
+              <a:t>&lt;</a:t>
             </a:r>
             <a:r>
               <a:rPr sz="1450">
@@ -5953,7 +5657,7 @@
                 </a:solidFill>
                 <a:latin typeface="Consolas"/>
               </a:rPr>
-              <a:t>String</a:t>
+              <a:t>Float</a:t>
             </a:r>
             <a:r>
               <a:rPr sz="1450">
@@ -5962,7 +5666,7 @@
                 </a:solidFill>
                 <a:latin typeface="Consolas"/>
               </a:rPr>
-              <a:t>) {</a:t>
+              <a:t>&gt; = .zero</a:t>
             </a:r>
           </a:p>
           <a:p>
@@ -5977,92 +5681,11 @@
             <a:r>
               <a:rPr sz="1450">
                 <a:solidFill>
-                  <a:srgbClr val="FF7AB2"/>
+                  <a:srgbClr val="E9EEFB"/>
                 </a:solidFill>
                 <a:latin typeface="Consolas"/>
               </a:rPr>
-              <a:t>    let</a:t>
-            </a:r>
-            <a:r>
-              <a:rPr sz="1450">
-                <a:solidFill>
-                  <a:srgbClr val="E9EEFB"/>
-                </a:solidFill>
-                <a:latin typeface="Consolas"/>
-              </a:rPr>
-              <a:t> decoded = </a:t>
-            </a:r>
-            <a:r>
-              <a:rPr sz="1450">
-                <a:solidFill>
-                  <a:srgbClr val="FF7AB2"/>
-                </a:solidFill>
-                <a:latin typeface="Consolas"/>
-              </a:rPr>
-              <a:t>try</a:t>
-            </a:r>
-            <a:r>
-              <a:rPr sz="1450">
-                <a:solidFill>
-                  <a:srgbClr val="E9EEFB"/>
-                </a:solidFill>
-                <a:latin typeface="Consolas"/>
-              </a:rPr>
-              <a:t> </a:t>
-            </a:r>
-            <a:r>
-              <a:rPr sz="1450">
-                <a:solidFill>
-                  <a:srgbClr val="7EE0C8"/>
-                </a:solidFill>
-                <a:latin typeface="Consolas"/>
-              </a:rPr>
-              <a:t>JSONDecoder</a:t>
-            </a:r>
-            <a:r>
-              <a:rPr sz="1450">
-                <a:solidFill>
-                  <a:srgbClr val="E9EEFB"/>
-                </a:solidFill>
-                <a:latin typeface="Consolas"/>
-              </a:rPr>
-              <a:t>().</a:t>
-            </a:r>
-            <a:r>
-              <a:rPr sz="1450">
-                <a:solidFill>
-                  <a:srgbClr val="82AAFF"/>
-                </a:solidFill>
-                <a:latin typeface="Consolas"/>
-              </a:rPr>
-              <a:t>decode</a:t>
-            </a:r>
-            <a:r>
-              <a:rPr sz="1450">
-                <a:solidFill>
-                  <a:srgbClr val="E9EEFB"/>
-                </a:solidFill>
-                <a:latin typeface="Consolas"/>
-              </a:rPr>
-              <a:t>(</a:t>
-            </a:r>
-            <a:r>
-              <a:rPr sz="1450">
-                <a:solidFill>
-                  <a:srgbClr val="7EE0C8"/>
-                </a:solidFill>
-                <a:latin typeface="Consolas"/>
-              </a:rPr>
-              <a:t>DroneTelemetry</a:t>
-            </a:r>
-            <a:r>
-              <a:rPr sz="1450">
-                <a:solidFill>
-                  <a:srgbClr val="E9EEFB"/>
-                </a:solidFill>
-                <a:latin typeface="Consolas"/>
-              </a:rPr>
-              <a:t>.self, ...)</a:t>
+              <a:t/>
             </a:r>
           </a:p>
           <a:p>
@@ -6077,11 +5700,29 @@
             <a:r>
               <a:rPr sz="1450">
                 <a:solidFill>
+                  <a:srgbClr val="FF7AB2"/>
+                </a:solidFill>
+                <a:latin typeface="Consolas"/>
+              </a:rPr>
+              <a:t>    func </a:t>
+            </a:r>
+            <a:r>
+              <a:rPr sz="1450">
+                <a:solidFill>
+                  <a:srgbClr val="82AAFF"/>
+                </a:solidFill>
+                <a:latin typeface="Consolas"/>
+              </a:rPr>
+              <a:t>tick</a:t>
+            </a:r>
+            <a:r>
+              <a:rPr sz="1450">
+                <a:solidFill>
                   <a:srgbClr val="E9EEFB"/>
                 </a:solidFill>
                 <a:latin typeface="Consolas"/>
               </a:rPr>
-              <a:t>    </a:t>
+              <a:t>(dt: </a:t>
             </a:r>
             <a:r>
               <a:rPr sz="1450">
@@ -6090,7 +5731,7 @@
                 </a:solidFill>
                 <a:latin typeface="Consolas"/>
               </a:rPr>
-              <a:t>DispatchQueue</a:t>
+              <a:t>Double</a:t>
             </a:r>
             <a:r>
               <a:rPr sz="1450">
@@ -6099,16 +5740,16 @@
                 </a:solidFill>
                 <a:latin typeface="Consolas"/>
               </a:rPr>
-              <a:t>.main.</a:t>
+              <a:t>) { </a:t>
             </a:r>
             <a:r>
               <a:rPr sz="1450">
                 <a:solidFill>
-                  <a:srgbClr val="82AAFF"/>
+                  <a:srgbClr val="5D6B8F"/>
                 </a:solidFill>
                 <a:latin typeface="Consolas"/>
               </a:rPr>
-              <a:t>async</a:t>
+              <a:t>/* render thread: physics */</a:t>
             </a:r>
             <a:r>
               <a:rPr sz="1450">
@@ -6117,7 +5758,7 @@
                 </a:solidFill>
                 <a:latin typeface="Consolas"/>
               </a:rPr>
-              <a:t> {</a:t>
+              <a:t> }</a:t>
             </a:r>
           </a:p>
           <a:p>
@@ -6136,16 +5777,25 @@
                 </a:solidFill>
                 <a:latin typeface="Consolas"/>
               </a:rPr>
-              <a:t>        self</a:t>
+              <a:t>    func </a:t>
             </a:r>
             <a:r>
               <a:rPr sz="1450">
                 <a:solidFill>
+                  <a:srgbClr val="82AAFF"/>
+                </a:solidFill>
+                <a:latin typeface="Consolas"/>
+              </a:rPr>
+              <a:t>syncPublished</a:t>
+            </a:r>
+            <a:r>
+              <a:rPr sz="1450">
+                <a:solidFill>
                   <a:srgbClr val="E9EEFB"/>
                 </a:solidFill>
                 <a:latin typeface="Consolas"/>
               </a:rPr>
-              <a:t>.telemetry   = decoded   </a:t>
+              <a:t>() { </a:t>
             </a:r>
             <a:r>
               <a:rPr sz="1450">
@@ -6154,7 +5804,16 @@
                 </a:solidFill>
                 <a:latin typeface="Consolas"/>
               </a:rPr>
-              <a:t>// @Published → SwiftUI redraws</a:t>
+              <a:t>/* main: _vars → @Published */</a:t>
+            </a:r>
+            <a:r>
+              <a:rPr sz="1450">
+                <a:solidFill>
+                  <a:srgbClr val="E9EEFB"/>
+                </a:solidFill>
+                <a:latin typeface="Consolas"/>
+              </a:rPr>
+              <a:t> }</a:t>
             </a:r>
           </a:p>
           <a:p>
@@ -6169,58 +5828,11 @@
             <a:r>
               <a:rPr sz="1450">
                 <a:solidFill>
-                  <a:srgbClr val="FF7AB2"/>
+                  <a:srgbClr val="E9EEFB"/>
                 </a:solidFill>
                 <a:latin typeface="Consolas"/>
               </a:rPr>
-              <a:t>        self</a:t>
-            </a:r>
-            <a:r>
-              <a:rPr sz="1450">
-                <a:solidFill>
-                  <a:srgbClr val="E9EEFB"/>
-                </a:solidFill>
-                <a:latin typeface="Consolas"/>
-              </a:rPr>
-              <a:t>.isConnected = </a:t>
-            </a:r>
-            <a:r>
-              <a:rPr sz="1450">
-                <a:solidFill>
-                  <a:srgbClr val="FF7AB2"/>
-                </a:solidFill>
-                <a:latin typeface="Consolas"/>
-              </a:rPr>
-              <a:t>true</a:t>
-            </a:r>
-          </a:p>
-          <a:p>
-            <a:pPr>
-              <a:lnSpc>
-                <a:spcPct val="100000"/>
-              </a:lnSpc>
-              <a:spcAft>
-                <a:spcPts val="200"/>
-              </a:spcAft>
-            </a:pPr>
-            <a:r>
-              <a:rPr sz="1450">
-                <a:solidFill>
-                  <a:srgbClr val="E9EEFB"/>
-                </a:solidFill>
-                <a:latin typeface="Consolas"/>
-              </a:rPr>
-              <a:t>    }</a:t>
-            </a:r>
-            <a:r>
-              <a:rPr sz="1450">
-                <a:solidFill>
-                  <a:srgbClr val="E9EEFB"/>
-                </a:solidFill>
-                <a:latin typeface="Consolas"/>
-              </a:rPr>
-              <a:t>
-}</a:t>
+              <a:t>}</a:t>
             </a:r>
           </a:p>
         </p:txBody>
@@ -6234,1938 +5846,6 @@
 </file>
 
 <file path=ppt/slides/slide5.xml><?xml version="1.0" encoding="utf-8"?>
-<p:sld xmlns:a="http://schemas.openxmlformats.org/drawingml/2006/main" xmlns:p="http://schemas.openxmlformats.org/presentationml/2006/main" xmlns:r="http://schemas.openxmlformats.org/officeDocument/2006/relationships">
-  <p:cSld>
-    <p:spTree>
-      <p:nvGrpSpPr>
-        <p:cNvPr id="1" name=""/>
-        <p:cNvGrpSpPr/>
-        <p:nvPr/>
-      </p:nvGrpSpPr>
-      <p:grpSpPr/>
-      <p:sp>
-        <p:nvSpPr>
-          <p:cNvPr id="2" name="Rectangle 1"/>
-          <p:cNvSpPr/>
-          <p:nvPr/>
-        </p:nvSpPr>
-        <p:spPr>
-          <a:xfrm>
-            <a:off x="0" y="0"/>
-            <a:ext cx="12191695" cy="6858000"/>
-          </a:xfrm>
-          <a:prstGeom prst="rect">
-            <a:avLst/>
-          </a:prstGeom>
-          <a:solidFill>
-            <a:srgbClr val="0A0F1E"/>
-          </a:solidFill>
-          <a:ln>
-            <a:noFill/>
-          </a:ln>
-          <a:effectLst/>
-        </p:spPr>
-        <p:style>
-          <a:lnRef idx="1">
-            <a:schemeClr val="accent1"/>
-          </a:lnRef>
-          <a:fillRef idx="3">
-            <a:schemeClr val="accent1"/>
-          </a:fillRef>
-          <a:effectRef idx="2">
-            <a:schemeClr val="accent1"/>
-          </a:effectRef>
-          <a:fontRef idx="minor">
-            <a:schemeClr val="lt1"/>
-          </a:fontRef>
-        </p:style>
-        <p:txBody>
-          <a:bodyPr rtlCol="0" anchor="ctr"/>
-          <a:lstStyle/>
-          <a:p>
-            <a:pPr algn="ctr"/>
-          </a:p>
-        </p:txBody>
-      </p:sp>
-      <p:sp>
-        <p:nvSpPr>
-          <p:cNvPr id="3" name="TextBox 2"/>
-          <p:cNvSpPr txBox="1"/>
-          <p:nvPr/>
-        </p:nvSpPr>
-        <p:spPr>
-          <a:xfrm>
-            <a:off x="777240" y="502920"/>
-            <a:ext cx="10058400" cy="457200"/>
-          </a:xfrm>
-          <a:prstGeom prst="rect">
-            <a:avLst/>
-          </a:prstGeom>
-          <a:noFill/>
-        </p:spPr>
-        <p:txBody>
-          <a:bodyPr wrap="square" anchor="t" lIns="0" rIns="0" tIns="0" bIns="0">
-            <a:spAutoFit/>
-          </a:bodyPr>
-          <a:lstStyle/>
-          <a:p>
-            <a:pPr algn="l">
-              <a:spcBef>
-                <a:spcPts val="0"/>
-              </a:spcBef>
-              <a:spcAft>
-                <a:spcPts val="600"/>
-              </a:spcAft>
-            </a:pPr>
-            <a:r>
-              <a:rPr sz="1500" b="1">
-                <a:solidFill>
-                  <a:srgbClr val="2979FF"/>
-                </a:solidFill>
-                <a:latin typeface="Helvetica Neue"/>
-              </a:rPr>
-              <a:t>CODE · SENSORS &amp; COMMANDS</a:t>
-            </a:r>
-          </a:p>
-        </p:txBody>
-      </p:sp>
-      <p:sp>
-        <p:nvSpPr>
-          <p:cNvPr id="4" name="TextBox 3"/>
-          <p:cNvSpPr txBox="1"/>
-          <p:nvPr/>
-        </p:nvSpPr>
-        <p:spPr>
-          <a:xfrm>
-            <a:off x="777240" y="868680"/>
-            <a:ext cx="10607040" cy="1005840"/>
-          </a:xfrm>
-          <a:prstGeom prst="rect">
-            <a:avLst/>
-          </a:prstGeom>
-          <a:noFill/>
-        </p:spPr>
-        <p:txBody>
-          <a:bodyPr wrap="square" anchor="t" lIns="0" rIns="0" tIns="0" bIns="0">
-            <a:spAutoFit/>
-          </a:bodyPr>
-          <a:lstStyle/>
-          <a:p>
-            <a:pPr algn="l">
-              <a:spcBef>
-                <a:spcPts val="0"/>
-              </a:spcBef>
-              <a:spcAft>
-                <a:spcPts val="600"/>
-              </a:spcAft>
-            </a:pPr>
-            <a:r>
-              <a:rPr sz="4000" b="1">
-                <a:solidFill>
-                  <a:srgbClr val="E9EEFB"/>
-                </a:solidFill>
-                <a:latin typeface="Helvetica Neue"/>
-              </a:rPr>
-              <a:t>Phone tilt → drone command</a:t>
-            </a:r>
-          </a:p>
-        </p:txBody>
-      </p:sp>
-      <p:sp>
-        <p:nvSpPr>
-          <p:cNvPr id="5" name="Rounded Rectangle 4"/>
-          <p:cNvSpPr/>
-          <p:nvPr/>
-        </p:nvSpPr>
-        <p:spPr>
-          <a:xfrm>
-            <a:off x="777240" y="1828800"/>
-            <a:ext cx="10607040" cy="3931920"/>
-          </a:xfrm>
-          <a:prstGeom prst="roundRect">
-            <a:avLst>
-              <a:gd name="adj" fmla="val 3000"/>
-            </a:avLst>
-          </a:prstGeom>
-          <a:solidFill>
-            <a:srgbClr val="0C1326"/>
-          </a:solidFill>
-          <a:ln w="12700">
-            <a:solidFill>
-              <a:srgbClr val="2979FF"/>
-            </a:solidFill>
-          </a:ln>
-          <a:effectLst/>
-        </p:spPr>
-        <p:style>
-          <a:lnRef idx="1">
-            <a:schemeClr val="accent1"/>
-          </a:lnRef>
-          <a:fillRef idx="3">
-            <a:schemeClr val="accent1"/>
-          </a:fillRef>
-          <a:effectRef idx="2">
-            <a:schemeClr val="accent1"/>
-          </a:effectRef>
-          <a:fontRef idx="minor">
-            <a:schemeClr val="lt1"/>
-          </a:fontRef>
-        </p:style>
-        <p:txBody>
-          <a:bodyPr rtlCol="0" anchor="ctr" wrap="square" lIns="320040" tIns="228600" rIns="182880"/>
-          <a:lstStyle/>
-          <a:p>
-            <a:pPr algn="ctr">
-              <a:lnSpc>
-                <a:spcPct val="100000"/>
-              </a:lnSpc>
-              <a:spcAft>
-                <a:spcPts val="200"/>
-              </a:spcAft>
-            </a:pPr>
-            <a:r>
-              <a:rPr sz="1450">
-                <a:solidFill>
-                  <a:srgbClr val="5D6B8F"/>
-                </a:solidFill>
-                <a:latin typeface="Consolas"/>
-              </a:rPr>
-              <a:t>// CoreMotion device-motion updates @ 10 Hz</a:t>
-            </a:r>
-          </a:p>
-          <a:p>
-            <a:pPr>
-              <a:lnSpc>
-                <a:spcPct val="100000"/>
-              </a:lnSpc>
-              <a:spcAft>
-                <a:spcPts val="200"/>
-              </a:spcAft>
-            </a:pPr>
-            <a:r>
-              <a:rPr sz="1450">
-                <a:solidFill>
-                  <a:srgbClr val="E9EEFB"/>
-                </a:solidFill>
-                <a:latin typeface="Consolas"/>
-              </a:rPr>
-              <a:t>motionManager.</a:t>
-            </a:r>
-            <a:r>
-              <a:rPr sz="1450">
-                <a:solidFill>
-                  <a:srgbClr val="82AAFF"/>
-                </a:solidFill>
-                <a:latin typeface="Consolas"/>
-              </a:rPr>
-              <a:t>startDeviceMotionUpdates</a:t>
-            </a:r>
-            <a:r>
-              <a:rPr sz="1450">
-                <a:solidFill>
-                  <a:srgbClr val="E9EEFB"/>
-                </a:solidFill>
-                <a:latin typeface="Consolas"/>
-              </a:rPr>
-              <a:t>(to: .main) { data, _ </a:t>
-            </a:r>
-            <a:r>
-              <a:rPr sz="1450">
-                <a:solidFill>
-                  <a:srgbClr val="FF7AB2"/>
-                </a:solidFill>
-                <a:latin typeface="Consolas"/>
-              </a:rPr>
-              <a:t>in</a:t>
-            </a:r>
-          </a:p>
-          <a:p>
-            <a:pPr>
-              <a:lnSpc>
-                <a:spcPct val="100000"/>
-              </a:lnSpc>
-              <a:spcAft>
-                <a:spcPts val="200"/>
-              </a:spcAft>
-            </a:pPr>
-            <a:r>
-              <a:rPr sz="1450">
-                <a:solidFill>
-                  <a:srgbClr val="FF7AB2"/>
-                </a:solidFill>
-                <a:latin typeface="Consolas"/>
-              </a:rPr>
-              <a:t>    let</a:t>
-            </a:r>
-            <a:r>
-              <a:rPr sz="1450">
-                <a:solidFill>
-                  <a:srgbClr val="E9EEFB"/>
-                </a:solidFill>
-                <a:latin typeface="Consolas"/>
-              </a:rPr>
-              <a:t> r = </a:t>
-            </a:r>
-            <a:r>
-              <a:rPr sz="1450">
-                <a:solidFill>
-                  <a:srgbClr val="F7C873"/>
-                </a:solidFill>
-                <a:latin typeface="Consolas"/>
-              </a:rPr>
-              <a:t>180</a:t>
-            </a:r>
-            <a:r>
-              <a:rPr sz="1450">
-                <a:solidFill>
-                  <a:srgbClr val="E9EEFB"/>
-                </a:solidFill>
-                <a:latin typeface="Consolas"/>
-              </a:rPr>
-              <a:t> / .pi</a:t>
-            </a:r>
-          </a:p>
-          <a:p>
-            <a:pPr>
-              <a:lnSpc>
-                <a:spcPct val="100000"/>
-              </a:lnSpc>
-              <a:spcAft>
-                <a:spcPts val="200"/>
-              </a:spcAft>
-            </a:pPr>
-            <a:r>
-              <a:rPr sz="1450">
-                <a:solidFill>
-                  <a:srgbClr val="FF7AB2"/>
-                </a:solidFill>
-                <a:latin typeface="Consolas"/>
-              </a:rPr>
-              <a:t>    self</a:t>
-            </a:r>
-            <a:r>
-              <a:rPr sz="1450">
-                <a:solidFill>
-                  <a:srgbClr val="E9EEFB"/>
-                </a:solidFill>
-                <a:latin typeface="Consolas"/>
-              </a:rPr>
-              <a:t>.pitch = data.attitude.pitch * r</a:t>
-            </a:r>
-          </a:p>
-          <a:p>
-            <a:pPr>
-              <a:lnSpc>
-                <a:spcPct val="100000"/>
-              </a:lnSpc>
-              <a:spcAft>
-                <a:spcPts val="200"/>
-              </a:spcAft>
-            </a:pPr>
-            <a:r>
-              <a:rPr sz="1450">
-                <a:solidFill>
-                  <a:srgbClr val="FF7AB2"/>
-                </a:solidFill>
-                <a:latin typeface="Consolas"/>
-              </a:rPr>
-              <a:t>    self</a:t>
-            </a:r>
-            <a:r>
-              <a:rPr sz="1450">
-                <a:solidFill>
-                  <a:srgbClr val="E9EEFB"/>
-                </a:solidFill>
-                <a:latin typeface="Consolas"/>
-              </a:rPr>
-              <a:t>.roll  = data.attitude.roll  * r</a:t>
-            </a:r>
-          </a:p>
-          <a:p>
-            <a:pPr>
-              <a:lnSpc>
-                <a:spcPct val="100000"/>
-              </a:lnSpc>
-              <a:spcAft>
-                <a:spcPts val="200"/>
-              </a:spcAft>
-            </a:pPr>
-            <a:r>
-              <a:rPr sz="1450">
-                <a:solidFill>
-                  <a:srgbClr val="E9EEFB"/>
-                </a:solidFill>
-                <a:latin typeface="Consolas"/>
-              </a:rPr>
-              <a:t>}</a:t>
-            </a:r>
-          </a:p>
-          <a:p>
-            <a:pPr>
-              <a:lnSpc>
-                <a:spcPct val="100000"/>
-              </a:lnSpc>
-              <a:spcAft>
-                <a:spcPts val="200"/>
-              </a:spcAft>
-            </a:pPr>
-            <a:r>
-              <a:rPr sz="1450">
-                <a:solidFill>
-                  <a:srgbClr val="E9EEFB"/>
-                </a:solidFill>
-                <a:latin typeface="Consolas"/>
-              </a:rPr>
-              <a:t/>
-            </a:r>
-          </a:p>
-          <a:p>
-            <a:pPr>
-              <a:lnSpc>
-                <a:spcPct val="100000"/>
-              </a:lnSpc>
-              <a:spcAft>
-                <a:spcPts val="200"/>
-              </a:spcAft>
-            </a:pPr>
-            <a:r>
-              <a:rPr sz="1450">
-                <a:solidFill>
-                  <a:srgbClr val="5D6B8F"/>
-                </a:solidFill>
-                <a:latin typeface="Consolas"/>
-              </a:rPr>
-              <a:t>// Type-safe JSON command builder (ControlProfile)</a:t>
-            </a:r>
-          </a:p>
-          <a:p>
-            <a:pPr>
-              <a:lnSpc>
-                <a:spcPct val="100000"/>
-              </a:lnSpc>
-              <a:spcAft>
-                <a:spcPts val="200"/>
-              </a:spcAft>
-            </a:pPr>
-            <a:r>
-              <a:rPr sz="1450">
-                <a:solidFill>
-                  <a:srgbClr val="FF7AB2"/>
-                </a:solidFill>
-                <a:latin typeface="Consolas"/>
-              </a:rPr>
-              <a:t>func </a:t>
-            </a:r>
-            <a:r>
-              <a:rPr sz="1450">
-                <a:solidFill>
-                  <a:srgbClr val="82AAFF"/>
-                </a:solidFill>
-                <a:latin typeface="Consolas"/>
-              </a:rPr>
-              <a:t>startBalanceCommand</a:t>
-            </a:r>
-            <a:r>
-              <a:rPr sz="1450">
-                <a:solidFill>
-                  <a:srgbClr val="E9EEFB"/>
-                </a:solidFill>
-                <a:latin typeface="Consolas"/>
-              </a:rPr>
-              <a:t>() -&gt; </a:t>
-            </a:r>
-            <a:r>
-              <a:rPr sz="1450">
-                <a:solidFill>
-                  <a:srgbClr val="7EE0C8"/>
-                </a:solidFill>
-                <a:latin typeface="Consolas"/>
-              </a:rPr>
-              <a:t>String</a:t>
-            </a:r>
-            <a:r>
-              <a:rPr sz="1450">
-                <a:solidFill>
-                  <a:srgbClr val="E9EEFB"/>
-                </a:solidFill>
-                <a:latin typeface="Consolas"/>
-              </a:rPr>
-              <a:t> {</a:t>
-            </a:r>
-          </a:p>
-          <a:p>
-            <a:pPr>
-              <a:lnSpc>
-                <a:spcPct val="100000"/>
-              </a:lnSpc>
-              <a:spcAft>
-                <a:spcPts val="200"/>
-              </a:spcAft>
-            </a:pPr>
-            <a:r>
-              <a:rPr sz="1450">
-                <a:solidFill>
-                  <a:srgbClr val="E9EEFB"/>
-                </a:solidFill>
-                <a:latin typeface="Consolas"/>
-              </a:rPr>
-              <a:t>    </a:t>
-            </a:r>
-            <a:r>
-              <a:rPr sz="1450">
-                <a:solidFill>
-                  <a:srgbClr val="C3E88D"/>
-                </a:solidFill>
-                <a:latin typeface="Consolas"/>
-              </a:rPr>
-              <a:t>"""{"cmd":"START_BALANCE","baseThrottle":\(baseThrottle),</a:t>
-            </a:r>
-          </a:p>
-          <a:p>
-            <a:pPr>
-              <a:lnSpc>
-                <a:spcPct val="100000"/>
-              </a:lnSpc>
-              <a:spcAft>
-                <a:spcPts val="200"/>
-              </a:spcAft>
-            </a:pPr>
-            <a:r>
-              <a:rPr sz="1450">
-                <a:solidFill>
-                  <a:srgbClr val="C3E88D"/>
-                </a:solidFill>
-                <a:latin typeface="Consolas"/>
-              </a:rPr>
-              <a:t>       "kPRoll":\(kPRoll),"kPPitch":\(kPPitch)}"""</a:t>
-            </a:r>
-          </a:p>
-          <a:p>
-            <a:pPr>
-              <a:lnSpc>
-                <a:spcPct val="100000"/>
-              </a:lnSpc>
-              <a:spcAft>
-                <a:spcPts val="200"/>
-              </a:spcAft>
-            </a:pPr>
-            <a:r>
-              <a:rPr sz="1450">
-                <a:solidFill>
-                  <a:srgbClr val="E9EEFB"/>
-                </a:solidFill>
-                <a:latin typeface="Consolas"/>
-              </a:rPr>
-              <a:t>}</a:t>
-            </a:r>
-          </a:p>
-        </p:txBody>
-      </p:sp>
-    </p:spTree>
-  </p:cSld>
-  <p:clrMapOvr>
-    <a:masterClrMapping/>
-  </p:clrMapOvr>
-</p:sld>
-</file>
-
-<file path=ppt/slides/slide6.xml><?xml version="1.0" encoding="utf-8"?>
-<p:sld xmlns:a="http://schemas.openxmlformats.org/drawingml/2006/main" xmlns:p="http://schemas.openxmlformats.org/presentationml/2006/main" xmlns:r="http://schemas.openxmlformats.org/officeDocument/2006/relationships">
-  <p:cSld>
-    <p:spTree>
-      <p:nvGrpSpPr>
-        <p:cNvPr id="1" name=""/>
-        <p:cNvGrpSpPr/>
-        <p:nvPr/>
-      </p:nvGrpSpPr>
-      <p:grpSpPr/>
-      <p:sp>
-        <p:nvSpPr>
-          <p:cNvPr id="2" name="Rectangle 1"/>
-          <p:cNvSpPr/>
-          <p:nvPr/>
-        </p:nvSpPr>
-        <p:spPr>
-          <a:xfrm>
-            <a:off x="0" y="0"/>
-            <a:ext cx="12191695" cy="6858000"/>
-          </a:xfrm>
-          <a:prstGeom prst="rect">
-            <a:avLst/>
-          </a:prstGeom>
-          <a:solidFill>
-            <a:srgbClr val="0A0F1E"/>
-          </a:solidFill>
-          <a:ln>
-            <a:noFill/>
-          </a:ln>
-          <a:effectLst/>
-        </p:spPr>
-        <p:style>
-          <a:lnRef idx="1">
-            <a:schemeClr val="accent1"/>
-          </a:lnRef>
-          <a:fillRef idx="3">
-            <a:schemeClr val="accent1"/>
-          </a:fillRef>
-          <a:effectRef idx="2">
-            <a:schemeClr val="accent1"/>
-          </a:effectRef>
-          <a:fontRef idx="minor">
-            <a:schemeClr val="lt1"/>
-          </a:fontRef>
-        </p:style>
-        <p:txBody>
-          <a:bodyPr rtlCol="0" anchor="ctr"/>
-          <a:lstStyle/>
-          <a:p>
-            <a:pPr algn="ctr"/>
-          </a:p>
-        </p:txBody>
-      </p:sp>
-      <p:sp>
-        <p:nvSpPr>
-          <p:cNvPr id="3" name="TextBox 2"/>
-          <p:cNvSpPr txBox="1"/>
-          <p:nvPr/>
-        </p:nvSpPr>
-        <p:spPr>
-          <a:xfrm>
-            <a:off x="777240" y="502920"/>
-            <a:ext cx="10058400" cy="457200"/>
-          </a:xfrm>
-          <a:prstGeom prst="rect">
-            <a:avLst/>
-          </a:prstGeom>
-          <a:noFill/>
-        </p:spPr>
-        <p:txBody>
-          <a:bodyPr wrap="square" anchor="t" lIns="0" rIns="0" tIns="0" bIns="0">
-            <a:spAutoFit/>
-          </a:bodyPr>
-          <a:lstStyle/>
-          <a:p>
-            <a:pPr algn="l">
-              <a:spcBef>
-                <a:spcPts val="0"/>
-              </a:spcBef>
-              <a:spcAft>
-                <a:spcPts val="600"/>
-              </a:spcAft>
-            </a:pPr>
-            <a:r>
-              <a:rPr sz="1500" b="1">
-                <a:solidFill>
-                  <a:srgbClr val="2979FF"/>
-                </a:solidFill>
-                <a:latin typeface="Helvetica Neue"/>
-              </a:rPr>
-              <a:t>CHALLENGES</a:t>
-            </a:r>
-          </a:p>
-        </p:txBody>
-      </p:sp>
-      <p:sp>
-        <p:nvSpPr>
-          <p:cNvPr id="4" name="TextBox 3"/>
-          <p:cNvSpPr txBox="1"/>
-          <p:nvPr/>
-        </p:nvSpPr>
-        <p:spPr>
-          <a:xfrm>
-            <a:off x="777240" y="868680"/>
-            <a:ext cx="10607040" cy="1005840"/>
-          </a:xfrm>
-          <a:prstGeom prst="rect">
-            <a:avLst/>
-          </a:prstGeom>
-          <a:noFill/>
-        </p:spPr>
-        <p:txBody>
-          <a:bodyPr wrap="square" anchor="t" lIns="0" rIns="0" tIns="0" bIns="0">
-            <a:spAutoFit/>
-          </a:bodyPr>
-          <a:lstStyle/>
-          <a:p>
-            <a:pPr algn="l">
-              <a:spcBef>
-                <a:spcPts val="0"/>
-              </a:spcBef>
-              <a:spcAft>
-                <a:spcPts val="600"/>
-              </a:spcAft>
-            </a:pPr>
-            <a:r>
-              <a:rPr sz="4000" b="1">
-                <a:solidFill>
-                  <a:srgbClr val="E9EEFB"/>
-                </a:solidFill>
-                <a:latin typeface="Helvetica Neue"/>
-              </a:rPr>
-              <a:t>What was hard — and how we solved it</a:t>
-            </a:r>
-          </a:p>
-        </p:txBody>
-      </p:sp>
-      <p:sp>
-        <p:nvSpPr>
-          <p:cNvPr id="5" name="Rounded Rectangle 4"/>
-          <p:cNvSpPr/>
-          <p:nvPr/>
-        </p:nvSpPr>
-        <p:spPr>
-          <a:xfrm>
-            <a:off x="777240" y="1828800"/>
-            <a:ext cx="5349240" cy="1874519"/>
-          </a:xfrm>
-          <a:prstGeom prst="roundRect">
-            <a:avLst>
-              <a:gd name="adj" fmla="val 6000"/>
-            </a:avLst>
-          </a:prstGeom>
-          <a:solidFill>
-            <a:srgbClr val="141C33"/>
-          </a:solidFill>
-          <a:ln w="15875">
-            <a:solidFill>
-              <a:srgbClr val="33D980"/>
-            </a:solidFill>
-          </a:ln>
-          <a:effectLst/>
-        </p:spPr>
-        <p:style>
-          <a:lnRef idx="1">
-            <a:schemeClr val="accent1"/>
-          </a:lnRef>
-          <a:fillRef idx="3">
-            <a:schemeClr val="accent1"/>
-          </a:fillRef>
-          <a:effectRef idx="2">
-            <a:schemeClr val="accent1"/>
-          </a:effectRef>
-          <a:fontRef idx="minor">
-            <a:schemeClr val="lt1"/>
-          </a:fontRef>
-        </p:style>
-        <p:txBody>
-          <a:bodyPr rtlCol="0" anchor="ctr"/>
-          <a:lstStyle/>
-          <a:p>
-            <a:pPr algn="ctr"/>
-          </a:p>
-        </p:txBody>
-      </p:sp>
-      <p:sp>
-        <p:nvSpPr>
-          <p:cNvPr id="6" name="TextBox 5"/>
-          <p:cNvSpPr txBox="1"/>
-          <p:nvPr/>
-        </p:nvSpPr>
-        <p:spPr>
-          <a:xfrm>
-            <a:off x="1097280" y="2103120"/>
-            <a:ext cx="4800600" cy="548640"/>
-          </a:xfrm>
-          <a:prstGeom prst="rect">
-            <a:avLst/>
-          </a:prstGeom>
-          <a:noFill/>
-        </p:spPr>
-        <p:txBody>
-          <a:bodyPr wrap="square" anchor="t" lIns="0" rIns="0" tIns="0" bIns="0">
-            <a:spAutoFit/>
-          </a:bodyPr>
-          <a:lstStyle/>
-          <a:p>
-            <a:pPr algn="l">
-              <a:spcBef>
-                <a:spcPts val="0"/>
-              </a:spcBef>
-              <a:spcAft>
-                <a:spcPts val="600"/>
-              </a:spcAft>
-            </a:pPr>
-            <a:r>
-              <a:rPr sz="2100" b="1">
-                <a:solidFill>
-                  <a:srgbClr val="33D980"/>
-                </a:solidFill>
-                <a:latin typeface="Helvetica Neue"/>
-              </a:rPr>
-              <a:t>Finding the drone</a:t>
-            </a:r>
-          </a:p>
-        </p:txBody>
-      </p:sp>
-      <p:sp>
-        <p:nvSpPr>
-          <p:cNvPr id="7" name="TextBox 6"/>
-          <p:cNvSpPr txBox="1"/>
-          <p:nvPr/>
-        </p:nvSpPr>
-        <p:spPr>
-          <a:xfrm>
-            <a:off x="1097280" y="2697480"/>
-            <a:ext cx="4709160" cy="914400"/>
-          </a:xfrm>
-          <a:prstGeom prst="rect">
-            <a:avLst/>
-          </a:prstGeom>
-          <a:noFill/>
-        </p:spPr>
-        <p:txBody>
-          <a:bodyPr wrap="square" anchor="t" lIns="0" rIns="0" tIns="0" bIns="0">
-            <a:spAutoFit/>
-          </a:bodyPr>
-          <a:lstStyle/>
-          <a:p>
-            <a:pPr algn="l">
-              <a:spcBef>
-                <a:spcPts val="0"/>
-              </a:spcBef>
-              <a:spcAft>
-                <a:spcPts val="0"/>
-              </a:spcAft>
-            </a:pPr>
-            <a:r>
-              <a:rPr sz="1450" b="0">
-                <a:solidFill>
-                  <a:srgbClr val="8A97B8"/>
-                </a:solidFill>
-                <a:latin typeface="Helvetica Neue"/>
-              </a:rPr>
-              <a:t>The ESP32 gets a random DHCP IP. A UDP beacon broadcasts the IP every 5 s, so the app auto-connects — no typing.</a:t>
-            </a:r>
-          </a:p>
-        </p:txBody>
-      </p:sp>
-      <p:sp>
-        <p:nvSpPr>
-          <p:cNvPr id="8" name="Rounded Rectangle 7"/>
-          <p:cNvSpPr/>
-          <p:nvPr/>
-        </p:nvSpPr>
-        <p:spPr>
-          <a:xfrm>
-            <a:off x="6400800" y="1828800"/>
-            <a:ext cx="5349240" cy="1874519"/>
-          </a:xfrm>
-          <a:prstGeom prst="roundRect">
-            <a:avLst>
-              <a:gd name="adj" fmla="val 6000"/>
-            </a:avLst>
-          </a:prstGeom>
-          <a:solidFill>
-            <a:srgbClr val="141C33"/>
-          </a:solidFill>
-          <a:ln w="15875">
-            <a:solidFill>
-              <a:srgbClr val="2979FF"/>
-            </a:solidFill>
-          </a:ln>
-          <a:effectLst/>
-        </p:spPr>
-        <p:style>
-          <a:lnRef idx="1">
-            <a:schemeClr val="accent1"/>
-          </a:lnRef>
-          <a:fillRef idx="3">
-            <a:schemeClr val="accent1"/>
-          </a:fillRef>
-          <a:effectRef idx="2">
-            <a:schemeClr val="accent1"/>
-          </a:effectRef>
-          <a:fontRef idx="minor">
-            <a:schemeClr val="lt1"/>
-          </a:fontRef>
-        </p:style>
-        <p:txBody>
-          <a:bodyPr rtlCol="0" anchor="ctr"/>
-          <a:lstStyle/>
-          <a:p>
-            <a:pPr algn="ctr"/>
-          </a:p>
-        </p:txBody>
-      </p:sp>
-      <p:sp>
-        <p:nvSpPr>
-          <p:cNvPr id="9" name="TextBox 8"/>
-          <p:cNvSpPr txBox="1"/>
-          <p:nvPr/>
-        </p:nvSpPr>
-        <p:spPr>
-          <a:xfrm>
-            <a:off x="6720840" y="2103120"/>
-            <a:ext cx="4800600" cy="548640"/>
-          </a:xfrm>
-          <a:prstGeom prst="rect">
-            <a:avLst/>
-          </a:prstGeom>
-          <a:noFill/>
-        </p:spPr>
-        <p:txBody>
-          <a:bodyPr wrap="square" anchor="t" lIns="0" rIns="0" tIns="0" bIns="0">
-            <a:spAutoFit/>
-          </a:bodyPr>
-          <a:lstStyle/>
-          <a:p>
-            <a:pPr algn="l">
-              <a:spcBef>
-                <a:spcPts val="0"/>
-              </a:spcBef>
-              <a:spcAft>
-                <a:spcPts val="600"/>
-              </a:spcAft>
-            </a:pPr>
-            <a:r>
-              <a:rPr sz="2100" b="1">
-                <a:solidFill>
-                  <a:srgbClr val="2979FF"/>
-                </a:solidFill>
-                <a:latin typeface="Helvetica Neue"/>
-              </a:rPr>
-              <a:t>Detecting a dropped link</a:t>
-            </a:r>
-          </a:p>
-        </p:txBody>
-      </p:sp>
-      <p:sp>
-        <p:nvSpPr>
-          <p:cNvPr id="10" name="TextBox 9"/>
-          <p:cNvSpPr txBox="1"/>
-          <p:nvPr/>
-        </p:nvSpPr>
-        <p:spPr>
-          <a:xfrm>
-            <a:off x="6720840" y="2697480"/>
-            <a:ext cx="4709160" cy="914400"/>
-          </a:xfrm>
-          <a:prstGeom prst="rect">
-            <a:avLst/>
-          </a:prstGeom>
-          <a:noFill/>
-        </p:spPr>
-        <p:txBody>
-          <a:bodyPr wrap="square" anchor="t" lIns="0" rIns="0" tIns="0" bIns="0">
-            <a:spAutoFit/>
-          </a:bodyPr>
-          <a:lstStyle/>
-          <a:p>
-            <a:pPr algn="l">
-              <a:spcBef>
-                <a:spcPts val="0"/>
-              </a:spcBef>
-              <a:spcAft>
-                <a:spcPts val="0"/>
-              </a:spcAft>
-            </a:pPr>
-            <a:r>
-              <a:rPr sz="1450" b="0">
-                <a:solidFill>
-                  <a:srgbClr val="8A97B8"/>
-                </a:solidFill>
-                <a:latin typeface="Helvetica Neue"/>
-              </a:rPr>
-              <a:t>WiFi can die silently. A 3 s timeout timer + 5 s WebSocket pings flip isConnected false the instant data stops.</a:t>
-            </a:r>
-          </a:p>
-        </p:txBody>
-      </p:sp>
-      <p:sp>
-        <p:nvSpPr>
-          <p:cNvPr id="11" name="Rounded Rectangle 10"/>
-          <p:cNvSpPr/>
-          <p:nvPr/>
-        </p:nvSpPr>
-        <p:spPr>
-          <a:xfrm>
-            <a:off x="777240" y="3977639"/>
-            <a:ext cx="5349240" cy="1874519"/>
-          </a:xfrm>
-          <a:prstGeom prst="roundRect">
-            <a:avLst>
-              <a:gd name="adj" fmla="val 6000"/>
-            </a:avLst>
-          </a:prstGeom>
-          <a:solidFill>
-            <a:srgbClr val="141C33"/>
-          </a:solidFill>
-          <a:ln w="15875">
-            <a:solidFill>
-              <a:srgbClr val="FF9900"/>
-            </a:solidFill>
-          </a:ln>
-          <a:effectLst/>
-        </p:spPr>
-        <p:style>
-          <a:lnRef idx="1">
-            <a:schemeClr val="accent1"/>
-          </a:lnRef>
-          <a:fillRef idx="3">
-            <a:schemeClr val="accent1"/>
-          </a:fillRef>
-          <a:effectRef idx="2">
-            <a:schemeClr val="accent1"/>
-          </a:effectRef>
-          <a:fontRef idx="minor">
-            <a:schemeClr val="lt1"/>
-          </a:fontRef>
-        </p:style>
-        <p:txBody>
-          <a:bodyPr rtlCol="0" anchor="ctr"/>
-          <a:lstStyle/>
-          <a:p>
-            <a:pPr algn="ctr"/>
-          </a:p>
-        </p:txBody>
-      </p:sp>
-      <p:sp>
-        <p:nvSpPr>
-          <p:cNvPr id="12" name="TextBox 11"/>
-          <p:cNvSpPr txBox="1"/>
-          <p:nvPr/>
-        </p:nvSpPr>
-        <p:spPr>
-          <a:xfrm>
-            <a:off x="1097280" y="4251959"/>
-            <a:ext cx="4800600" cy="548640"/>
-          </a:xfrm>
-          <a:prstGeom prst="rect">
-            <a:avLst/>
-          </a:prstGeom>
-          <a:noFill/>
-        </p:spPr>
-        <p:txBody>
-          <a:bodyPr wrap="square" anchor="t" lIns="0" rIns="0" tIns="0" bIns="0">
-            <a:spAutoFit/>
-          </a:bodyPr>
-          <a:lstStyle/>
-          <a:p>
-            <a:pPr algn="l">
-              <a:spcBef>
-                <a:spcPts val="0"/>
-              </a:spcBef>
-              <a:spcAft>
-                <a:spcPts val="600"/>
-              </a:spcAft>
-            </a:pPr>
-            <a:r>
-              <a:rPr sz="2100" b="1">
-                <a:solidFill>
-                  <a:srgbClr val="FF9900"/>
-                </a:solidFill>
-                <a:latin typeface="Helvetica Neue"/>
-              </a:rPr>
-              <a:t>Thread safety</a:t>
-            </a:r>
-          </a:p>
-        </p:txBody>
-      </p:sp>
-      <p:sp>
-        <p:nvSpPr>
-          <p:cNvPr id="13" name="TextBox 12"/>
-          <p:cNvSpPr txBox="1"/>
-          <p:nvPr/>
-        </p:nvSpPr>
-        <p:spPr>
-          <a:xfrm>
-            <a:off x="1097280" y="4846319"/>
-            <a:ext cx="4709160" cy="914400"/>
-          </a:xfrm>
-          <a:prstGeom prst="rect">
-            <a:avLst/>
-          </a:prstGeom>
-          <a:noFill/>
-        </p:spPr>
-        <p:txBody>
-          <a:bodyPr wrap="square" anchor="t" lIns="0" rIns="0" tIns="0" bIns="0">
-            <a:spAutoFit/>
-          </a:bodyPr>
-          <a:lstStyle/>
-          <a:p>
-            <a:pPr algn="l">
-              <a:spcBef>
-                <a:spcPts val="0"/>
-              </a:spcBef>
-              <a:spcAft>
-                <a:spcPts val="0"/>
-              </a:spcAft>
-            </a:pPr>
-            <a:r>
-              <a:rPr sz="1450" b="0">
-                <a:solidFill>
-                  <a:srgbClr val="8A97B8"/>
-                </a:solidFill>
-                <a:latin typeface="Helvetica Neue"/>
-              </a:rPr>
-              <a:t>SceneKit physics runs on the render thread, SwiftUI only on main. Physics writes _vars, synced to @Published at 20 Hz.</a:t>
-            </a:r>
-          </a:p>
-        </p:txBody>
-      </p:sp>
-      <p:sp>
-        <p:nvSpPr>
-          <p:cNvPr id="14" name="Rounded Rectangle 13"/>
-          <p:cNvSpPr/>
-          <p:nvPr/>
-        </p:nvSpPr>
-        <p:spPr>
-          <a:xfrm>
-            <a:off x="6400800" y="3977639"/>
-            <a:ext cx="5349240" cy="1874519"/>
-          </a:xfrm>
-          <a:prstGeom prst="roundRect">
-            <a:avLst>
-              <a:gd name="adj" fmla="val 6000"/>
-            </a:avLst>
-          </a:prstGeom>
-          <a:solidFill>
-            <a:srgbClr val="141C33"/>
-          </a:solidFill>
-          <a:ln w="15875">
-            <a:solidFill>
-              <a:srgbClr val="FF4545"/>
-            </a:solidFill>
-          </a:ln>
-          <a:effectLst/>
-        </p:spPr>
-        <p:style>
-          <a:lnRef idx="1">
-            <a:schemeClr val="accent1"/>
-          </a:lnRef>
-          <a:fillRef idx="3">
-            <a:schemeClr val="accent1"/>
-          </a:fillRef>
-          <a:effectRef idx="2">
-            <a:schemeClr val="accent1"/>
-          </a:effectRef>
-          <a:fontRef idx="minor">
-            <a:schemeClr val="lt1"/>
-          </a:fontRef>
-        </p:style>
-        <p:txBody>
-          <a:bodyPr rtlCol="0" anchor="ctr"/>
-          <a:lstStyle/>
-          <a:p>
-            <a:pPr algn="ctr"/>
-          </a:p>
-        </p:txBody>
-      </p:sp>
-      <p:sp>
-        <p:nvSpPr>
-          <p:cNvPr id="15" name="TextBox 14"/>
-          <p:cNvSpPr txBox="1"/>
-          <p:nvPr/>
-        </p:nvSpPr>
-        <p:spPr>
-          <a:xfrm>
-            <a:off x="6720840" y="4251959"/>
-            <a:ext cx="4800600" cy="548640"/>
-          </a:xfrm>
-          <a:prstGeom prst="rect">
-            <a:avLst/>
-          </a:prstGeom>
-          <a:noFill/>
-        </p:spPr>
-        <p:txBody>
-          <a:bodyPr wrap="square" anchor="t" lIns="0" rIns="0" tIns="0" bIns="0">
-            <a:spAutoFit/>
-          </a:bodyPr>
-          <a:lstStyle/>
-          <a:p>
-            <a:pPr algn="l">
-              <a:spcBef>
-                <a:spcPts val="0"/>
-              </a:spcBef>
-              <a:spcAft>
-                <a:spcPts val="600"/>
-              </a:spcAft>
-            </a:pPr>
-            <a:r>
-              <a:rPr sz="2100" b="1">
-                <a:solidFill>
-                  <a:srgbClr val="FF4545"/>
-                </a:solidFill>
-                <a:latin typeface="Helvetica Neue"/>
-              </a:rPr>
-              <a:t>Flight safety</a:t>
-            </a:r>
-          </a:p>
-        </p:txBody>
-      </p:sp>
-      <p:sp>
-        <p:nvSpPr>
-          <p:cNvPr id="16" name="TextBox 15"/>
-          <p:cNvSpPr txBox="1"/>
-          <p:nvPr/>
-        </p:nvSpPr>
-        <p:spPr>
-          <a:xfrm>
-            <a:off x="6720840" y="4846319"/>
-            <a:ext cx="4709160" cy="914400"/>
-          </a:xfrm>
-          <a:prstGeom prst="rect">
-            <a:avLst/>
-          </a:prstGeom>
-          <a:noFill/>
-        </p:spPr>
-        <p:txBody>
-          <a:bodyPr wrap="square" anchor="t" lIns="0" rIns="0" tIns="0" bIns="0">
-            <a:spAutoFit/>
-          </a:bodyPr>
-          <a:lstStyle/>
-          <a:p>
-            <a:pPr algn="l">
-              <a:spcBef>
-                <a:spcPts val="0"/>
-              </a:spcBef>
-              <a:spcAft>
-                <a:spcPts val="0"/>
-              </a:spcAft>
-            </a:pPr>
-            <a:r>
-              <a:rPr sz="1450" b="0">
-                <a:solidFill>
-                  <a:srgbClr val="8A97B8"/>
-                </a:solidFill>
-                <a:latin typeface="Helvetica Neue"/>
-              </a:rPr>
-              <a:t>Accidental motor spin is dangerous. 1.5 s hold-to-arm, debounced safe-test, and a tilt-over-60° emergency stop.</a:t>
-            </a:r>
-          </a:p>
-        </p:txBody>
-      </p:sp>
-    </p:spTree>
-  </p:cSld>
-  <p:clrMapOvr>
-    <a:masterClrMapping/>
-  </p:clrMapOvr>
-</p:sld>
-</file>
-
-<file path=ppt/slides/slide7.xml><?xml version="1.0" encoding="utf-8"?>
-<p:sld xmlns:a="http://schemas.openxmlformats.org/drawingml/2006/main" xmlns:p="http://schemas.openxmlformats.org/presentationml/2006/main" xmlns:r="http://schemas.openxmlformats.org/officeDocument/2006/relationships">
-  <p:cSld>
-    <p:spTree>
-      <p:nvGrpSpPr>
-        <p:cNvPr id="1" name=""/>
-        <p:cNvGrpSpPr/>
-        <p:nvPr/>
-      </p:nvGrpSpPr>
-      <p:grpSpPr/>
-      <p:sp>
-        <p:nvSpPr>
-          <p:cNvPr id="2" name="Rectangle 1"/>
-          <p:cNvSpPr/>
-          <p:nvPr/>
-        </p:nvSpPr>
-        <p:spPr>
-          <a:xfrm>
-            <a:off x="0" y="0"/>
-            <a:ext cx="12191695" cy="6858000"/>
-          </a:xfrm>
-          <a:prstGeom prst="rect">
-            <a:avLst/>
-          </a:prstGeom>
-          <a:solidFill>
-            <a:srgbClr val="0A0F1E"/>
-          </a:solidFill>
-          <a:ln>
-            <a:noFill/>
-          </a:ln>
-          <a:effectLst/>
-        </p:spPr>
-        <p:style>
-          <a:lnRef idx="1">
-            <a:schemeClr val="accent1"/>
-          </a:lnRef>
-          <a:fillRef idx="3">
-            <a:schemeClr val="accent1"/>
-          </a:fillRef>
-          <a:effectRef idx="2">
-            <a:schemeClr val="accent1"/>
-          </a:effectRef>
-          <a:fontRef idx="minor">
-            <a:schemeClr val="lt1"/>
-          </a:fontRef>
-        </p:style>
-        <p:txBody>
-          <a:bodyPr rtlCol="0" anchor="ctr"/>
-          <a:lstStyle/>
-          <a:p>
-            <a:pPr algn="ctr"/>
-          </a:p>
-        </p:txBody>
-      </p:sp>
-      <p:sp>
-        <p:nvSpPr>
-          <p:cNvPr id="3" name="TextBox 2"/>
-          <p:cNvSpPr txBox="1"/>
-          <p:nvPr/>
-        </p:nvSpPr>
-        <p:spPr>
-          <a:xfrm>
-            <a:off x="777240" y="502920"/>
-            <a:ext cx="10058400" cy="457200"/>
-          </a:xfrm>
-          <a:prstGeom prst="rect">
-            <a:avLst/>
-          </a:prstGeom>
-          <a:noFill/>
-        </p:spPr>
-        <p:txBody>
-          <a:bodyPr wrap="square" anchor="t" lIns="0" rIns="0" tIns="0" bIns="0">
-            <a:spAutoFit/>
-          </a:bodyPr>
-          <a:lstStyle/>
-          <a:p>
-            <a:pPr algn="l">
-              <a:spcBef>
-                <a:spcPts val="0"/>
-              </a:spcBef>
-              <a:spcAft>
-                <a:spcPts val="600"/>
-              </a:spcAft>
-            </a:pPr>
-            <a:r>
-              <a:rPr sz="1500" b="1">
-                <a:solidFill>
-                  <a:srgbClr val="2979FF"/>
-                </a:solidFill>
-                <a:latin typeface="Helvetica Neue"/>
-              </a:rPr>
-              <a:t>CODE · THE THREADING CHALLENGE</a:t>
-            </a:r>
-          </a:p>
-        </p:txBody>
-      </p:sp>
-      <p:sp>
-        <p:nvSpPr>
-          <p:cNvPr id="4" name="TextBox 3"/>
-          <p:cNvSpPr txBox="1"/>
-          <p:nvPr/>
-        </p:nvSpPr>
-        <p:spPr>
-          <a:xfrm>
-            <a:off x="777240" y="868680"/>
-            <a:ext cx="10607040" cy="1005840"/>
-          </a:xfrm>
-          <a:prstGeom prst="rect">
-            <a:avLst/>
-          </a:prstGeom>
-          <a:noFill/>
-        </p:spPr>
-        <p:txBody>
-          <a:bodyPr wrap="square" anchor="t" lIns="0" rIns="0" tIns="0" bIns="0">
-            <a:spAutoFit/>
-          </a:bodyPr>
-          <a:lstStyle/>
-          <a:p>
-            <a:pPr algn="l">
-              <a:spcBef>
-                <a:spcPts val="0"/>
-              </a:spcBef>
-              <a:spcAft>
-                <a:spcPts val="600"/>
-              </a:spcAft>
-            </a:pPr>
-            <a:r>
-              <a:rPr sz="4000" b="1">
-                <a:solidFill>
-                  <a:srgbClr val="E9EEFB"/>
-                </a:solidFill>
-                <a:latin typeface="Helvetica Neue"/>
-              </a:rPr>
-              <a:t>Two threads, one drone</a:t>
-            </a:r>
-          </a:p>
-        </p:txBody>
-      </p:sp>
-      <p:sp>
-        <p:nvSpPr>
-          <p:cNvPr id="5" name="TextBox 4"/>
-          <p:cNvSpPr txBox="1"/>
-          <p:nvPr/>
-        </p:nvSpPr>
-        <p:spPr>
-          <a:xfrm>
-            <a:off x="777240" y="1691640"/>
-            <a:ext cx="10607040" cy="640080"/>
-          </a:xfrm>
-          <a:prstGeom prst="rect">
-            <a:avLst/>
-          </a:prstGeom>
-          <a:noFill/>
-        </p:spPr>
-        <p:txBody>
-          <a:bodyPr wrap="square" anchor="t" lIns="0" rIns="0" tIns="0" bIns="0">
-            <a:spAutoFit/>
-          </a:bodyPr>
-          <a:lstStyle/>
-          <a:p>
-            <a:pPr algn="l">
-              <a:spcBef>
-                <a:spcPts val="0"/>
-              </a:spcBef>
-              <a:spcAft>
-                <a:spcPts val="600"/>
-              </a:spcAft>
-            </a:pPr>
-            <a:r>
-              <a:rPr sz="1600" b="0">
-                <a:solidFill>
-                  <a:srgbClr val="8A97B8"/>
-                </a:solidFill>
-                <a:latin typeface="Helvetica Neue"/>
-              </a:rPr>
-              <a:t>Physics on SceneKit's render thread must never touch SwiftUI directly — so internal state is kept separate from published state.</a:t>
-            </a:r>
-          </a:p>
-        </p:txBody>
-      </p:sp>
-      <p:sp>
-        <p:nvSpPr>
-          <p:cNvPr id="6" name="Rounded Rectangle 5"/>
-          <p:cNvSpPr/>
-          <p:nvPr/>
-        </p:nvSpPr>
-        <p:spPr>
-          <a:xfrm>
-            <a:off x="777240" y="2423160"/>
-            <a:ext cx="10607040" cy="3931920"/>
-          </a:xfrm>
-          <a:prstGeom prst="roundRect">
-            <a:avLst>
-              <a:gd name="adj" fmla="val 3000"/>
-            </a:avLst>
-          </a:prstGeom>
-          <a:solidFill>
-            <a:srgbClr val="0C1326"/>
-          </a:solidFill>
-          <a:ln w="12700">
-            <a:solidFill>
-              <a:srgbClr val="2979FF"/>
-            </a:solidFill>
-          </a:ln>
-          <a:effectLst/>
-        </p:spPr>
-        <p:style>
-          <a:lnRef idx="1">
-            <a:schemeClr val="accent1"/>
-          </a:lnRef>
-          <a:fillRef idx="3">
-            <a:schemeClr val="accent1"/>
-          </a:fillRef>
-          <a:effectRef idx="2">
-            <a:schemeClr val="accent1"/>
-          </a:effectRef>
-          <a:fontRef idx="minor">
-            <a:schemeClr val="lt1"/>
-          </a:fontRef>
-        </p:style>
-        <p:txBody>
-          <a:bodyPr rtlCol="0" anchor="ctr" wrap="square" lIns="320040" tIns="228600" rIns="182880"/>
-          <a:lstStyle/>
-          <a:p>
-            <a:pPr algn="ctr">
-              <a:lnSpc>
-                <a:spcPct val="100000"/>
-              </a:lnSpc>
-              <a:spcAft>
-                <a:spcPts val="200"/>
-              </a:spcAft>
-            </a:pPr>
-            <a:r>
-              <a:rPr sz="1450">
-                <a:solidFill>
-                  <a:srgbClr val="FF7AB2"/>
-                </a:solidFill>
-                <a:latin typeface="Consolas"/>
-              </a:rPr>
-              <a:t>class </a:t>
-            </a:r>
-            <a:r>
-              <a:rPr sz="1450">
-                <a:solidFill>
-                  <a:srgbClr val="7EE0C8"/>
-                </a:solidFill>
-                <a:latin typeface="Consolas"/>
-              </a:rPr>
-              <a:t>DroneSimulator</a:t>
-            </a:r>
-            <a:r>
-              <a:rPr sz="1450">
-                <a:solidFill>
-                  <a:srgbClr val="E9EEFB"/>
-                </a:solidFill>
-                <a:latin typeface="Consolas"/>
-              </a:rPr>
-              <a:t>: </a:t>
-            </a:r>
-            <a:r>
-              <a:rPr sz="1450">
-                <a:solidFill>
-                  <a:srgbClr val="7EE0C8"/>
-                </a:solidFill>
-                <a:latin typeface="Consolas"/>
-              </a:rPr>
-              <a:t>ObservableObject</a:t>
-            </a:r>
-            <a:r>
-              <a:rPr sz="1450">
-                <a:solidFill>
-                  <a:srgbClr val="E9EEFB"/>
-                </a:solidFill>
-                <a:latin typeface="Consolas"/>
-              </a:rPr>
-              <a:t> {</a:t>
-            </a:r>
-          </a:p>
-          <a:p>
-            <a:pPr>
-              <a:lnSpc>
-                <a:spcPct val="100000"/>
-              </a:lnSpc>
-              <a:spcAft>
-                <a:spcPts val="200"/>
-              </a:spcAft>
-            </a:pPr>
-            <a:r>
-              <a:rPr sz="1450">
-                <a:solidFill>
-                  <a:srgbClr val="5D6B8F"/>
-                </a:solidFill>
-                <a:latin typeface="Consolas"/>
-              </a:rPr>
-              <a:t>    // Main thread only — drives SwiftUI</a:t>
-            </a:r>
-          </a:p>
-          <a:p>
-            <a:pPr>
-              <a:lnSpc>
-                <a:spcPct val="100000"/>
-              </a:lnSpc>
-              <a:spcAft>
-                <a:spcPts val="200"/>
-              </a:spcAft>
-            </a:pPr>
-            <a:r>
-              <a:rPr sz="1450">
-                <a:solidFill>
-                  <a:srgbClr val="E9EEFB"/>
-                </a:solidFill>
-                <a:latin typeface="Consolas"/>
-              </a:rPr>
-              <a:t>    @</a:t>
-            </a:r>
-            <a:r>
-              <a:rPr sz="1450">
-                <a:solidFill>
-                  <a:srgbClr val="7EE0C8"/>
-                </a:solidFill>
-                <a:latin typeface="Consolas"/>
-              </a:rPr>
-              <a:t>Published</a:t>
-            </a:r>
-            <a:r>
-              <a:rPr sz="1450">
-                <a:solidFill>
-                  <a:srgbClr val="FF7AB2"/>
-                </a:solidFill>
-                <a:latin typeface="Consolas"/>
-              </a:rPr>
-              <a:t> var</a:t>
-            </a:r>
-            <a:r>
-              <a:rPr sz="1450">
-                <a:solidFill>
-                  <a:srgbClr val="E9EEFB"/>
-                </a:solidFill>
-                <a:latin typeface="Consolas"/>
-              </a:rPr>
-              <a:t> simRoll = </a:t>
-            </a:r>
-            <a:r>
-              <a:rPr sz="1450">
-                <a:solidFill>
-                  <a:srgbClr val="F7C873"/>
-                </a:solidFill>
-                <a:latin typeface="Consolas"/>
-              </a:rPr>
-              <a:t>0.0</a:t>
-            </a:r>
-          </a:p>
-          <a:p>
-            <a:pPr>
-              <a:lnSpc>
-                <a:spcPct val="100000"/>
-              </a:lnSpc>
-              <a:spcAft>
-                <a:spcPts val="200"/>
-              </a:spcAft>
-            </a:pPr>
-            <a:r>
-              <a:rPr sz="1450">
-                <a:solidFill>
-                  <a:srgbClr val="E9EEFB"/>
-                </a:solidFill>
-                <a:latin typeface="Consolas"/>
-              </a:rPr>
-              <a:t>    @</a:t>
-            </a:r>
-            <a:r>
-              <a:rPr sz="1450">
-                <a:solidFill>
-                  <a:srgbClr val="7EE0C8"/>
-                </a:solidFill>
-                <a:latin typeface="Consolas"/>
-              </a:rPr>
-              <a:t>Published</a:t>
-            </a:r>
-            <a:r>
-              <a:rPr sz="1450">
-                <a:solidFill>
-                  <a:srgbClr val="FF7AB2"/>
-                </a:solidFill>
-                <a:latin typeface="Consolas"/>
-              </a:rPr>
-              <a:t> var</a:t>
-            </a:r>
-            <a:r>
-              <a:rPr sz="1450">
-                <a:solidFill>
-                  <a:srgbClr val="E9EEFB"/>
-                </a:solidFill>
-                <a:latin typeface="Consolas"/>
-              </a:rPr>
-              <a:t> isCrashed = </a:t>
-            </a:r>
-            <a:r>
-              <a:rPr sz="1450">
-                <a:solidFill>
-                  <a:srgbClr val="FF7AB2"/>
-                </a:solidFill>
-                <a:latin typeface="Consolas"/>
-              </a:rPr>
-              <a:t>false</a:t>
-            </a:r>
-          </a:p>
-          <a:p>
-            <a:pPr>
-              <a:lnSpc>
-                <a:spcPct val="100000"/>
-              </a:lnSpc>
-              <a:spcAft>
-                <a:spcPts val="200"/>
-              </a:spcAft>
-            </a:pPr>
-            <a:r>
-              <a:rPr sz="1450">
-                <a:solidFill>
-                  <a:srgbClr val="E9EEFB"/>
-                </a:solidFill>
-                <a:latin typeface="Consolas"/>
-              </a:rPr>
-              <a:t/>
-            </a:r>
-          </a:p>
-          <a:p>
-            <a:pPr>
-              <a:lnSpc>
-                <a:spcPct val="100000"/>
-              </a:lnSpc>
-              <a:spcAft>
-                <a:spcPts val="200"/>
-              </a:spcAft>
-            </a:pPr>
-            <a:r>
-              <a:rPr sz="1450">
-                <a:solidFill>
-                  <a:srgbClr val="5D6B8F"/>
-                </a:solidFill>
-                <a:latin typeface="Consolas"/>
-              </a:rPr>
-              <a:t>    // Render thread only — raw physics integration</a:t>
-            </a:r>
-          </a:p>
-          <a:p>
-            <a:pPr>
-              <a:lnSpc>
-                <a:spcPct val="100000"/>
-              </a:lnSpc>
-              <a:spcAft>
-                <a:spcPts val="200"/>
-              </a:spcAft>
-            </a:pPr>
-            <a:r>
-              <a:rPr sz="1450">
-                <a:solidFill>
-                  <a:srgbClr val="FF7AB2"/>
-                </a:solidFill>
-                <a:latin typeface="Consolas"/>
-              </a:rPr>
-              <a:t>    var</a:t>
-            </a:r>
-            <a:r>
-              <a:rPr sz="1450">
-                <a:solidFill>
-                  <a:srgbClr val="E9EEFB"/>
-                </a:solidFill>
-                <a:latin typeface="Consolas"/>
-              </a:rPr>
-              <a:t> _roll = </a:t>
-            </a:r>
-            <a:r>
-              <a:rPr sz="1450">
-                <a:solidFill>
-                  <a:srgbClr val="F7C873"/>
-                </a:solidFill>
-                <a:latin typeface="Consolas"/>
-              </a:rPr>
-              <a:t>0.0</a:t>
-            </a:r>
-          </a:p>
-          <a:p>
-            <a:pPr>
-              <a:lnSpc>
-                <a:spcPct val="100000"/>
-              </a:lnSpc>
-              <a:spcAft>
-                <a:spcPts val="200"/>
-              </a:spcAft>
-            </a:pPr>
-            <a:r>
-              <a:rPr sz="1450">
-                <a:solidFill>
-                  <a:srgbClr val="FF7AB2"/>
-                </a:solidFill>
-                <a:latin typeface="Consolas"/>
-              </a:rPr>
-              <a:t>    var</a:t>
-            </a:r>
-            <a:r>
-              <a:rPr sz="1450">
-                <a:solidFill>
-                  <a:srgbClr val="E9EEFB"/>
-                </a:solidFill>
-                <a:latin typeface="Consolas"/>
-              </a:rPr>
-              <a:t> _vel: </a:t>
-            </a:r>
-            <a:r>
-              <a:rPr sz="1450">
-                <a:solidFill>
-                  <a:srgbClr val="7EE0C8"/>
-                </a:solidFill>
-                <a:latin typeface="Consolas"/>
-              </a:rPr>
-              <a:t>SIMD3</a:t>
-            </a:r>
-            <a:r>
-              <a:rPr sz="1450">
-                <a:solidFill>
-                  <a:srgbClr val="E9EEFB"/>
-                </a:solidFill>
-                <a:latin typeface="Consolas"/>
-              </a:rPr>
-              <a:t>&lt;</a:t>
-            </a:r>
-            <a:r>
-              <a:rPr sz="1450">
-                <a:solidFill>
-                  <a:srgbClr val="7EE0C8"/>
-                </a:solidFill>
-                <a:latin typeface="Consolas"/>
-              </a:rPr>
-              <a:t>Float</a:t>
-            </a:r>
-            <a:r>
-              <a:rPr sz="1450">
-                <a:solidFill>
-                  <a:srgbClr val="E9EEFB"/>
-                </a:solidFill>
-                <a:latin typeface="Consolas"/>
-              </a:rPr>
-              <a:t>&gt; = .zero</a:t>
-            </a:r>
-          </a:p>
-          <a:p>
-            <a:pPr>
-              <a:lnSpc>
-                <a:spcPct val="100000"/>
-              </a:lnSpc>
-              <a:spcAft>
-                <a:spcPts val="200"/>
-              </a:spcAft>
-            </a:pPr>
-            <a:r>
-              <a:rPr sz="1450">
-                <a:solidFill>
-                  <a:srgbClr val="E9EEFB"/>
-                </a:solidFill>
-                <a:latin typeface="Consolas"/>
-              </a:rPr>
-              <a:t/>
-            </a:r>
-          </a:p>
-          <a:p>
-            <a:pPr>
-              <a:lnSpc>
-                <a:spcPct val="100000"/>
-              </a:lnSpc>
-              <a:spcAft>
-                <a:spcPts val="200"/>
-              </a:spcAft>
-            </a:pPr>
-            <a:r>
-              <a:rPr sz="1450">
-                <a:solidFill>
-                  <a:srgbClr val="FF7AB2"/>
-                </a:solidFill>
-                <a:latin typeface="Consolas"/>
-              </a:rPr>
-              <a:t>    func </a:t>
-            </a:r>
-            <a:r>
-              <a:rPr sz="1450">
-                <a:solidFill>
-                  <a:srgbClr val="82AAFF"/>
-                </a:solidFill>
-                <a:latin typeface="Consolas"/>
-              </a:rPr>
-              <a:t>tick</a:t>
-            </a:r>
-            <a:r>
-              <a:rPr sz="1450">
-                <a:solidFill>
-                  <a:srgbClr val="E9EEFB"/>
-                </a:solidFill>
-                <a:latin typeface="Consolas"/>
-              </a:rPr>
-              <a:t>(dt: </a:t>
-            </a:r>
-            <a:r>
-              <a:rPr sz="1450">
-                <a:solidFill>
-                  <a:srgbClr val="7EE0C8"/>
-                </a:solidFill>
-                <a:latin typeface="Consolas"/>
-              </a:rPr>
-              <a:t>Double</a:t>
-            </a:r>
-            <a:r>
-              <a:rPr sz="1450">
-                <a:solidFill>
-                  <a:srgbClr val="E9EEFB"/>
-                </a:solidFill>
-                <a:latin typeface="Consolas"/>
-              </a:rPr>
-              <a:t>) { </a:t>
-            </a:r>
-            <a:r>
-              <a:rPr sz="1450">
-                <a:solidFill>
-                  <a:srgbClr val="5D6B8F"/>
-                </a:solidFill>
-                <a:latin typeface="Consolas"/>
-              </a:rPr>
-              <a:t>/* render thread: physics */</a:t>
-            </a:r>
-            <a:r>
-              <a:rPr sz="1450">
-                <a:solidFill>
-                  <a:srgbClr val="E9EEFB"/>
-                </a:solidFill>
-                <a:latin typeface="Consolas"/>
-              </a:rPr>
-              <a:t> }</a:t>
-            </a:r>
-          </a:p>
-          <a:p>
-            <a:pPr>
-              <a:lnSpc>
-                <a:spcPct val="100000"/>
-              </a:lnSpc>
-              <a:spcAft>
-                <a:spcPts val="200"/>
-              </a:spcAft>
-            </a:pPr>
-            <a:r>
-              <a:rPr sz="1450">
-                <a:solidFill>
-                  <a:srgbClr val="FF7AB2"/>
-                </a:solidFill>
-                <a:latin typeface="Consolas"/>
-              </a:rPr>
-              <a:t>    func </a:t>
-            </a:r>
-            <a:r>
-              <a:rPr sz="1450">
-                <a:solidFill>
-                  <a:srgbClr val="82AAFF"/>
-                </a:solidFill>
-                <a:latin typeface="Consolas"/>
-              </a:rPr>
-              <a:t>syncPublished</a:t>
-            </a:r>
-            <a:r>
-              <a:rPr sz="1450">
-                <a:solidFill>
-                  <a:srgbClr val="E9EEFB"/>
-                </a:solidFill>
-                <a:latin typeface="Consolas"/>
-              </a:rPr>
-              <a:t>() { </a:t>
-            </a:r>
-            <a:r>
-              <a:rPr sz="1450">
-                <a:solidFill>
-                  <a:srgbClr val="5D6B8F"/>
-                </a:solidFill>
-                <a:latin typeface="Consolas"/>
-              </a:rPr>
-              <a:t>/* main: _vars → @Published */</a:t>
-            </a:r>
-            <a:r>
-              <a:rPr sz="1450">
-                <a:solidFill>
-                  <a:srgbClr val="E9EEFB"/>
-                </a:solidFill>
-                <a:latin typeface="Consolas"/>
-              </a:rPr>
-              <a:t> }</a:t>
-            </a:r>
-          </a:p>
-          <a:p>
-            <a:pPr>
-              <a:lnSpc>
-                <a:spcPct val="100000"/>
-              </a:lnSpc>
-              <a:spcAft>
-                <a:spcPts val="200"/>
-              </a:spcAft>
-            </a:pPr>
-            <a:r>
-              <a:rPr sz="1450">
-                <a:solidFill>
-                  <a:srgbClr val="E9EEFB"/>
-                </a:solidFill>
-                <a:latin typeface="Consolas"/>
-              </a:rPr>
-              <a:t>}</a:t>
-            </a:r>
-          </a:p>
-        </p:txBody>
-      </p:sp>
-    </p:spTree>
-  </p:cSld>
-  <p:clrMapOvr>
-    <a:masterClrMapping/>
-  </p:clrMapOvr>
-</p:sld>
-</file>
-
-<file path=ppt/slides/slide8.xml><?xml version="1.0" encoding="utf-8"?>
 <p:sld xmlns:a="http://schemas.openxmlformats.org/drawingml/2006/main" xmlns:p="http://schemas.openxmlformats.org/presentationml/2006/main" xmlns:r="http://schemas.openxmlformats.org/officeDocument/2006/relationships">
   <p:cSld>
     <p:spTree>

</xml_diff>